<commit_message>
feat(cl1): fill topic-deck image gaps (diagrams + gen + AWS reuse); 31/31 placed
Place real images into all 8 image-bearing CL1 topic decks via the per-topic
build scripts (a _img() helper -> committed files):
- 10 draw-diagram diagrams (topic_NN/diagrams/, editable .drawio + PNG)
- 7 image-gen illustrations/icons (topic_01/images/)
- 14 AWS Academy reuse images extracted/exported into topic_NN/images/

Visual-reviewed every image slide (review-slides skill): 0 leftover
placeholders; reshaped 3 wide-short diagrams (deployment-models -> 2x2,
service-model-spectrum + multi-az-rds -> vertical). Adds the image-gap-survey
working checklist.

Co-Authored-By: Claude Opus 4.8 (1M context) <noreply@anthropic.com>
</commit_message>
<xml_diff>
--- a/S1-CL1-Cloud-Design-Build/delivery/topic_03/Topic_03_Slides.pptx
+++ b/S1-CL1-Cloud-Design-Build/delivery/topic_03/Topic_03_Slides.pptx
@@ -4,38 +4,35 @@
   <p:sldMasterIdLst>
     <p:sldMasterId id="2147483648" r:id="rId1"/>
   </p:sldMasterIdLst>
-  <p:notesMasterIdLst>
-    <p:notesMasterId r:id="rId28"/>
-  </p:notesMasterIdLst>
   <p:sldIdLst>
-    <p:sldId id="256" r:id="rId2"/>
-    <p:sldId id="257" r:id="rId3"/>
-    <p:sldId id="258" r:id="rId4"/>
-    <p:sldId id="259" r:id="rId5"/>
-    <p:sldId id="260" r:id="rId6"/>
-    <p:sldId id="261" r:id="rId7"/>
-    <p:sldId id="262" r:id="rId8"/>
-    <p:sldId id="263" r:id="rId9"/>
-    <p:sldId id="264" r:id="rId10"/>
-    <p:sldId id="265" r:id="rId11"/>
-    <p:sldId id="266" r:id="rId12"/>
-    <p:sldId id="267" r:id="rId13"/>
-    <p:sldId id="268" r:id="rId14"/>
-    <p:sldId id="269" r:id="rId15"/>
-    <p:sldId id="270" r:id="rId16"/>
-    <p:sldId id="271" r:id="rId17"/>
-    <p:sldId id="272" r:id="rId18"/>
-    <p:sldId id="273" r:id="rId19"/>
-    <p:sldId id="274" r:id="rId20"/>
-    <p:sldId id="275" r:id="rId21"/>
-    <p:sldId id="276" r:id="rId22"/>
-    <p:sldId id="277" r:id="rId23"/>
-    <p:sldId id="278" r:id="rId24"/>
-    <p:sldId id="279" r:id="rId25"/>
-    <p:sldId id="280" r:id="rId26"/>
-    <p:sldId id="281" r:id="rId27"/>
+    <p:sldId id="256" r:id="rId7"/>
+    <p:sldId id="257" r:id="rId8"/>
+    <p:sldId id="258" r:id="rId9"/>
+    <p:sldId id="259" r:id="rId10"/>
+    <p:sldId id="260" r:id="rId11"/>
+    <p:sldId id="261" r:id="rId12"/>
+    <p:sldId id="262" r:id="rId13"/>
+    <p:sldId id="263" r:id="rId14"/>
+    <p:sldId id="264" r:id="rId15"/>
+    <p:sldId id="265" r:id="rId16"/>
+    <p:sldId id="266" r:id="rId17"/>
+    <p:sldId id="267" r:id="rId18"/>
+    <p:sldId id="268" r:id="rId19"/>
+    <p:sldId id="269" r:id="rId20"/>
+    <p:sldId id="270" r:id="rId21"/>
+    <p:sldId id="271" r:id="rId22"/>
+    <p:sldId id="272" r:id="rId23"/>
+    <p:sldId id="273" r:id="rId24"/>
+    <p:sldId id="274" r:id="rId25"/>
+    <p:sldId id="275" r:id="rId26"/>
+    <p:sldId id="276" r:id="rId27"/>
+    <p:sldId id="277" r:id="rId28"/>
+    <p:sldId id="278" r:id="rId29"/>
+    <p:sldId id="279" r:id="rId30"/>
+    <p:sldId id="280" r:id="rId31"/>
+    <p:sldId id="281" r:id="rId32"/>
   </p:sldIdLst>
-  <p:sldSz cx="12192000" cy="6858000"/>
+  <p:sldSz cx="12191695" cy="6858000" type="screen4x3"/>
   <p:notesSz cx="6858000" cy="9144000"/>
   <p:defaultTextStyle>
     <a:defPPr>
@@ -132,457 +129,7 @@
       </a:defRPr>
     </a:lvl9pPr>
   </p:defaultTextStyle>
-  <p:extLst>
-    <p:ext uri="{EFAFB233-063F-42B5-8137-9DF3F51BA10A}">
-      <p15:sldGuideLst xmlns:p15="http://schemas.microsoft.com/office/powerpoint/2012/main">
-        <p15:guide id="1" orient="horz" pos="2160">
-          <p15:clr>
-            <a:srgbClr val="A4A3A4"/>
-          </p15:clr>
-        </p15:guide>
-        <p15:guide id="2" pos="2880">
-          <p15:clr>
-            <a:srgbClr val="A4A3A4"/>
-          </p15:clr>
-        </p15:guide>
-      </p15:sldGuideLst>
-    </p:ext>
-  </p:extLst>
 </p:presentation>
-</file>
-
-<file path=ppt/notesMasters/notesMaster1.xml><?xml version="1.0" encoding="utf-8"?>
-<p:notesMaster xmlns:a="http://schemas.openxmlformats.org/drawingml/2006/main" xmlns:r="http://schemas.openxmlformats.org/officeDocument/2006/relationships" xmlns:p="http://schemas.openxmlformats.org/presentationml/2006/main">
-  <p:cSld>
-    <p:bg>
-      <p:bgRef idx="1001">
-        <a:schemeClr val="bg1"/>
-      </p:bgRef>
-    </p:bg>
-    <p:spTree>
-      <p:nvGrpSpPr>
-        <p:cNvPr id="1" name=""/>
-        <p:cNvGrpSpPr/>
-        <p:nvPr/>
-      </p:nvGrpSpPr>
-      <p:grpSpPr>
-        <a:xfrm>
-          <a:off x="0" y="0"/>
-          <a:ext cx="0" cy="0"/>
-          <a:chOff x="0" y="0"/>
-          <a:chExt cx="0" cy="0"/>
-        </a:xfrm>
-      </p:grpSpPr>
-      <p:sp>
-        <p:nvSpPr>
-          <p:cNvPr id="2" name="Header Placeholder 1"/>
-          <p:cNvSpPr>
-            <a:spLocks noGrp="1"/>
-          </p:cNvSpPr>
-          <p:nvPr>
-            <p:ph type="hdr" sz="quarter"/>
-          </p:nvPr>
-        </p:nvSpPr>
-        <p:spPr>
-          <a:xfrm>
-            <a:off x="0" y="0"/>
-            <a:ext cx="2971800" cy="458788"/>
-          </a:xfrm>
-          <a:prstGeom prst="rect">
-            <a:avLst/>
-          </a:prstGeom>
-        </p:spPr>
-        <p:txBody>
-          <a:bodyPr vert="horz" lIns="91440" tIns="45720" rIns="91440" bIns="45720" rtlCol="0"/>
-          <a:lstStyle>
-            <a:lvl1pPr algn="l">
-              <a:defRPr sz="1200"/>
-            </a:lvl1pPr>
-          </a:lstStyle>
-          <a:p>
-            <a:endParaRPr lang="en-AU"/>
-          </a:p>
-        </p:txBody>
-      </p:sp>
-      <p:sp>
-        <p:nvSpPr>
-          <p:cNvPr id="3" name="Date Placeholder 2"/>
-          <p:cNvSpPr>
-            <a:spLocks noGrp="1"/>
-          </p:cNvSpPr>
-          <p:nvPr>
-            <p:ph type="dt" idx="1"/>
-          </p:nvPr>
-        </p:nvSpPr>
-        <p:spPr>
-          <a:xfrm>
-            <a:off x="3884613" y="0"/>
-            <a:ext cx="2971800" cy="458788"/>
-          </a:xfrm>
-          <a:prstGeom prst="rect">
-            <a:avLst/>
-          </a:prstGeom>
-        </p:spPr>
-        <p:txBody>
-          <a:bodyPr vert="horz" lIns="91440" tIns="45720" rIns="91440" bIns="45720" rtlCol="0"/>
-          <a:lstStyle>
-            <a:lvl1pPr algn="r">
-              <a:defRPr sz="1200"/>
-            </a:lvl1pPr>
-          </a:lstStyle>
-          <a:p>
-            <a:fld id="{9890B06A-6EBA-4AFC-94EE-11AF9381E625}" type="datetimeFigureOut">
-              <a:rPr lang="en-AU" smtClean="0"/>
-              <a:t>2/06/2026</a:t>
-            </a:fld>
-            <a:endParaRPr lang="en-AU"/>
-          </a:p>
-        </p:txBody>
-      </p:sp>
-      <p:sp>
-        <p:nvSpPr>
-          <p:cNvPr id="4" name="Slide Image Placeholder 3"/>
-          <p:cNvSpPr>
-            <a:spLocks noGrp="1" noRot="1" noChangeAspect="1"/>
-          </p:cNvSpPr>
-          <p:nvPr>
-            <p:ph type="sldImg" idx="2"/>
-          </p:nvPr>
-        </p:nvSpPr>
-        <p:spPr>
-          <a:xfrm>
-            <a:off x="685800" y="1143000"/>
-            <a:ext cx="5486400" cy="3086100"/>
-          </a:xfrm>
-          <a:prstGeom prst="rect">
-            <a:avLst/>
-          </a:prstGeom>
-          <a:noFill/>
-          <a:ln w="12700">
-            <a:solidFill>
-              <a:prstClr val="black"/>
-            </a:solidFill>
-          </a:ln>
-        </p:spPr>
-        <p:txBody>
-          <a:bodyPr vert="horz" lIns="91440" tIns="45720" rIns="91440" bIns="45720" rtlCol="0" anchor="ctr"/>
-          <a:lstStyle/>
-          <a:p>
-            <a:endParaRPr lang="en-AU"/>
-          </a:p>
-        </p:txBody>
-      </p:sp>
-      <p:sp>
-        <p:nvSpPr>
-          <p:cNvPr id="5" name="Notes Placeholder 4"/>
-          <p:cNvSpPr>
-            <a:spLocks noGrp="1"/>
-          </p:cNvSpPr>
-          <p:nvPr>
-            <p:ph type="body" sz="quarter" idx="3"/>
-          </p:nvPr>
-        </p:nvSpPr>
-        <p:spPr>
-          <a:xfrm>
-            <a:off x="685800" y="4400550"/>
-            <a:ext cx="5486400" cy="3600450"/>
-          </a:xfrm>
-          <a:prstGeom prst="rect">
-            <a:avLst/>
-          </a:prstGeom>
-        </p:spPr>
-        <p:txBody>
-          <a:bodyPr vert="horz" lIns="91440" tIns="45720" rIns="91440" bIns="45720" rtlCol="0"/>
-          <a:lstStyle/>
-          <a:p>
-            <a:pPr lvl="0"/>
-            <a:r>
-              <a:rPr lang="en-US"/>
-              <a:t>Click to edit Master text styles</a:t>
-            </a:r>
-          </a:p>
-          <a:p>
-            <a:pPr lvl="1"/>
-            <a:r>
-              <a:rPr lang="en-US"/>
-              <a:t>Second level</a:t>
-            </a:r>
-          </a:p>
-          <a:p>
-            <a:pPr lvl="2"/>
-            <a:r>
-              <a:rPr lang="en-US"/>
-              <a:t>Third level</a:t>
-            </a:r>
-          </a:p>
-          <a:p>
-            <a:pPr lvl="3"/>
-            <a:r>
-              <a:rPr lang="en-US"/>
-              <a:t>Fourth level</a:t>
-            </a:r>
-          </a:p>
-          <a:p>
-            <a:pPr lvl="4"/>
-            <a:r>
-              <a:rPr lang="en-US"/>
-              <a:t>Fifth level</a:t>
-            </a:r>
-            <a:endParaRPr lang="en-AU"/>
-          </a:p>
-        </p:txBody>
-      </p:sp>
-      <p:sp>
-        <p:nvSpPr>
-          <p:cNvPr id="6" name="Footer Placeholder 5"/>
-          <p:cNvSpPr>
-            <a:spLocks noGrp="1"/>
-          </p:cNvSpPr>
-          <p:nvPr>
-            <p:ph type="ftr" sz="quarter" idx="4"/>
-          </p:nvPr>
-        </p:nvSpPr>
-        <p:spPr>
-          <a:xfrm>
-            <a:off x="0" y="8685213"/>
-            <a:ext cx="2971800" cy="458787"/>
-          </a:xfrm>
-          <a:prstGeom prst="rect">
-            <a:avLst/>
-          </a:prstGeom>
-        </p:spPr>
-        <p:txBody>
-          <a:bodyPr vert="horz" lIns="91440" tIns="45720" rIns="91440" bIns="45720" rtlCol="0" anchor="b"/>
-          <a:lstStyle>
-            <a:lvl1pPr algn="l">
-              <a:defRPr sz="1200"/>
-            </a:lvl1pPr>
-          </a:lstStyle>
-          <a:p>
-            <a:endParaRPr lang="en-AU"/>
-          </a:p>
-        </p:txBody>
-      </p:sp>
-      <p:sp>
-        <p:nvSpPr>
-          <p:cNvPr id="7" name="Slide Number Placeholder 6"/>
-          <p:cNvSpPr>
-            <a:spLocks noGrp="1"/>
-          </p:cNvSpPr>
-          <p:nvPr>
-            <p:ph type="sldNum" sz="quarter" idx="5"/>
-          </p:nvPr>
-        </p:nvSpPr>
-        <p:spPr>
-          <a:xfrm>
-            <a:off x="3884613" y="8685213"/>
-            <a:ext cx="2971800" cy="458787"/>
-          </a:xfrm>
-          <a:prstGeom prst="rect">
-            <a:avLst/>
-          </a:prstGeom>
-        </p:spPr>
-        <p:txBody>
-          <a:bodyPr vert="horz" lIns="91440" tIns="45720" rIns="91440" bIns="45720" rtlCol="0" anchor="b"/>
-          <a:lstStyle>
-            <a:lvl1pPr algn="r">
-              <a:defRPr sz="1200"/>
-            </a:lvl1pPr>
-          </a:lstStyle>
-          <a:p>
-            <a:fld id="{1F743E08-7C00-4973-9AD1-14F753946BE0}" type="slidenum">
-              <a:rPr lang="en-AU" smtClean="0"/>
-              <a:t>‹#›</a:t>
-            </a:fld>
-            <a:endParaRPr lang="en-AU"/>
-          </a:p>
-        </p:txBody>
-      </p:sp>
-    </p:spTree>
-    <p:extLst>
-      <p:ext uri="{BB962C8B-B14F-4D97-AF65-F5344CB8AC3E}">
-        <p14:creationId xmlns:p14="http://schemas.microsoft.com/office/powerpoint/2010/main" val="3168934665"/>
-      </p:ext>
-    </p:extLst>
-  </p:cSld>
-  <p:clrMap bg1="lt1" tx1="dk1" bg2="lt2" tx2="dk2" accent1="accent1" accent2="accent2" accent3="accent3" accent4="accent4" accent5="accent5" accent6="accent6" hlink="hlink" folHlink="folHlink"/>
-  <p:notesStyle>
-    <a:lvl1pPr marL="0" algn="l" defTabSz="914400" rtl="0" eaLnBrk="1" latinLnBrk="0" hangingPunct="1">
-      <a:defRPr sz="1200" kern="1200">
-        <a:solidFill>
-          <a:schemeClr val="tx1"/>
-        </a:solidFill>
-        <a:latin typeface="+mn-lt"/>
-        <a:ea typeface="+mn-ea"/>
-        <a:cs typeface="+mn-cs"/>
-      </a:defRPr>
-    </a:lvl1pPr>
-    <a:lvl2pPr marL="457200" algn="l" defTabSz="914400" rtl="0" eaLnBrk="1" latinLnBrk="0" hangingPunct="1">
-      <a:defRPr sz="1200" kern="1200">
-        <a:solidFill>
-          <a:schemeClr val="tx1"/>
-        </a:solidFill>
-        <a:latin typeface="+mn-lt"/>
-        <a:ea typeface="+mn-ea"/>
-        <a:cs typeface="+mn-cs"/>
-      </a:defRPr>
-    </a:lvl2pPr>
-    <a:lvl3pPr marL="914400" algn="l" defTabSz="914400" rtl="0" eaLnBrk="1" latinLnBrk="0" hangingPunct="1">
-      <a:defRPr sz="1200" kern="1200">
-        <a:solidFill>
-          <a:schemeClr val="tx1"/>
-        </a:solidFill>
-        <a:latin typeface="+mn-lt"/>
-        <a:ea typeface="+mn-ea"/>
-        <a:cs typeface="+mn-cs"/>
-      </a:defRPr>
-    </a:lvl3pPr>
-    <a:lvl4pPr marL="1371600" algn="l" defTabSz="914400" rtl="0" eaLnBrk="1" latinLnBrk="0" hangingPunct="1">
-      <a:defRPr sz="1200" kern="1200">
-        <a:solidFill>
-          <a:schemeClr val="tx1"/>
-        </a:solidFill>
-        <a:latin typeface="+mn-lt"/>
-        <a:ea typeface="+mn-ea"/>
-        <a:cs typeface="+mn-cs"/>
-      </a:defRPr>
-    </a:lvl4pPr>
-    <a:lvl5pPr marL="1828800" algn="l" defTabSz="914400" rtl="0" eaLnBrk="1" latinLnBrk="0" hangingPunct="1">
-      <a:defRPr sz="1200" kern="1200">
-        <a:solidFill>
-          <a:schemeClr val="tx1"/>
-        </a:solidFill>
-        <a:latin typeface="+mn-lt"/>
-        <a:ea typeface="+mn-ea"/>
-        <a:cs typeface="+mn-cs"/>
-      </a:defRPr>
-    </a:lvl5pPr>
-    <a:lvl6pPr marL="2286000" algn="l" defTabSz="914400" rtl="0" eaLnBrk="1" latinLnBrk="0" hangingPunct="1">
-      <a:defRPr sz="1200" kern="1200">
-        <a:solidFill>
-          <a:schemeClr val="tx1"/>
-        </a:solidFill>
-        <a:latin typeface="+mn-lt"/>
-        <a:ea typeface="+mn-ea"/>
-        <a:cs typeface="+mn-cs"/>
-      </a:defRPr>
-    </a:lvl6pPr>
-    <a:lvl7pPr marL="2743200" algn="l" defTabSz="914400" rtl="0" eaLnBrk="1" latinLnBrk="0" hangingPunct="1">
-      <a:defRPr sz="1200" kern="1200">
-        <a:solidFill>
-          <a:schemeClr val="tx1"/>
-        </a:solidFill>
-        <a:latin typeface="+mn-lt"/>
-        <a:ea typeface="+mn-ea"/>
-        <a:cs typeface="+mn-cs"/>
-      </a:defRPr>
-    </a:lvl7pPr>
-    <a:lvl8pPr marL="3200400" algn="l" defTabSz="914400" rtl="0" eaLnBrk="1" latinLnBrk="0" hangingPunct="1">
-      <a:defRPr sz="1200" kern="1200">
-        <a:solidFill>
-          <a:schemeClr val="tx1"/>
-        </a:solidFill>
-        <a:latin typeface="+mn-lt"/>
-        <a:ea typeface="+mn-ea"/>
-        <a:cs typeface="+mn-cs"/>
-      </a:defRPr>
-    </a:lvl8pPr>
-    <a:lvl9pPr marL="3657600" algn="l" defTabSz="914400" rtl="0" eaLnBrk="1" latinLnBrk="0" hangingPunct="1">
-      <a:defRPr sz="1200" kern="1200">
-        <a:solidFill>
-          <a:schemeClr val="tx1"/>
-        </a:solidFill>
-        <a:latin typeface="+mn-lt"/>
-        <a:ea typeface="+mn-ea"/>
-        <a:cs typeface="+mn-cs"/>
-      </a:defRPr>
-    </a:lvl9pPr>
-  </p:notesStyle>
-</p:notesMaster>
-</file>
-
-<file path=ppt/notesSlides/notesSlide1.xml><?xml version="1.0" encoding="utf-8"?>
-<p:notes xmlns:a="http://schemas.openxmlformats.org/drawingml/2006/main" xmlns:r="http://schemas.openxmlformats.org/officeDocument/2006/relationships" xmlns:p="http://schemas.openxmlformats.org/presentationml/2006/main">
-  <p:cSld>
-    <p:spTree>
-      <p:nvGrpSpPr>
-        <p:cNvPr id="1" name=""/>
-        <p:cNvGrpSpPr/>
-        <p:nvPr/>
-      </p:nvGrpSpPr>
-      <p:grpSpPr>
-        <a:xfrm>
-          <a:off x="0" y="0"/>
-          <a:ext cx="0" cy="0"/>
-          <a:chOff x="0" y="0"/>
-          <a:chExt cx="0" cy="0"/>
-        </a:xfrm>
-      </p:grpSpPr>
-      <p:sp>
-        <p:nvSpPr>
-          <p:cNvPr id="2" name="Slide Image Placeholder 1"/>
-          <p:cNvSpPr>
-            <a:spLocks noGrp="1" noRot="1" noChangeAspect="1"/>
-          </p:cNvSpPr>
-          <p:nvPr>
-            <p:ph type="sldImg"/>
-          </p:nvPr>
-        </p:nvSpPr>
-        <p:spPr/>
-      </p:sp>
-      <p:sp>
-        <p:nvSpPr>
-          <p:cNvPr id="3" name="Notes Placeholder 2"/>
-          <p:cNvSpPr>
-            <a:spLocks noGrp="1"/>
-          </p:cNvSpPr>
-          <p:nvPr>
-            <p:ph type="body" idx="1"/>
-          </p:nvPr>
-        </p:nvSpPr>
-        <p:spPr/>
-        <p:txBody>
-          <a:bodyPr/>
-          <a:lstStyle/>
-          <a:p>
-            <a:endParaRPr lang="en-AU" dirty="0"/>
-          </a:p>
-        </p:txBody>
-      </p:sp>
-      <p:sp>
-        <p:nvSpPr>
-          <p:cNvPr id="4" name="Slide Number Placeholder 3"/>
-          <p:cNvSpPr>
-            <a:spLocks noGrp="1"/>
-          </p:cNvSpPr>
-          <p:nvPr>
-            <p:ph type="sldNum" sz="quarter" idx="5"/>
-          </p:nvPr>
-        </p:nvSpPr>
-        <p:spPr/>
-        <p:txBody>
-          <a:bodyPr/>
-          <a:lstStyle/>
-          <a:p>
-            <a:fld id="{1F743E08-7C00-4973-9AD1-14F753946BE0}" type="slidenum">
-              <a:rPr lang="en-AU" smtClean="0"/>
-              <a:t>15</a:t>
-            </a:fld>
-            <a:endParaRPr lang="en-AU"/>
-          </a:p>
-        </p:txBody>
-      </p:sp>
-    </p:spTree>
-    <p:extLst>
-      <p:ext uri="{BB962C8B-B14F-4D97-AF65-F5344CB8AC3E}">
-        <p14:creationId xmlns:p14="http://schemas.microsoft.com/office/powerpoint/2010/main" val="3999268144"/>
-      </p:ext>
-    </p:extLst>
-  </p:cSld>
-  <p:clrMapOvr>
-    <a:masterClrMapping/>
-  </p:clrMapOvr>
-</p:notes>
 </file>
 
 <file path=ppt/slideLayouts/slideLayout1.xml><?xml version="1.0" encoding="utf-8"?>
@@ -623,9 +170,10 @@
           <a:lstStyle/>
           <a:p>
             <a:r>
-              <a:rPr lang="en-US"/>
+              <a:rPr lang="en-US" smtClean="0"/>
               <a:t>Click to edit Master title style</a:t>
             </a:r>
+            <a:endParaRPr lang="en-US"/>
           </a:p>
         </p:txBody>
       </p:sp>
@@ -741,9 +289,10 @@
           </a:lstStyle>
           <a:p>
             <a:r>
-              <a:rPr lang="en-US"/>
+              <a:rPr lang="en-US" smtClean="0"/>
               <a:t>Click to edit Master subtitle style</a:t>
             </a:r>
+            <a:endParaRPr lang="en-US"/>
           </a:p>
         </p:txBody>
       </p:sp>
@@ -764,7 +313,7 @@
           <a:p>
             <a:fld id="{5BCAD085-E8A6-8845-BD4E-CB4CCA059FC4}" type="datetimeFigureOut">
               <a:rPr lang="en-US" smtClean="0"/>
-              <a:t>6/2/2026</a:t>
+              <a:t>1/27/13</a:t>
             </a:fld>
             <a:endParaRPr lang="en-US"/>
           </a:p>
@@ -858,9 +407,10 @@
           <a:lstStyle/>
           <a:p>
             <a:r>
-              <a:rPr lang="en-US"/>
+              <a:rPr lang="en-US" smtClean="0"/>
               <a:t>Click to edit Master title style</a:t>
             </a:r>
+            <a:endParaRPr lang="en-US"/>
           </a:p>
         </p:txBody>
       </p:sp>
@@ -881,37 +431,38 @@
           <a:p>
             <a:pPr lvl="0"/>
             <a:r>
-              <a:rPr lang="en-US"/>
+              <a:rPr lang="en-US" smtClean="0"/>
               <a:t>Click to edit Master text styles</a:t>
             </a:r>
           </a:p>
           <a:p>
             <a:pPr lvl="1"/>
             <a:r>
-              <a:rPr lang="en-US"/>
+              <a:rPr lang="en-US" smtClean="0"/>
               <a:t>Second level</a:t>
             </a:r>
           </a:p>
           <a:p>
             <a:pPr lvl="2"/>
             <a:r>
-              <a:rPr lang="en-US"/>
+              <a:rPr lang="en-US" smtClean="0"/>
               <a:t>Third level</a:t>
             </a:r>
           </a:p>
           <a:p>
             <a:pPr lvl="3"/>
             <a:r>
-              <a:rPr lang="en-US"/>
+              <a:rPr lang="en-US" smtClean="0"/>
               <a:t>Fourth level</a:t>
             </a:r>
           </a:p>
           <a:p>
             <a:pPr lvl="4"/>
             <a:r>
-              <a:rPr lang="en-US"/>
+              <a:rPr lang="en-US" smtClean="0"/>
               <a:t>Fifth level</a:t>
             </a:r>
+            <a:endParaRPr lang="en-US"/>
           </a:p>
         </p:txBody>
       </p:sp>
@@ -932,7 +483,7 @@
           <a:p>
             <a:fld id="{5BCAD085-E8A6-8845-BD4E-CB4CCA059FC4}" type="datetimeFigureOut">
               <a:rPr lang="en-US" smtClean="0"/>
-              <a:t>6/2/2026</a:t>
+              <a:t>1/27/13</a:t>
             </a:fld>
             <a:endParaRPr lang="en-US"/>
           </a:p>
@@ -1031,9 +582,10 @@
           <a:lstStyle/>
           <a:p>
             <a:r>
-              <a:rPr lang="en-US"/>
+              <a:rPr lang="en-US" smtClean="0"/>
               <a:t>Click to edit Master title style</a:t>
             </a:r>
+            <a:endParaRPr lang="en-US"/>
           </a:p>
         </p:txBody>
       </p:sp>
@@ -1059,37 +611,38 @@
           <a:p>
             <a:pPr lvl="0"/>
             <a:r>
-              <a:rPr lang="en-US"/>
+              <a:rPr lang="en-US" smtClean="0"/>
               <a:t>Click to edit Master text styles</a:t>
             </a:r>
           </a:p>
           <a:p>
             <a:pPr lvl="1"/>
             <a:r>
-              <a:rPr lang="en-US"/>
+              <a:rPr lang="en-US" smtClean="0"/>
               <a:t>Second level</a:t>
             </a:r>
           </a:p>
           <a:p>
             <a:pPr lvl="2"/>
             <a:r>
-              <a:rPr lang="en-US"/>
+              <a:rPr lang="en-US" smtClean="0"/>
               <a:t>Third level</a:t>
             </a:r>
           </a:p>
           <a:p>
             <a:pPr lvl="3"/>
             <a:r>
-              <a:rPr lang="en-US"/>
+              <a:rPr lang="en-US" smtClean="0"/>
               <a:t>Fourth level</a:t>
             </a:r>
           </a:p>
           <a:p>
             <a:pPr lvl="4"/>
             <a:r>
-              <a:rPr lang="en-US"/>
+              <a:rPr lang="en-US" smtClean="0"/>
               <a:t>Fifth level</a:t>
             </a:r>
+            <a:endParaRPr lang="en-US"/>
           </a:p>
         </p:txBody>
       </p:sp>
@@ -1110,7 +663,7 @@
           <a:p>
             <a:fld id="{5BCAD085-E8A6-8845-BD4E-CB4CCA059FC4}" type="datetimeFigureOut">
               <a:rPr lang="en-US" smtClean="0"/>
-              <a:t>6/2/2026</a:t>
+              <a:t>1/27/13</a:t>
             </a:fld>
             <a:endParaRPr lang="en-US"/>
           </a:p>
@@ -1204,9 +757,10 @@
           <a:lstStyle/>
           <a:p>
             <a:r>
-              <a:rPr lang="en-US"/>
+              <a:rPr lang="en-US" smtClean="0"/>
               <a:t>Click to edit Master title style</a:t>
             </a:r>
+            <a:endParaRPr lang="en-US"/>
           </a:p>
         </p:txBody>
       </p:sp>
@@ -1227,37 +781,38 @@
           <a:p>
             <a:pPr lvl="0"/>
             <a:r>
-              <a:rPr lang="en-US"/>
+              <a:rPr lang="en-US" smtClean="0"/>
               <a:t>Click to edit Master text styles</a:t>
             </a:r>
           </a:p>
           <a:p>
             <a:pPr lvl="1"/>
             <a:r>
-              <a:rPr lang="en-US"/>
+              <a:rPr lang="en-US" smtClean="0"/>
               <a:t>Second level</a:t>
             </a:r>
           </a:p>
           <a:p>
             <a:pPr lvl="2"/>
             <a:r>
-              <a:rPr lang="en-US"/>
+              <a:rPr lang="en-US" smtClean="0"/>
               <a:t>Third level</a:t>
             </a:r>
           </a:p>
           <a:p>
             <a:pPr lvl="3"/>
             <a:r>
-              <a:rPr lang="en-US"/>
+              <a:rPr lang="en-US" smtClean="0"/>
               <a:t>Fourth level</a:t>
             </a:r>
           </a:p>
           <a:p>
             <a:pPr lvl="4"/>
             <a:r>
-              <a:rPr lang="en-US"/>
+              <a:rPr lang="en-US" smtClean="0"/>
               <a:t>Fifth level</a:t>
             </a:r>
+            <a:endParaRPr lang="en-US"/>
           </a:p>
         </p:txBody>
       </p:sp>
@@ -1278,7 +833,7 @@
           <a:p>
             <a:fld id="{5BCAD085-E8A6-8845-BD4E-CB4CCA059FC4}" type="datetimeFigureOut">
               <a:rPr lang="en-US" smtClean="0"/>
-              <a:t>6/2/2026</a:t>
+              <a:t>1/27/13</a:t>
             </a:fld>
             <a:endParaRPr lang="en-US"/>
           </a:p>
@@ -1381,9 +936,10 @@
           </a:lstStyle>
           <a:p>
             <a:r>
-              <a:rPr lang="en-US"/>
+              <a:rPr lang="en-US" smtClean="0"/>
               <a:t>Click to edit Master title style</a:t>
             </a:r>
+            <a:endParaRPr lang="en-US"/>
           </a:p>
         </p:txBody>
       </p:sp>
@@ -1500,7 +1056,7 @@
           <a:p>
             <a:pPr lvl="0"/>
             <a:r>
-              <a:rPr lang="en-US"/>
+              <a:rPr lang="en-US" smtClean="0"/>
               <a:t>Click to edit Master text styles</a:t>
             </a:r>
           </a:p>
@@ -1523,7 +1079,7 @@
           <a:p>
             <a:fld id="{5BCAD085-E8A6-8845-BD4E-CB4CCA059FC4}" type="datetimeFigureOut">
               <a:rPr lang="en-US" smtClean="0"/>
-              <a:t>6/2/2026</a:t>
+              <a:t>1/27/13</a:t>
             </a:fld>
             <a:endParaRPr lang="en-US"/>
           </a:p>
@@ -1617,9 +1173,10 @@
           <a:lstStyle/>
           <a:p>
             <a:r>
-              <a:rPr lang="en-US"/>
+              <a:rPr lang="en-US" smtClean="0"/>
               <a:t>Click to edit Master title style</a:t>
             </a:r>
+            <a:endParaRPr lang="en-US"/>
           </a:p>
         </p:txBody>
       </p:sp>
@@ -1673,37 +1230,38 @@
           <a:p>
             <a:pPr lvl="0"/>
             <a:r>
-              <a:rPr lang="en-US"/>
+              <a:rPr lang="en-US" smtClean="0"/>
               <a:t>Click to edit Master text styles</a:t>
             </a:r>
           </a:p>
           <a:p>
             <a:pPr lvl="1"/>
             <a:r>
-              <a:rPr lang="en-US"/>
+              <a:rPr lang="en-US" smtClean="0"/>
               <a:t>Second level</a:t>
             </a:r>
           </a:p>
           <a:p>
             <a:pPr lvl="2"/>
             <a:r>
-              <a:rPr lang="en-US"/>
+              <a:rPr lang="en-US" smtClean="0"/>
               <a:t>Third level</a:t>
             </a:r>
           </a:p>
           <a:p>
             <a:pPr lvl="3"/>
             <a:r>
-              <a:rPr lang="en-US"/>
+              <a:rPr lang="en-US" smtClean="0"/>
               <a:t>Fourth level</a:t>
             </a:r>
           </a:p>
           <a:p>
             <a:pPr lvl="4"/>
             <a:r>
-              <a:rPr lang="en-US"/>
+              <a:rPr lang="en-US" smtClean="0"/>
               <a:t>Fifth level</a:t>
             </a:r>
+            <a:endParaRPr lang="en-US"/>
           </a:p>
         </p:txBody>
       </p:sp>
@@ -1757,37 +1315,38 @@
           <a:p>
             <a:pPr lvl="0"/>
             <a:r>
-              <a:rPr lang="en-US"/>
+              <a:rPr lang="en-US" smtClean="0"/>
               <a:t>Click to edit Master text styles</a:t>
             </a:r>
           </a:p>
           <a:p>
             <a:pPr lvl="1"/>
             <a:r>
-              <a:rPr lang="en-US"/>
+              <a:rPr lang="en-US" smtClean="0"/>
               <a:t>Second level</a:t>
             </a:r>
           </a:p>
           <a:p>
             <a:pPr lvl="2"/>
             <a:r>
-              <a:rPr lang="en-US"/>
+              <a:rPr lang="en-US" smtClean="0"/>
               <a:t>Third level</a:t>
             </a:r>
           </a:p>
           <a:p>
             <a:pPr lvl="3"/>
             <a:r>
-              <a:rPr lang="en-US"/>
+              <a:rPr lang="en-US" smtClean="0"/>
               <a:t>Fourth level</a:t>
             </a:r>
           </a:p>
           <a:p>
             <a:pPr lvl="4"/>
             <a:r>
-              <a:rPr lang="en-US"/>
+              <a:rPr lang="en-US" smtClean="0"/>
               <a:t>Fifth level</a:t>
             </a:r>
+            <a:endParaRPr lang="en-US"/>
           </a:p>
         </p:txBody>
       </p:sp>
@@ -1808,7 +1367,7 @@
           <a:p>
             <a:fld id="{5BCAD085-E8A6-8845-BD4E-CB4CCA059FC4}" type="datetimeFigureOut">
               <a:rPr lang="en-US" smtClean="0"/>
-              <a:t>6/2/2026</a:t>
+              <a:t>1/27/13</a:t>
             </a:fld>
             <a:endParaRPr lang="en-US"/>
           </a:p>
@@ -1906,9 +1465,10 @@
           </a:lstStyle>
           <a:p>
             <a:r>
-              <a:rPr lang="en-US"/>
+              <a:rPr lang="en-US" smtClean="0"/>
               <a:t>Click to edit Master title style</a:t>
             </a:r>
+            <a:endParaRPr lang="en-US"/>
           </a:p>
         </p:txBody>
       </p:sp>
@@ -1971,7 +1531,7 @@
           <a:p>
             <a:pPr lvl="0"/>
             <a:r>
-              <a:rPr lang="en-US"/>
+              <a:rPr lang="en-US" smtClean="0"/>
               <a:t>Click to edit Master text styles</a:t>
             </a:r>
           </a:p>
@@ -2027,37 +1587,38 @@
           <a:p>
             <a:pPr lvl="0"/>
             <a:r>
-              <a:rPr lang="en-US"/>
+              <a:rPr lang="en-US" smtClean="0"/>
               <a:t>Click to edit Master text styles</a:t>
             </a:r>
           </a:p>
           <a:p>
             <a:pPr lvl="1"/>
             <a:r>
-              <a:rPr lang="en-US"/>
+              <a:rPr lang="en-US" smtClean="0"/>
               <a:t>Second level</a:t>
             </a:r>
           </a:p>
           <a:p>
             <a:pPr lvl="2"/>
             <a:r>
-              <a:rPr lang="en-US"/>
+              <a:rPr lang="en-US" smtClean="0"/>
               <a:t>Third level</a:t>
             </a:r>
           </a:p>
           <a:p>
             <a:pPr lvl="3"/>
             <a:r>
-              <a:rPr lang="en-US"/>
+              <a:rPr lang="en-US" smtClean="0"/>
               <a:t>Fourth level</a:t>
             </a:r>
           </a:p>
           <a:p>
             <a:pPr lvl="4"/>
             <a:r>
-              <a:rPr lang="en-US"/>
+              <a:rPr lang="en-US" smtClean="0"/>
               <a:t>Fifth level</a:t>
             </a:r>
+            <a:endParaRPr lang="en-US"/>
           </a:p>
         </p:txBody>
       </p:sp>
@@ -2120,7 +1681,7 @@
           <a:p>
             <a:pPr lvl="0"/>
             <a:r>
-              <a:rPr lang="en-US"/>
+              <a:rPr lang="en-US" smtClean="0"/>
               <a:t>Click to edit Master text styles</a:t>
             </a:r>
           </a:p>
@@ -2176,37 +1737,38 @@
           <a:p>
             <a:pPr lvl="0"/>
             <a:r>
-              <a:rPr lang="en-US"/>
+              <a:rPr lang="en-US" smtClean="0"/>
               <a:t>Click to edit Master text styles</a:t>
             </a:r>
           </a:p>
           <a:p>
             <a:pPr lvl="1"/>
             <a:r>
-              <a:rPr lang="en-US"/>
+              <a:rPr lang="en-US" smtClean="0"/>
               <a:t>Second level</a:t>
             </a:r>
           </a:p>
           <a:p>
             <a:pPr lvl="2"/>
             <a:r>
-              <a:rPr lang="en-US"/>
+              <a:rPr lang="en-US" smtClean="0"/>
               <a:t>Third level</a:t>
             </a:r>
           </a:p>
           <a:p>
             <a:pPr lvl="3"/>
             <a:r>
-              <a:rPr lang="en-US"/>
+              <a:rPr lang="en-US" smtClean="0"/>
               <a:t>Fourth level</a:t>
             </a:r>
           </a:p>
           <a:p>
             <a:pPr lvl="4"/>
             <a:r>
-              <a:rPr lang="en-US"/>
+              <a:rPr lang="en-US" smtClean="0"/>
               <a:t>Fifth level</a:t>
             </a:r>
+            <a:endParaRPr lang="en-US"/>
           </a:p>
         </p:txBody>
       </p:sp>
@@ -2227,7 +1789,7 @@
           <a:p>
             <a:fld id="{5BCAD085-E8A6-8845-BD4E-CB4CCA059FC4}" type="datetimeFigureOut">
               <a:rPr lang="en-US" smtClean="0"/>
-              <a:t>6/2/2026</a:t>
+              <a:t>1/27/13</a:t>
             </a:fld>
             <a:endParaRPr lang="en-US"/>
           </a:p>
@@ -2321,9 +1883,10 @@
           <a:lstStyle/>
           <a:p>
             <a:r>
-              <a:rPr lang="en-US"/>
+              <a:rPr lang="en-US" smtClean="0"/>
               <a:t>Click to edit Master title style</a:t>
             </a:r>
+            <a:endParaRPr lang="en-US"/>
           </a:p>
         </p:txBody>
       </p:sp>
@@ -2344,7 +1907,7 @@
           <a:p>
             <a:fld id="{5BCAD085-E8A6-8845-BD4E-CB4CCA059FC4}" type="datetimeFigureOut">
               <a:rPr lang="en-US" smtClean="0"/>
-              <a:t>6/2/2026</a:t>
+              <a:t>1/27/13</a:t>
             </a:fld>
             <a:endParaRPr lang="en-US"/>
           </a:p>
@@ -2439,7 +2002,7 @@
           <a:p>
             <a:fld id="{5BCAD085-E8A6-8845-BD4E-CB4CCA059FC4}" type="datetimeFigureOut">
               <a:rPr lang="en-US" smtClean="0"/>
-              <a:t>6/2/2026</a:t>
+              <a:t>1/27/13</a:t>
             </a:fld>
             <a:endParaRPr lang="en-US"/>
           </a:p>
@@ -2542,9 +2105,10 @@
           </a:lstStyle>
           <a:p>
             <a:r>
-              <a:rPr lang="en-US"/>
+              <a:rPr lang="en-US" smtClean="0"/>
               <a:t>Click to edit Master title style</a:t>
             </a:r>
+            <a:endParaRPr lang="en-US"/>
           </a:p>
         </p:txBody>
       </p:sp>
@@ -2598,37 +2162,38 @@
           <a:p>
             <a:pPr lvl="0"/>
             <a:r>
-              <a:rPr lang="en-US"/>
+              <a:rPr lang="en-US" smtClean="0"/>
               <a:t>Click to edit Master text styles</a:t>
             </a:r>
           </a:p>
           <a:p>
             <a:pPr lvl="1"/>
             <a:r>
-              <a:rPr lang="en-US"/>
+              <a:rPr lang="en-US" smtClean="0"/>
               <a:t>Second level</a:t>
             </a:r>
           </a:p>
           <a:p>
             <a:pPr lvl="2"/>
             <a:r>
-              <a:rPr lang="en-US"/>
+              <a:rPr lang="en-US" smtClean="0"/>
               <a:t>Third level</a:t>
             </a:r>
           </a:p>
           <a:p>
             <a:pPr lvl="3"/>
             <a:r>
-              <a:rPr lang="en-US"/>
+              <a:rPr lang="en-US" smtClean="0"/>
               <a:t>Fourth level</a:t>
             </a:r>
           </a:p>
           <a:p>
             <a:pPr lvl="4"/>
             <a:r>
-              <a:rPr lang="en-US"/>
+              <a:rPr lang="en-US" smtClean="0"/>
               <a:t>Fifth level</a:t>
             </a:r>
+            <a:endParaRPr lang="en-US"/>
           </a:p>
         </p:txBody>
       </p:sp>
@@ -2691,7 +2256,7 @@
           <a:p>
             <a:pPr lvl="0"/>
             <a:r>
-              <a:rPr lang="en-US"/>
+              <a:rPr lang="en-US" smtClean="0"/>
               <a:t>Click to edit Master text styles</a:t>
             </a:r>
           </a:p>
@@ -2714,7 +2279,7 @@
           <a:p>
             <a:fld id="{5BCAD085-E8A6-8845-BD4E-CB4CCA059FC4}" type="datetimeFigureOut">
               <a:rPr lang="en-US" smtClean="0"/>
-              <a:t>6/2/2026</a:t>
+              <a:t>1/27/13</a:t>
             </a:fld>
             <a:endParaRPr lang="en-US"/>
           </a:p>
@@ -2817,9 +2382,10 @@
           </a:lstStyle>
           <a:p>
             <a:r>
-              <a:rPr lang="en-US"/>
+              <a:rPr lang="en-US" smtClean="0"/>
               <a:t>Click to edit Master title style</a:t>
             </a:r>
+            <a:endParaRPr lang="en-US"/>
           </a:p>
         </p:txBody>
       </p:sp>
@@ -2943,7 +2509,7 @@
           <a:p>
             <a:pPr lvl="0"/>
             <a:r>
-              <a:rPr lang="en-US"/>
+              <a:rPr lang="en-US" smtClean="0"/>
               <a:t>Click to edit Master text styles</a:t>
             </a:r>
           </a:p>
@@ -2966,7 +2532,7 @@
           <a:p>
             <a:fld id="{5BCAD085-E8A6-8845-BD4E-CB4CCA059FC4}" type="datetimeFigureOut">
               <a:rPr lang="en-US" smtClean="0"/>
-              <a:t>6/2/2026</a:t>
+              <a:t>1/27/13</a:t>
             </a:fld>
             <a:endParaRPr lang="en-US"/>
           </a:p>
@@ -3075,9 +2641,10 @@
           <a:lstStyle/>
           <a:p>
             <a:r>
-              <a:rPr lang="en-US"/>
+              <a:rPr lang="en-US" smtClean="0"/>
               <a:t>Click to edit Master title style</a:t>
             </a:r>
+            <a:endParaRPr lang="en-US"/>
           </a:p>
         </p:txBody>
       </p:sp>
@@ -3108,37 +2675,38 @@
           <a:p>
             <a:pPr lvl="0"/>
             <a:r>
-              <a:rPr lang="en-US"/>
+              <a:rPr lang="en-US" smtClean="0"/>
               <a:t>Click to edit Master text styles</a:t>
             </a:r>
           </a:p>
           <a:p>
             <a:pPr lvl="1"/>
             <a:r>
-              <a:rPr lang="en-US"/>
+              <a:rPr lang="en-US" smtClean="0"/>
               <a:t>Second level</a:t>
             </a:r>
           </a:p>
           <a:p>
             <a:pPr lvl="2"/>
             <a:r>
-              <a:rPr lang="en-US"/>
+              <a:rPr lang="en-US" smtClean="0"/>
               <a:t>Third level</a:t>
             </a:r>
           </a:p>
           <a:p>
             <a:pPr lvl="3"/>
             <a:r>
-              <a:rPr lang="en-US"/>
+              <a:rPr lang="en-US" smtClean="0"/>
               <a:t>Fourth level</a:t>
             </a:r>
           </a:p>
           <a:p>
             <a:pPr lvl="4"/>
             <a:r>
-              <a:rPr lang="en-US"/>
+              <a:rPr lang="en-US" smtClean="0"/>
               <a:t>Fifth level</a:t>
             </a:r>
+            <a:endParaRPr lang="en-US"/>
           </a:p>
         </p:txBody>
       </p:sp>
@@ -3177,7 +2745,7 @@
           <a:p>
             <a:fld id="{5BCAD085-E8A6-8845-BD4E-CB4CCA059FC4}" type="datetimeFigureOut">
               <a:rPr lang="en-US" smtClean="0"/>
-              <a:t>6/2/2026</a:t>
+              <a:t>1/27/13</a:t>
             </a:fld>
             <a:endParaRPr lang="en-US"/>
           </a:p>
@@ -3536,7 +3104,7 @@
 </file>
 
 <file path=ppt/slides/slide1.xml><?xml version="1.0" encoding="utf-8"?>
-<p:sld xmlns:a="http://schemas.openxmlformats.org/drawingml/2006/main" xmlns:r="http://schemas.openxmlformats.org/officeDocument/2006/relationships" xmlns:p="http://schemas.openxmlformats.org/presentationml/2006/main">
+<p:sld xmlns:a="http://schemas.openxmlformats.org/drawingml/2006/main" xmlns:p="http://schemas.openxmlformats.org/presentationml/2006/main" xmlns:r="http://schemas.openxmlformats.org/officeDocument/2006/relationships">
   <p:cSld>
     <p:bg>
       <p:bgPr>
@@ -3552,14 +3120,7 @@
         <p:cNvGrpSpPr/>
         <p:nvPr/>
       </p:nvGrpSpPr>
-      <p:grpSpPr>
-        <a:xfrm>
-          <a:off x="0" y="0"/>
-          <a:ext cx="0" cy="0"/>
-          <a:chOff x="0" y="0"/>
-          <a:chExt cx="0" cy="0"/>
-        </a:xfrm>
-      </p:grpSpPr>
+      <p:grpSpPr/>
       <p:sp>
         <p:nvSpPr>
           <p:cNvPr id="2" name="Rectangle 1"/>
@@ -3601,7 +3162,6 @@
           <a:lstStyle/>
           <a:p>
             <a:pPr algn="ctr"/>
-            <a:endParaRPr/>
           </a:p>
         </p:txBody>
       </p:sp>
@@ -3622,7 +3182,7 @@
           <a:noFill/>
         </p:spPr>
         <p:txBody>
-          <a:bodyPr wrap="square" lIns="0" tIns="0" rIns="0" bIns="0" anchor="t">
+          <a:bodyPr wrap="square" anchor="t" lIns="0" rIns="0" tIns="0" bIns="0">
             <a:spAutoFit/>
           </a:bodyPr>
           <a:lstStyle/>
@@ -3688,7 +3248,7 @@
           <a:noFill/>
         </p:spPr>
         <p:txBody>
-          <a:bodyPr wrap="square" lIns="0" tIns="0" rIns="0" bIns="0" anchor="t">
+          <a:bodyPr wrap="square" anchor="t" lIns="0" rIns="0" tIns="0" bIns="0">
             <a:spAutoFit/>
           </a:bodyPr>
           <a:lstStyle/>
@@ -3723,7 +3283,7 @@
 </file>
 
 <file path=ppt/slides/slide10.xml><?xml version="1.0" encoding="utf-8"?>
-<p:sld xmlns:a="http://schemas.openxmlformats.org/drawingml/2006/main" xmlns:r="http://schemas.openxmlformats.org/officeDocument/2006/relationships" xmlns:p="http://schemas.openxmlformats.org/presentationml/2006/main">
+<p:sld xmlns:a="http://schemas.openxmlformats.org/drawingml/2006/main" xmlns:p="http://schemas.openxmlformats.org/presentationml/2006/main" xmlns:r="http://schemas.openxmlformats.org/officeDocument/2006/relationships">
   <p:cSld>
     <p:bg>
       <p:bgPr>
@@ -3739,14 +3299,7 @@
         <p:cNvGrpSpPr/>
         <p:nvPr/>
       </p:nvGrpSpPr>
-      <p:grpSpPr>
-        <a:xfrm>
-          <a:off x="0" y="0"/>
-          <a:ext cx="0" cy="0"/>
-          <a:chOff x="0" y="0"/>
-          <a:chExt cx="0" cy="0"/>
-        </a:xfrm>
-      </p:grpSpPr>
+      <p:grpSpPr/>
       <p:sp>
         <p:nvSpPr>
           <p:cNvPr id="2" name="TextBox 1"/>
@@ -3764,7 +3317,7 @@
           <a:noFill/>
         </p:spPr>
         <p:txBody>
-          <a:bodyPr wrap="square" lIns="0" tIns="0" rIns="0" bIns="0" anchor="t">
+          <a:bodyPr wrap="square" anchor="t" lIns="0" rIns="0" tIns="0" bIns="0">
             <a:spAutoFit/>
           </a:bodyPr>
           <a:lstStyle/>
@@ -3838,7 +3391,6 @@
           <a:lstStyle/>
           <a:p>
             <a:pPr algn="ctr"/>
-            <a:endParaRPr/>
           </a:p>
         </p:txBody>
       </p:sp>
@@ -3885,7 +3437,6 @@
           <a:lstStyle/>
           <a:p>
             <a:pPr algn="ctr"/>
-            <a:endParaRPr/>
           </a:p>
         </p:txBody>
       </p:sp>
@@ -3930,7 +3481,6 @@
           <a:lstStyle/>
           <a:p>
             <a:pPr algn="ctr"/>
-            <a:endParaRPr/>
           </a:p>
         </p:txBody>
       </p:sp>
@@ -3951,7 +3501,7 @@
           <a:noFill/>
         </p:spPr>
         <p:txBody>
-          <a:bodyPr wrap="square" lIns="0" tIns="0" rIns="0" bIns="0" anchor="ctr">
+          <a:bodyPr wrap="square" anchor="ctr" lIns="0" rIns="0" tIns="0" bIns="0">
             <a:spAutoFit/>
           </a:bodyPr>
           <a:lstStyle/>
@@ -4016,7 +3566,6 @@
           <a:lstStyle/>
           <a:p>
             <a:pPr algn="ctr"/>
-            <a:endParaRPr/>
           </a:p>
         </p:txBody>
       </p:sp>
@@ -4061,7 +3610,6 @@
           <a:lstStyle/>
           <a:p>
             <a:pPr algn="ctr"/>
-            <a:endParaRPr/>
           </a:p>
         </p:txBody>
       </p:sp>
@@ -4082,7 +3630,7 @@
           <a:noFill/>
         </p:spPr>
         <p:txBody>
-          <a:bodyPr wrap="square" lIns="0" tIns="0" rIns="0" bIns="0" anchor="ctr">
+          <a:bodyPr wrap="square" anchor="ctr" lIns="0" rIns="0" tIns="0" bIns="0">
             <a:spAutoFit/>
           </a:bodyPr>
           <a:lstStyle/>
@@ -4147,7 +3695,6 @@
           <a:lstStyle/>
           <a:p>
             <a:pPr algn="ctr"/>
-            <a:endParaRPr/>
           </a:p>
         </p:txBody>
       </p:sp>
@@ -4192,7 +3739,6 @@
           <a:lstStyle/>
           <a:p>
             <a:pPr algn="ctr"/>
-            <a:endParaRPr/>
           </a:p>
         </p:txBody>
       </p:sp>
@@ -4213,7 +3759,7 @@
           <a:noFill/>
         </p:spPr>
         <p:txBody>
-          <a:bodyPr wrap="square" lIns="0" tIns="0" rIns="0" bIns="0" anchor="ctr">
+          <a:bodyPr wrap="square" anchor="ctr" lIns="0" rIns="0" tIns="0" bIns="0">
             <a:spAutoFit/>
           </a:bodyPr>
           <a:lstStyle/>
@@ -4278,7 +3824,6 @@
           <a:lstStyle/>
           <a:p>
             <a:pPr algn="ctr"/>
-            <a:endParaRPr/>
           </a:p>
         </p:txBody>
       </p:sp>
@@ -4323,7 +3868,6 @@
           <a:lstStyle/>
           <a:p>
             <a:pPr algn="ctr"/>
-            <a:endParaRPr/>
           </a:p>
         </p:txBody>
       </p:sp>
@@ -4344,7 +3888,7 @@
           <a:noFill/>
         </p:spPr>
         <p:txBody>
-          <a:bodyPr wrap="square" lIns="0" tIns="0" rIns="0" bIns="0" anchor="ctr">
+          <a:bodyPr wrap="square" anchor="ctr" lIns="0" rIns="0" tIns="0" bIns="0">
             <a:spAutoFit/>
           </a:bodyPr>
           <a:lstStyle/>
@@ -4407,7 +3951,6 @@
           <a:lstStyle/>
           <a:p>
             <a:pPr algn="ctr"/>
-            <a:endParaRPr/>
           </a:p>
         </p:txBody>
       </p:sp>
@@ -4428,7 +3971,7 @@
           <a:noFill/>
         </p:spPr>
         <p:txBody>
-          <a:bodyPr wrap="square" lIns="0" tIns="0" rIns="0" bIns="0" anchor="t">
+          <a:bodyPr wrap="square" anchor="t" lIns="0" rIns="0" tIns="0" bIns="0">
             <a:spAutoFit/>
           </a:bodyPr>
           <a:lstStyle/>
@@ -4471,7 +4014,7 @@
           <a:noFill/>
         </p:spPr>
         <p:txBody>
-          <a:bodyPr wrap="square" lIns="0" tIns="0" rIns="0" bIns="0" anchor="t">
+          <a:bodyPr wrap="square" anchor="t" lIns="0" rIns="0" tIns="0" bIns="0">
             <a:spAutoFit/>
           </a:bodyPr>
           <a:lstStyle/>
@@ -4498,7 +4041,7 @@
 </file>
 
 <file path=ppt/slides/slide11.xml><?xml version="1.0" encoding="utf-8"?>
-<p:sld xmlns:a="http://schemas.openxmlformats.org/drawingml/2006/main" xmlns:r="http://schemas.openxmlformats.org/officeDocument/2006/relationships" xmlns:p="http://schemas.openxmlformats.org/presentationml/2006/main">
+<p:sld xmlns:a="http://schemas.openxmlformats.org/drawingml/2006/main" xmlns:p="http://schemas.openxmlformats.org/presentationml/2006/main" xmlns:r="http://schemas.openxmlformats.org/officeDocument/2006/relationships">
   <p:cSld>
     <p:bg>
       <p:bgPr>
@@ -4514,14 +4057,7 @@
         <p:cNvGrpSpPr/>
         <p:nvPr/>
       </p:nvGrpSpPr>
-      <p:grpSpPr>
-        <a:xfrm>
-          <a:off x="0" y="0"/>
-          <a:ext cx="0" cy="0"/>
-          <a:chOff x="0" y="0"/>
-          <a:chExt cx="0" cy="0"/>
-        </a:xfrm>
-      </p:grpSpPr>
+      <p:grpSpPr/>
       <p:sp>
         <p:nvSpPr>
           <p:cNvPr id="2" name="Rectangle 1"/>
@@ -4563,7 +4099,6 @@
           <a:lstStyle/>
           <a:p>
             <a:pPr algn="ctr"/>
-            <a:endParaRPr/>
           </a:p>
         </p:txBody>
       </p:sp>
@@ -4584,7 +4119,7 @@
           <a:noFill/>
         </p:spPr>
         <p:txBody>
-          <a:bodyPr wrap="square" lIns="0" tIns="0" rIns="0" bIns="0" anchor="t">
+          <a:bodyPr wrap="square" anchor="t" lIns="0" rIns="0" tIns="0" bIns="0">
             <a:spAutoFit/>
           </a:bodyPr>
           <a:lstStyle/>
@@ -4618,7 +4153,7 @@
           <a:noFill/>
         </p:spPr>
         <p:txBody>
-          <a:bodyPr wrap="square" lIns="0" tIns="0" rIns="0" bIns="0" anchor="t">
+          <a:bodyPr wrap="square" anchor="t" lIns="0" rIns="0" tIns="0" bIns="0">
             <a:spAutoFit/>
           </a:bodyPr>
           <a:lstStyle/>
@@ -4708,7 +4243,6 @@
           <a:lstStyle/>
           <a:p>
             <a:pPr algn="ctr"/>
-            <a:endParaRPr/>
           </a:p>
         </p:txBody>
       </p:sp>
@@ -4729,7 +4263,7 @@
           <a:noFill/>
         </p:spPr>
         <p:txBody>
-          <a:bodyPr wrap="square" lIns="0" tIns="0" rIns="0" bIns="0" anchor="t">
+          <a:bodyPr wrap="square" anchor="t" lIns="0" rIns="0" tIns="0" bIns="0">
             <a:spAutoFit/>
           </a:bodyPr>
           <a:lstStyle/>
@@ -4772,13 +4306,21 @@
           <a:noFill/>
         </p:spPr>
         <p:txBody>
-          <a:bodyPr wrap="square" lIns="0" tIns="0" rIns="0" bIns="0" anchor="t">
+          <a:bodyPr wrap="square" anchor="t" lIns="0" rIns="0" tIns="0" bIns="0">
             <a:spAutoFit/>
           </a:bodyPr>
           <a:lstStyle/>
           <a:p>
             <a:pPr algn="r"/>
-            <a:endParaRPr/>
+            <a:r>
+              <a:rPr sz="1100" b="0" i="0">
+                <a:solidFill>
+                  <a:srgbClr val="7A7A7A"/>
+                </a:solidFill>
+                <a:latin typeface="Roboto"/>
+              </a:rPr>
+              <a:t/>
+            </a:r>
           </a:p>
         </p:txBody>
       </p:sp>
@@ -4791,7 +4333,7 @@
 </file>
 
 <file path=ppt/slides/slide12.xml><?xml version="1.0" encoding="utf-8"?>
-<p:sld xmlns:a="http://schemas.openxmlformats.org/drawingml/2006/main" xmlns:r="http://schemas.openxmlformats.org/officeDocument/2006/relationships" xmlns:p="http://schemas.openxmlformats.org/presentationml/2006/main">
+<p:sld xmlns:a="http://schemas.openxmlformats.org/drawingml/2006/main" xmlns:p="http://schemas.openxmlformats.org/presentationml/2006/main" xmlns:r="http://schemas.openxmlformats.org/officeDocument/2006/relationships">
   <p:cSld>
     <p:bg>
       <p:bgPr>
@@ -4807,14 +4349,7 @@
         <p:cNvGrpSpPr/>
         <p:nvPr/>
       </p:nvGrpSpPr>
-      <p:grpSpPr>
-        <a:xfrm>
-          <a:off x="0" y="0"/>
-          <a:ext cx="0" cy="0"/>
-          <a:chOff x="0" y="0"/>
-          <a:chExt cx="0" cy="0"/>
-        </a:xfrm>
-      </p:grpSpPr>
+      <p:grpSpPr/>
       <p:sp>
         <p:nvSpPr>
           <p:cNvPr id="2" name="TextBox 1"/>
@@ -4832,7 +4367,7 @@
           <a:noFill/>
         </p:spPr>
         <p:txBody>
-          <a:bodyPr wrap="square" lIns="0" tIns="0" rIns="0" bIns="0" anchor="t">
+          <a:bodyPr wrap="square" anchor="t" lIns="0" rIns="0" tIns="0" bIns="0">
             <a:spAutoFit/>
           </a:bodyPr>
           <a:lstStyle/>
@@ -4890,7 +4425,6 @@
           <a:lstStyle/>
           <a:p>
             <a:pPr algn="ctr"/>
-            <a:endParaRPr/>
           </a:p>
         </p:txBody>
       </p:sp>
@@ -4911,7 +4445,7 @@
           <a:noFill/>
         </p:spPr>
         <p:txBody>
-          <a:bodyPr wrap="square" lIns="0" tIns="0" rIns="0" bIns="0" anchor="t">
+          <a:bodyPr wrap="square" anchor="t" lIns="0" rIns="0" tIns="0" bIns="0">
             <a:spAutoFit/>
           </a:bodyPr>
           <a:lstStyle/>
@@ -4996,7 +4530,16 @@
                 </a:solidFill>
                 <a:latin typeface="Roboto"/>
               </a:rPr>
-              <a:t>■  The board decides on total cost + benefit, not a monthly price.</a:t>
+              <a:t>■  </a:t>
+            </a:r>
+            <a:r>
+              <a:rPr sz="1800" b="1" i="0">
+                <a:solidFill>
+                  <a:srgbClr val="27B5CE"/>
+                </a:solidFill>
+                <a:latin typeface="Roboto"/>
+              </a:rPr>
+              <a:t>The board decides on total cost + benefit, not a monthly price.</a:t>
             </a:r>
           </a:p>
         </p:txBody>
@@ -5042,7 +4585,6 @@
           <a:lstStyle/>
           <a:p>
             <a:pPr algn="ctr"/>
-            <a:endParaRPr/>
           </a:p>
         </p:txBody>
       </p:sp>
@@ -5063,7 +4605,7 @@
           <a:noFill/>
         </p:spPr>
         <p:txBody>
-          <a:bodyPr wrap="square" lIns="0" tIns="0" rIns="0" bIns="0" anchor="t">
+          <a:bodyPr wrap="square" anchor="t" lIns="0" rIns="0" tIns="0" bIns="0">
             <a:spAutoFit/>
           </a:bodyPr>
           <a:lstStyle/>
@@ -5106,7 +4648,7 @@
           <a:noFill/>
         </p:spPr>
         <p:txBody>
-          <a:bodyPr wrap="square" lIns="0" tIns="0" rIns="0" bIns="0" anchor="t">
+          <a:bodyPr wrap="square" anchor="t" lIns="0" rIns="0" tIns="0" bIns="0">
             <a:spAutoFit/>
           </a:bodyPr>
           <a:lstStyle/>
@@ -5133,7 +4675,7 @@
 </file>
 
 <file path=ppt/slides/slide13.xml><?xml version="1.0" encoding="utf-8"?>
-<p:sld xmlns:a="http://schemas.openxmlformats.org/drawingml/2006/main" xmlns:r="http://schemas.openxmlformats.org/officeDocument/2006/relationships" xmlns:p="http://schemas.openxmlformats.org/presentationml/2006/main">
+<p:sld xmlns:a="http://schemas.openxmlformats.org/drawingml/2006/main" xmlns:p="http://schemas.openxmlformats.org/presentationml/2006/main" xmlns:r="http://schemas.openxmlformats.org/officeDocument/2006/relationships">
   <p:cSld>
     <p:bg>
       <p:bgPr>
@@ -5149,14 +4691,7 @@
         <p:cNvGrpSpPr/>
         <p:nvPr/>
       </p:nvGrpSpPr>
-      <p:grpSpPr>
-        <a:xfrm>
-          <a:off x="0" y="0"/>
-          <a:ext cx="0" cy="0"/>
-          <a:chOff x="0" y="0"/>
-          <a:chExt cx="0" cy="0"/>
-        </a:xfrm>
-      </p:grpSpPr>
+      <p:grpSpPr/>
       <p:sp>
         <p:nvSpPr>
           <p:cNvPr id="2" name="TextBox 1"/>
@@ -5174,7 +4709,7 @@
           <a:noFill/>
         </p:spPr>
         <p:txBody>
-          <a:bodyPr wrap="square" lIns="0" tIns="0" rIns="0" bIns="0" anchor="t">
+          <a:bodyPr wrap="square" anchor="t" lIns="0" rIns="0" tIns="0" bIns="0">
             <a:spAutoFit/>
           </a:bodyPr>
           <a:lstStyle/>
@@ -5196,7 +4731,7 @@
               </a:spcBef>
             </a:pPr>
             <a:r>
-              <a:rPr sz="1700" b="0" i="1">
+              <a:rPr sz="1800" b="0" i="1">
                 <a:solidFill>
                   <a:srgbClr val="D68E10"/>
                 </a:solidFill>
@@ -5248,7 +4783,6 @@
           <a:lstStyle/>
           <a:p>
             <a:pPr algn="ctr"/>
-            <a:endParaRPr/>
           </a:p>
         </p:txBody>
       </p:sp>
@@ -5269,7 +4803,7 @@
           <a:noFill/>
         </p:spPr>
         <p:txBody>
-          <a:bodyPr wrap="square" lIns="0" tIns="0" rIns="0" bIns="0" anchor="t">
+          <a:bodyPr wrap="square" anchor="t" lIns="0" rIns="0" tIns="0" bIns="0">
             <a:spAutoFit/>
           </a:bodyPr>
           <a:lstStyle/>
@@ -5354,7 +4888,16 @@
                 </a:solidFill>
                 <a:latin typeface="Roboto"/>
               </a:rPr>
-              <a:t>■  State every assumption — an unstated assumption is a hole in the case.</a:t>
+              <a:t>■  </a:t>
+            </a:r>
+            <a:r>
+              <a:rPr sz="1800" b="1" i="0">
+                <a:solidFill>
+                  <a:srgbClr val="27B5CE"/>
+                </a:solidFill>
+                <a:latin typeface="Roboto"/>
+              </a:rPr>
+              <a:t>State every assumption — an unstated assumption is a hole in the case.</a:t>
             </a:r>
           </a:p>
           <a:p>
@@ -5431,7 +4974,6 @@
           <a:lstStyle/>
           <a:p>
             <a:pPr algn="ctr"/>
-            <a:endParaRPr/>
           </a:p>
         </p:txBody>
       </p:sp>
@@ -5452,7 +4994,7 @@
           <a:noFill/>
         </p:spPr>
         <p:txBody>
-          <a:bodyPr wrap="square" lIns="0" tIns="0" rIns="0" bIns="0" anchor="t">
+          <a:bodyPr wrap="square" anchor="t" lIns="0" rIns="0" tIns="0" bIns="0">
             <a:spAutoFit/>
           </a:bodyPr>
           <a:lstStyle/>
@@ -5495,7 +5037,7 @@
           <a:noFill/>
         </p:spPr>
         <p:txBody>
-          <a:bodyPr wrap="square" lIns="0" tIns="0" rIns="0" bIns="0" anchor="t">
+          <a:bodyPr wrap="square" anchor="t" lIns="0" rIns="0" tIns="0" bIns="0">
             <a:spAutoFit/>
           </a:bodyPr>
           <a:lstStyle/>
@@ -5522,7 +5064,7 @@
 </file>
 
 <file path=ppt/slides/slide14.xml><?xml version="1.0" encoding="utf-8"?>
-<p:sld xmlns:a="http://schemas.openxmlformats.org/drawingml/2006/main" xmlns:r="http://schemas.openxmlformats.org/officeDocument/2006/relationships" xmlns:p="http://schemas.openxmlformats.org/presentationml/2006/main">
+<p:sld xmlns:a="http://schemas.openxmlformats.org/drawingml/2006/main" xmlns:p="http://schemas.openxmlformats.org/presentationml/2006/main" xmlns:r="http://schemas.openxmlformats.org/officeDocument/2006/relationships">
   <p:cSld>
     <p:bg>
       <p:bgPr>
@@ -5538,14 +5080,7 @@
         <p:cNvGrpSpPr/>
         <p:nvPr/>
       </p:nvGrpSpPr>
-      <p:grpSpPr>
-        <a:xfrm>
-          <a:off x="0" y="0"/>
-          <a:ext cx="0" cy="0"/>
-          <a:chOff x="0" y="0"/>
-          <a:chExt cx="0" cy="0"/>
-        </a:xfrm>
-      </p:grpSpPr>
+      <p:grpSpPr/>
       <p:sp>
         <p:nvSpPr>
           <p:cNvPr id="2" name="TextBox 1"/>
@@ -5563,7 +5098,7 @@
           <a:noFill/>
         </p:spPr>
         <p:txBody>
-          <a:bodyPr wrap="square" lIns="0" tIns="0" rIns="0" bIns="0" anchor="t">
+          <a:bodyPr wrap="square" anchor="t" lIns="0" rIns="0" tIns="0" bIns="0">
             <a:spAutoFit/>
           </a:bodyPr>
           <a:lstStyle/>
@@ -5621,7 +5156,6 @@
           <a:lstStyle/>
           <a:p>
             <a:pPr algn="ctr"/>
-            <a:endParaRPr/>
           </a:p>
         </p:txBody>
       </p:sp>
@@ -5642,7 +5176,7 @@
           <a:noFill/>
         </p:spPr>
         <p:txBody>
-          <a:bodyPr wrap="square" lIns="0" tIns="0" rIns="0" bIns="0" anchor="t">
+          <a:bodyPr wrap="square" anchor="t" lIns="0" rIns="0" tIns="0" bIns="0">
             <a:spAutoFit/>
           </a:bodyPr>
           <a:lstStyle/>
@@ -5727,7 +5261,16 @@
                 </a:solidFill>
                 <a:latin typeface="Roboto"/>
               </a:rPr>
-              <a:t>■  Watch software licensing (Windows / SQL Server) — it rides on BOTH options; don't drop it.</a:t>
+              <a:t>■  </a:t>
+            </a:r>
+            <a:r>
+              <a:rPr sz="1800" b="1" i="0">
+                <a:solidFill>
+                  <a:srgbClr val="27B5CE"/>
+                </a:solidFill>
+                <a:latin typeface="Roboto"/>
+              </a:rPr>
+              <a:t>Watch software licensing (Windows / SQL Server) — it rides on BOTH options; don't drop it.</a:t>
             </a:r>
           </a:p>
         </p:txBody>
@@ -5773,7 +5316,6 @@
           <a:lstStyle/>
           <a:p>
             <a:pPr algn="ctr"/>
-            <a:endParaRPr/>
           </a:p>
         </p:txBody>
       </p:sp>
@@ -5794,7 +5336,7 @@
           <a:noFill/>
         </p:spPr>
         <p:txBody>
-          <a:bodyPr wrap="square" lIns="0" tIns="0" rIns="0" bIns="0" anchor="t">
+          <a:bodyPr wrap="square" anchor="t" lIns="0" rIns="0" tIns="0" bIns="0">
             <a:spAutoFit/>
           </a:bodyPr>
           <a:lstStyle/>
@@ -5837,7 +5379,7 @@
           <a:noFill/>
         </p:spPr>
         <p:txBody>
-          <a:bodyPr wrap="square" lIns="0" tIns="0" rIns="0" bIns="0" anchor="t">
+          <a:bodyPr wrap="square" anchor="t" lIns="0" rIns="0" tIns="0" bIns="0">
             <a:spAutoFit/>
           </a:bodyPr>
           <a:lstStyle/>
@@ -5864,7 +5406,7 @@
 </file>
 
 <file path=ppt/slides/slide15.xml><?xml version="1.0" encoding="utf-8"?>
-<p:sld xmlns:a="http://schemas.openxmlformats.org/drawingml/2006/main" xmlns:r="http://schemas.openxmlformats.org/officeDocument/2006/relationships" xmlns:p="http://schemas.openxmlformats.org/presentationml/2006/main">
+<p:sld xmlns:a="http://schemas.openxmlformats.org/drawingml/2006/main" xmlns:p="http://schemas.openxmlformats.org/presentationml/2006/main" xmlns:r="http://schemas.openxmlformats.org/officeDocument/2006/relationships">
   <p:cSld>
     <p:bg>
       <p:bgPr>
@@ -5880,14 +5422,7 @@
         <p:cNvGrpSpPr/>
         <p:nvPr/>
       </p:nvGrpSpPr>
-      <p:grpSpPr>
-        <a:xfrm>
-          <a:off x="0" y="0"/>
-          <a:ext cx="0" cy="0"/>
-          <a:chOff x="0" y="0"/>
-          <a:chExt cx="0" cy="0"/>
-        </a:xfrm>
-      </p:grpSpPr>
+      <p:grpSpPr/>
       <p:sp>
         <p:nvSpPr>
           <p:cNvPr id="2" name="TextBox 1"/>
@@ -5905,7 +5440,7 @@
           <a:noFill/>
         </p:spPr>
         <p:txBody>
-          <a:bodyPr wrap="square" lIns="0" tIns="0" rIns="0" bIns="0" anchor="t">
+          <a:bodyPr wrap="square" anchor="t" lIns="0" rIns="0" tIns="0" bIns="0">
             <a:spAutoFit/>
           </a:bodyPr>
           <a:lstStyle/>
@@ -5927,7 +5462,7 @@
               </a:spcBef>
             </a:pPr>
             <a:r>
-              <a:rPr sz="1700" b="0" i="1">
+              <a:rPr sz="1800" b="0" i="1">
                 <a:solidFill>
                   <a:srgbClr val="D68E10"/>
                 </a:solidFill>
@@ -5979,7 +5514,6 @@
           <a:lstStyle/>
           <a:p>
             <a:pPr algn="ctr"/>
-            <a:endParaRPr/>
           </a:p>
         </p:txBody>
       </p:sp>
@@ -6000,7 +5534,7 @@
           <a:noFill/>
         </p:spPr>
         <p:txBody>
-          <a:bodyPr wrap="square" lIns="0" tIns="0" rIns="0" bIns="0" anchor="t">
+          <a:bodyPr wrap="square" anchor="t" lIns="0" rIns="0" tIns="0" bIns="0">
             <a:spAutoFit/>
           </a:bodyPr>
           <a:lstStyle/>
@@ -6161,9 +5695,33 @@
           </a:p>
         </p:txBody>
       </p:sp>
-      <p:sp>
-        <p:nvSpPr>
-          <p:cNvPr id="7" name="Rectangle 6"/>
+      <p:pic>
+        <p:nvPicPr>
+          <p:cNvPr id="5" name="Picture 4" descr="03-pricing-calculator.png"/>
+          <p:cNvPicPr>
+            <a:picLocks noChangeAspect="1"/>
+          </p:cNvPicPr>
+          <p:nvPr/>
+        </p:nvPicPr>
+        <p:blipFill>
+          <a:blip r:embed="rId2"/>
+          <a:stretch>
+            <a:fillRect/>
+          </a:stretch>
+        </p:blipFill>
+        <p:spPr>
+          <a:xfrm>
+            <a:off x="6400800" y="2297709"/>
+            <a:ext cx="5120640" cy="2994101"/>
+          </a:xfrm>
+          <a:prstGeom prst="rect">
+            <a:avLst/>
+          </a:prstGeom>
+        </p:spPr>
+      </p:pic>
+      <p:sp>
+        <p:nvSpPr>
+          <p:cNvPr id="6" name="Rectangle 5"/>
           <p:cNvSpPr/>
           <p:nvPr/>
         </p:nvSpPr>
@@ -6202,7 +5760,49 @@
           <a:lstStyle/>
           <a:p>
             <a:pPr algn="ctr"/>
-            <a:endParaRPr/>
+          </a:p>
+        </p:txBody>
+      </p:sp>
+      <p:sp>
+        <p:nvSpPr>
+          <p:cNvPr id="7" name="TextBox 6"/>
+          <p:cNvSpPr txBox="1"/>
+          <p:nvPr/>
+        </p:nvSpPr>
+        <p:spPr>
+          <a:xfrm>
+            <a:off x="502920" y="6400800"/>
+            <a:ext cx="5486400" cy="320040"/>
+          </a:xfrm>
+          <a:prstGeom prst="rect">
+            <a:avLst/>
+          </a:prstGeom>
+          <a:noFill/>
+        </p:spPr>
+        <p:txBody>
+          <a:bodyPr wrap="square" anchor="t" lIns="0" rIns="0" tIns="0" bIns="0">
+            <a:spAutoFit/>
+          </a:bodyPr>
+          <a:lstStyle/>
+          <a:p>
+            <a:r>
+              <a:rPr sz="1100" b="1" i="0">
+                <a:solidFill>
+                  <a:srgbClr val="2A2929"/>
+                </a:solidFill>
+                <a:latin typeface="Roboto"/>
+              </a:rPr>
+              <a:t>Kangan </a:t>
+            </a:r>
+            <a:r>
+              <a:rPr sz="1100" b="1" i="0">
+                <a:solidFill>
+                  <a:srgbClr val="D68E10"/>
+                </a:solidFill>
+                <a:latin typeface="Roboto"/>
+              </a:rPr>
+              <a:t>Institute</a:t>
+            </a:r>
           </a:p>
         </p:txBody>
       </p:sp>
@@ -6214,8 +5814,8 @@
         </p:nvSpPr>
         <p:spPr>
           <a:xfrm>
-            <a:off x="502920" y="6400800"/>
-            <a:ext cx="5486400" cy="320040"/>
+            <a:off x="10515600" y="6400800"/>
+            <a:ext cx="1188720" cy="320040"/>
           </a:xfrm>
           <a:prstGeom prst="rect">
             <a:avLst/>
@@ -6223,54 +5823,11 @@
           <a:noFill/>
         </p:spPr>
         <p:txBody>
-          <a:bodyPr wrap="square" lIns="0" tIns="0" rIns="0" bIns="0" anchor="t">
+          <a:bodyPr wrap="square" anchor="t" lIns="0" rIns="0" tIns="0" bIns="0">
             <a:spAutoFit/>
           </a:bodyPr>
           <a:lstStyle/>
           <a:p>
-            <a:r>
-              <a:rPr sz="1100" b="1" i="0">
-                <a:solidFill>
-                  <a:srgbClr val="2A2929"/>
-                </a:solidFill>
-                <a:latin typeface="Roboto"/>
-              </a:rPr>
-              <a:t>Kangan </a:t>
-            </a:r>
-            <a:r>
-              <a:rPr sz="1100" b="1" i="0">
-                <a:solidFill>
-                  <a:srgbClr val="D68E10"/>
-                </a:solidFill>
-                <a:latin typeface="Roboto"/>
-              </a:rPr>
-              <a:t>Institute</a:t>
-            </a:r>
-          </a:p>
-        </p:txBody>
-      </p:sp>
-      <p:sp>
-        <p:nvSpPr>
-          <p:cNvPr id="9" name="TextBox 8"/>
-          <p:cNvSpPr txBox="1"/>
-          <p:nvPr/>
-        </p:nvSpPr>
-        <p:spPr>
-          <a:xfrm>
-            <a:off x="10515600" y="6400800"/>
-            <a:ext cx="1188720" cy="320040"/>
-          </a:xfrm>
-          <a:prstGeom prst="rect">
-            <a:avLst/>
-          </a:prstGeom>
-          <a:noFill/>
-        </p:spPr>
-        <p:txBody>
-          <a:bodyPr wrap="square" lIns="0" tIns="0" rIns="0" bIns="0" anchor="t">
-            <a:spAutoFit/>
-          </a:bodyPr>
-          <a:lstStyle/>
-          <a:p>
             <a:pPr algn="r"/>
             <a:r>
               <a:rPr sz="1100" b="0" i="0">
@@ -6281,89 +5838,6 @@
               </a:rPr>
               <a:t>12</a:t>
             </a:r>
-          </a:p>
-        </p:txBody>
-      </p:sp>
-      <p:pic>
-        <p:nvPicPr>
-          <p:cNvPr id="10" name="Picture 9" descr="AWS Pricing Calculator website.">
-            <a:extLst>
-              <a:ext uri="{FF2B5EF4-FFF2-40B4-BE49-F238E27FC236}">
-                <a16:creationId xmlns:a16="http://schemas.microsoft.com/office/drawing/2014/main" id="{95B9C72A-111D-DAD9-C6A0-94B048AB7340}"/>
-              </a:ext>
-            </a:extLst>
-          </p:cNvPr>
-          <p:cNvPicPr>
-            <a:picLocks noChangeAspect="1"/>
-          </p:cNvPicPr>
-          <p:nvPr/>
-        </p:nvPicPr>
-        <p:blipFill>
-          <a:blip r:embed="rId3"/>
-          <a:stretch>
-            <a:fillRect/>
-          </a:stretch>
-        </p:blipFill>
-        <p:spPr>
-          <a:xfrm>
-            <a:off x="6334530" y="1554511"/>
-            <a:ext cx="5575239" cy="3259912"/>
-          </a:xfrm>
-          <a:prstGeom prst="rect">
-            <a:avLst/>
-          </a:prstGeom>
-        </p:spPr>
-      </p:pic>
-      <p:sp>
-        <p:nvSpPr>
-          <p:cNvPr id="11" name="TextBox 10">
-            <a:extLst>
-              <a:ext uri="{FF2B5EF4-FFF2-40B4-BE49-F238E27FC236}">
-                <a16:creationId xmlns:a16="http://schemas.microsoft.com/office/drawing/2014/main" id="{3F5B2059-4D5B-5F24-D2BC-166916F6BCCF}"/>
-              </a:ext>
-            </a:extLst>
-          </p:cNvPr>
-          <p:cNvSpPr txBox="1"/>
-          <p:nvPr/>
-        </p:nvSpPr>
-        <p:spPr>
-          <a:xfrm>
-            <a:off x="6748744" y="4841824"/>
-            <a:ext cx="4746812" cy="461665"/>
-          </a:xfrm>
-          <a:prstGeom prst="rect">
-            <a:avLst/>
-          </a:prstGeom>
-          <a:noFill/>
-        </p:spPr>
-        <p:txBody>
-          <a:bodyPr wrap="none" rtlCol="0">
-            <a:spAutoFit/>
-          </a:bodyPr>
-          <a:lstStyle/>
-          <a:p>
-            <a:r>
-              <a:rPr lang="en-US" sz="2400" dirty="0">
-                <a:latin typeface="Amazon Ember Light" panose="020B0403020204020204" pitchFamily="34" charset="0"/>
-                <a:ea typeface="Amazon Ember Light" panose="020B0403020204020204" pitchFamily="34" charset="0"/>
-                <a:cs typeface="Amazon Ember Light" panose="020B0403020204020204" pitchFamily="34" charset="0"/>
-              </a:rPr>
-              <a:t>Access the </a:t>
-            </a:r>
-            <a:r>
-              <a:rPr lang="en-US" sz="2400" dirty="0">
-                <a:latin typeface="Amazon Ember Light" panose="020B0403020204020204" pitchFamily="34" charset="0"/>
-                <a:ea typeface="Amazon Ember Light" panose="020B0403020204020204" pitchFamily="34" charset="0"/>
-                <a:cs typeface="Amazon Ember Light" panose="020B0403020204020204" pitchFamily="34" charset="0"/>
-                <a:hlinkClick r:id="rId4"/>
-              </a:rPr>
-              <a:t>AWS Pricing Calculator</a:t>
-            </a:r>
-            <a:endParaRPr lang="en-US" sz="2400" dirty="0">
-              <a:latin typeface="Amazon Ember Light" panose="020B0403020204020204" pitchFamily="34" charset="0"/>
-              <a:ea typeface="Amazon Ember Light" panose="020B0403020204020204" pitchFamily="34" charset="0"/>
-              <a:cs typeface="Amazon Ember Light" panose="020B0403020204020204" pitchFamily="34" charset="0"/>
-            </a:endParaRPr>
           </a:p>
         </p:txBody>
       </p:sp>
@@ -6376,7 +5850,7 @@
 </file>
 
 <file path=ppt/slides/slide16.xml><?xml version="1.0" encoding="utf-8"?>
-<p:sld xmlns:a="http://schemas.openxmlformats.org/drawingml/2006/main" xmlns:r="http://schemas.openxmlformats.org/officeDocument/2006/relationships" xmlns:p="http://schemas.openxmlformats.org/presentationml/2006/main">
+<p:sld xmlns:a="http://schemas.openxmlformats.org/drawingml/2006/main" xmlns:p="http://schemas.openxmlformats.org/presentationml/2006/main" xmlns:r="http://schemas.openxmlformats.org/officeDocument/2006/relationships">
   <p:cSld>
     <p:bg>
       <p:bgPr>
@@ -6392,14 +5866,7 @@
         <p:cNvGrpSpPr/>
         <p:nvPr/>
       </p:nvGrpSpPr>
-      <p:grpSpPr>
-        <a:xfrm>
-          <a:off x="0" y="0"/>
-          <a:ext cx="0" cy="0"/>
-          <a:chOff x="0" y="0"/>
-          <a:chExt cx="0" cy="0"/>
-        </a:xfrm>
-      </p:grpSpPr>
+      <p:grpSpPr/>
       <p:sp>
         <p:nvSpPr>
           <p:cNvPr id="2" name="Rectangle 1"/>
@@ -6441,7 +5908,6 @@
           <a:lstStyle/>
           <a:p>
             <a:pPr algn="ctr"/>
-            <a:endParaRPr/>
           </a:p>
         </p:txBody>
       </p:sp>
@@ -6482,7 +5948,7 @@
           </a:fontRef>
         </p:style>
         <p:txBody>
-          <a:bodyPr wrap="none" rtlCol="0" anchor="ctr"/>
+          <a:bodyPr rtlCol="0" anchor="ctr"/>
           <a:lstStyle/>
           <a:p>
             <a:pPr algn="ctr"/>
@@ -6515,7 +5981,7 @@
           <a:noFill/>
         </p:spPr>
         <p:txBody>
-          <a:bodyPr wrap="square" lIns="0" tIns="0" rIns="0" bIns="0" anchor="ctr">
+          <a:bodyPr wrap="square" anchor="ctr" lIns="0" rIns="0" tIns="0" bIns="0">
             <a:spAutoFit/>
           </a:bodyPr>
           <a:lstStyle/>
@@ -6549,7 +6015,7 @@
           <a:noFill/>
         </p:spPr>
         <p:txBody>
-          <a:bodyPr wrap="square" lIns="0" tIns="0" rIns="0" bIns="0" anchor="t">
+          <a:bodyPr wrap="square" anchor="t" lIns="0" rIns="0" tIns="0" bIns="0">
             <a:spAutoFit/>
           </a:bodyPr>
           <a:lstStyle/>
@@ -6566,7 +6032,7 @@
               </a:spcAft>
             </a:pPr>
             <a:r>
-              <a:rPr sz="1700" b="1" i="0" dirty="0">
+              <a:rPr sz="1700" b="1" i="0">
                 <a:solidFill>
                   <a:srgbClr val="EDAB0C"/>
                 </a:solidFill>
@@ -6575,7 +6041,7 @@
               <a:t>■  </a:t>
             </a:r>
             <a:r>
-              <a:rPr sz="1700" b="1" i="0" dirty="0">
+              <a:rPr sz="1700" b="1" i="0">
                 <a:solidFill>
                   <a:srgbClr val="2A2929"/>
                 </a:solidFill>
@@ -6597,7 +6063,7 @@
               </a:spcAft>
             </a:pPr>
             <a:r>
-              <a:rPr sz="1700" b="1" i="0" dirty="0">
+              <a:rPr sz="1700" b="1" i="0">
                 <a:solidFill>
                   <a:srgbClr val="EDAB0C"/>
                 </a:solidFill>
@@ -6606,7 +6072,7 @@
               <a:t>■  </a:t>
             </a:r>
             <a:r>
-              <a:rPr sz="1700" b="0" i="0" dirty="0">
+              <a:rPr sz="1700" b="0" i="0">
                 <a:solidFill>
                   <a:srgbClr val="2A2929"/>
                 </a:solidFill>
@@ -6628,7 +6094,7 @@
               </a:spcAft>
             </a:pPr>
             <a:r>
-              <a:rPr sz="1400" b="0" i="0" dirty="0">
+              <a:rPr sz="1400" b="0" i="0">
                 <a:solidFill>
                   <a:srgbClr val="7A7A7A"/>
                 </a:solidFill>
@@ -6637,7 +6103,7 @@
               <a:t>–  </a:t>
             </a:r>
             <a:r>
-              <a:rPr sz="1400" b="0" i="0" dirty="0">
+              <a:rPr sz="1400" b="0" i="0">
                 <a:solidFill>
                   <a:srgbClr val="2A2929"/>
                 </a:solidFill>
@@ -6659,7 +6125,7 @@
               </a:spcAft>
             </a:pPr>
             <a:r>
-              <a:rPr sz="1400" b="0" i="0" dirty="0">
+              <a:rPr sz="1400" b="0" i="0">
                 <a:solidFill>
                   <a:srgbClr val="7A7A7A"/>
                 </a:solidFill>
@@ -6668,7 +6134,7 @@
               <a:t>–  </a:t>
             </a:r>
             <a:r>
-              <a:rPr sz="1400" b="0" i="0" dirty="0">
+              <a:rPr sz="1400" b="0" i="0">
                 <a:solidFill>
                   <a:srgbClr val="2A2929"/>
                 </a:solidFill>
@@ -6690,7 +6156,7 @@
               </a:spcAft>
             </a:pPr>
             <a:r>
-              <a:rPr sz="1400" b="0" i="0" dirty="0">
+              <a:rPr sz="1400" b="0" i="0">
                 <a:solidFill>
                   <a:srgbClr val="7A7A7A"/>
                 </a:solidFill>
@@ -6699,7 +6165,7 @@
               <a:t>–  </a:t>
             </a:r>
             <a:r>
-              <a:rPr sz="1400" b="0" i="0" dirty="0">
+              <a:rPr sz="1400" b="0" i="0">
                 <a:solidFill>
                   <a:srgbClr val="2A2929"/>
                 </a:solidFill>
@@ -6721,7 +6187,7 @@
               </a:spcAft>
             </a:pPr>
             <a:r>
-              <a:rPr sz="1700" b="1" i="0" dirty="0">
+              <a:rPr sz="1700" b="1" i="0">
                 <a:solidFill>
                   <a:srgbClr val="27B5CE"/>
                 </a:solidFill>
@@ -6730,7 +6196,7 @@
               <a:t>■  </a:t>
             </a:r>
             <a:r>
-              <a:rPr sz="1700" b="0" i="0" dirty="0">
+              <a:rPr sz="1700" b="0" i="0">
                 <a:solidFill>
                   <a:srgbClr val="27B5CE"/>
                 </a:solidFill>
@@ -6752,7 +6218,7 @@
               </a:spcAft>
             </a:pPr>
             <a:r>
-              <a:rPr sz="1700" b="1" i="0" dirty="0">
+              <a:rPr sz="1700" b="1" i="0">
                 <a:solidFill>
                   <a:srgbClr val="EDAB0C"/>
                 </a:solidFill>
@@ -6761,29 +6227,14 @@
               <a:t>■  </a:t>
             </a:r>
             <a:r>
-              <a:rPr sz="1700" b="0" i="0" dirty="0">
+              <a:rPr sz="1700" b="0" i="0">
                 <a:solidFill>
                   <a:srgbClr val="484848"/>
                 </a:solidFill>
                 <a:latin typeface="Roboto"/>
               </a:rPr>
-              <a:t>🔗  </a:t>
-            </a:r>
-            <a:r>
-              <a:rPr sz="1700" b="0" i="0" dirty="0" err="1">
-                <a:solidFill>
-                  <a:srgbClr val="484848"/>
-                </a:solidFill>
-                <a:latin typeface="Roboto"/>
-              </a:rPr>
-              <a:t>calculator.aws</a:t>
-            </a:r>
-            <a:endParaRPr sz="1700" b="0" i="0" dirty="0">
-              <a:solidFill>
-                <a:srgbClr val="484848"/>
-              </a:solidFill>
-              <a:latin typeface="Roboto"/>
-            </a:endParaRPr>
+              <a:t>🔗  calculator.aws</a:t>
+            </a:r>
           </a:p>
         </p:txBody>
       </p:sp>
@@ -6830,7 +6281,6 @@
           <a:lstStyle/>
           <a:p>
             <a:pPr algn="ctr"/>
-            <a:endParaRPr/>
           </a:p>
         </p:txBody>
       </p:sp>
@@ -6851,7 +6301,7 @@
           <a:noFill/>
         </p:spPr>
         <p:txBody>
-          <a:bodyPr wrap="square" lIns="0" tIns="0" rIns="0" bIns="0" anchor="ctr">
+          <a:bodyPr wrap="square" anchor="ctr" lIns="0" rIns="0" tIns="0" bIns="0">
             <a:spAutoFit/>
           </a:bodyPr>
           <a:lstStyle/>
@@ -6909,7 +6359,6 @@
           <a:lstStyle/>
           <a:p>
             <a:pPr algn="ctr"/>
-            <a:endParaRPr/>
           </a:p>
         </p:txBody>
       </p:sp>
@@ -6930,7 +6379,7 @@
           <a:noFill/>
         </p:spPr>
         <p:txBody>
-          <a:bodyPr wrap="square" lIns="0" tIns="0" rIns="0" bIns="0" anchor="t">
+          <a:bodyPr wrap="square" anchor="t" lIns="0" rIns="0" tIns="0" bIns="0">
             <a:spAutoFit/>
           </a:bodyPr>
           <a:lstStyle/>
@@ -6973,7 +6422,7 @@
           <a:noFill/>
         </p:spPr>
         <p:txBody>
-          <a:bodyPr wrap="square" lIns="0" tIns="0" rIns="0" bIns="0" anchor="t">
+          <a:bodyPr wrap="square" anchor="t" lIns="0" rIns="0" tIns="0" bIns="0">
             <a:spAutoFit/>
           </a:bodyPr>
           <a:lstStyle/>
@@ -6991,204 +6440,6 @@
           </a:p>
         </p:txBody>
       </p:sp>
-      <p:grpSp>
-        <p:nvGrpSpPr>
-          <p:cNvPr id="11" name="Group 10" descr="Choosing the create estimate button to open the Pricing Calculator tool.">
-            <a:extLst>
-              <a:ext uri="{FF2B5EF4-FFF2-40B4-BE49-F238E27FC236}">
-                <a16:creationId xmlns:a16="http://schemas.microsoft.com/office/drawing/2014/main" id="{0DBFEC46-9CEB-D6AE-68EA-944EEE082022}"/>
-              </a:ext>
-            </a:extLst>
-          </p:cNvPr>
-          <p:cNvGrpSpPr/>
-          <p:nvPr/>
-        </p:nvGrpSpPr>
-        <p:grpSpPr>
-          <a:xfrm>
-            <a:off x="2990712" y="3806388"/>
-            <a:ext cx="8100335" cy="2365812"/>
-            <a:chOff x="337813" y="2816435"/>
-            <a:chExt cx="11516375" cy="3405498"/>
-          </a:xfrm>
-        </p:grpSpPr>
-        <p:grpSp>
-          <p:nvGrpSpPr>
-            <p:cNvPr id="12" name="Group 11" descr="Screenshot of AWS Pricing Calculator website and tool.">
-              <a:extLst>
-                <a:ext uri="{FF2B5EF4-FFF2-40B4-BE49-F238E27FC236}">
-                  <a16:creationId xmlns:a16="http://schemas.microsoft.com/office/drawing/2014/main" id="{8E3B2791-A466-9375-2B42-E979E2FFD0D4}"/>
-                </a:ext>
-              </a:extLst>
-            </p:cNvPr>
-            <p:cNvGrpSpPr/>
-            <p:nvPr/>
-          </p:nvGrpSpPr>
-          <p:grpSpPr>
-            <a:xfrm>
-              <a:off x="337813" y="2816435"/>
-              <a:ext cx="11516375" cy="3405498"/>
-              <a:chOff x="449698" y="2576595"/>
-              <a:chExt cx="11516375" cy="3405498"/>
-            </a:xfrm>
-          </p:grpSpPr>
-          <p:pic>
-            <p:nvPicPr>
-              <p:cNvPr id="14" name="Picture 13" descr="screenshot of create estimate button on AWS Pricing Calculator website.">
-                <a:extLst>
-                  <a:ext uri="{FF2B5EF4-FFF2-40B4-BE49-F238E27FC236}">
-                    <a16:creationId xmlns:a16="http://schemas.microsoft.com/office/drawing/2014/main" id="{767AA6D4-5392-3B1C-42DD-977ECA5CAE61}"/>
-                  </a:ext>
-                </a:extLst>
-              </p:cNvPr>
-              <p:cNvPicPr>
-                <a:picLocks noChangeAspect="1"/>
-              </p:cNvPicPr>
-              <p:nvPr/>
-            </p:nvPicPr>
-            <p:blipFill>
-              <a:blip r:embed="rId2"/>
-              <a:stretch>
-                <a:fillRect/>
-              </a:stretch>
-            </p:blipFill>
-            <p:spPr>
-              <a:xfrm>
-                <a:off x="449698" y="2782726"/>
-                <a:ext cx="4881805" cy="2139685"/>
-              </a:xfrm>
-              <a:prstGeom prst="rect">
-                <a:avLst/>
-              </a:prstGeom>
-            </p:spPr>
-          </p:pic>
-          <p:pic>
-            <p:nvPicPr>
-              <p:cNvPr id="15" name="Picture 14" descr="Screenshot of AWS Pricing Calculator tool.">
-                <a:extLst>
-                  <a:ext uri="{FF2B5EF4-FFF2-40B4-BE49-F238E27FC236}">
-                    <a16:creationId xmlns:a16="http://schemas.microsoft.com/office/drawing/2014/main" id="{8959ABA3-FEBF-6A9F-AFD7-D634B5C569DF}"/>
-                  </a:ext>
-                </a:extLst>
-              </p:cNvPr>
-              <p:cNvPicPr>
-                <a:picLocks noChangeAspect="1"/>
-              </p:cNvPicPr>
-              <p:nvPr/>
-            </p:nvPicPr>
-            <p:blipFill>
-              <a:blip r:embed="rId3"/>
-              <a:stretch>
-                <a:fillRect/>
-              </a:stretch>
-            </p:blipFill>
-            <p:spPr>
-              <a:xfrm>
-                <a:off x="6420742" y="2576595"/>
-                <a:ext cx="5545331" cy="3405498"/>
-              </a:xfrm>
-              <a:prstGeom prst="rect">
-                <a:avLst/>
-              </a:prstGeom>
-            </p:spPr>
-          </p:pic>
-          <p:sp>
-            <p:nvSpPr>
-              <p:cNvPr id="16" name="Oval 15">
-                <a:extLst>
-                  <a:ext uri="{FF2B5EF4-FFF2-40B4-BE49-F238E27FC236}">
-                    <a16:creationId xmlns:a16="http://schemas.microsoft.com/office/drawing/2014/main" id="{D1585B64-B92B-38B5-2E1F-984C1CBF7405}"/>
-                  </a:ext>
-                </a:extLst>
-              </p:cNvPr>
-              <p:cNvSpPr/>
-              <p:nvPr/>
-            </p:nvSpPr>
-            <p:spPr>
-              <a:xfrm>
-                <a:off x="496136" y="4092477"/>
-                <a:ext cx="1947263" cy="754984"/>
-              </a:xfrm>
-              <a:prstGeom prst="ellipse">
-                <a:avLst/>
-              </a:prstGeom>
-              <a:noFill/>
-              <a:ln w="38100">
-                <a:solidFill>
-                  <a:schemeClr val="tx2"/>
-                </a:solidFill>
-              </a:ln>
-            </p:spPr>
-            <p:style>
-              <a:lnRef idx="2">
-                <a:schemeClr val="accent1">
-                  <a:shade val="50000"/>
-                </a:schemeClr>
-              </a:lnRef>
-              <a:fillRef idx="1">
-                <a:schemeClr val="accent1"/>
-              </a:fillRef>
-              <a:effectRef idx="0">
-                <a:schemeClr val="accent1"/>
-              </a:effectRef>
-              <a:fontRef idx="minor">
-                <a:schemeClr val="lt1"/>
-              </a:fontRef>
-            </p:style>
-            <p:txBody>
-              <a:bodyPr rtlCol="0" anchor="ctr"/>
-              <a:lstStyle/>
-              <a:p>
-                <a:pPr algn="ctr"/>
-                <a:endParaRPr lang="en-US"/>
-              </a:p>
-            </p:txBody>
-          </p:sp>
-        </p:grpSp>
-        <p:cxnSp>
-          <p:nvCxnSpPr>
-            <p:cNvPr id="13" name="Elbow Connector 9">
-              <a:extLst>
-                <a:ext uri="{FF2B5EF4-FFF2-40B4-BE49-F238E27FC236}">
-                  <a16:creationId xmlns:a16="http://schemas.microsoft.com/office/drawing/2014/main" id="{22B2C05C-33CA-4A0B-A12E-0150FF500C37}"/>
-                </a:ext>
-              </a:extLst>
-            </p:cNvPr>
-            <p:cNvCxnSpPr/>
-            <p:nvPr/>
-          </p:nvCxnSpPr>
-          <p:spPr>
-            <a:xfrm flipV="1">
-              <a:off x="2331514" y="3591098"/>
-              <a:ext cx="3977343" cy="1080655"/>
-            </a:xfrm>
-            <a:prstGeom prst="bentConnector3">
-              <a:avLst>
-                <a:gd name="adj1" fmla="val 82604"/>
-              </a:avLst>
-            </a:prstGeom>
-            <a:ln w="38100">
-              <a:solidFill>
-                <a:schemeClr val="tx2"/>
-              </a:solidFill>
-              <a:tailEnd type="triangle"/>
-            </a:ln>
-          </p:spPr>
-          <p:style>
-            <a:lnRef idx="1">
-              <a:schemeClr val="accent1"/>
-            </a:lnRef>
-            <a:fillRef idx="0">
-              <a:schemeClr val="accent1"/>
-            </a:fillRef>
-            <a:effectRef idx="0">
-              <a:schemeClr val="accent1"/>
-            </a:effectRef>
-            <a:fontRef idx="minor">
-              <a:schemeClr val="tx1"/>
-            </a:fontRef>
-          </p:style>
-        </p:cxnSp>
-      </p:grpSp>
     </p:spTree>
   </p:cSld>
   <p:clrMapOvr>
@@ -7198,7 +6449,7 @@
 </file>
 
 <file path=ppt/slides/slide17.xml><?xml version="1.0" encoding="utf-8"?>
-<p:sld xmlns:a="http://schemas.openxmlformats.org/drawingml/2006/main" xmlns:r="http://schemas.openxmlformats.org/officeDocument/2006/relationships" xmlns:p="http://schemas.openxmlformats.org/presentationml/2006/main">
+<p:sld xmlns:a="http://schemas.openxmlformats.org/drawingml/2006/main" xmlns:p="http://schemas.openxmlformats.org/presentationml/2006/main" xmlns:r="http://schemas.openxmlformats.org/officeDocument/2006/relationships">
   <p:cSld>
     <p:bg>
       <p:bgPr>
@@ -7214,14 +6465,7 @@
         <p:cNvGrpSpPr/>
         <p:nvPr/>
       </p:nvGrpSpPr>
-      <p:grpSpPr>
-        <a:xfrm>
-          <a:off x="0" y="0"/>
-          <a:ext cx="0" cy="0"/>
-          <a:chOff x="0" y="0"/>
-          <a:chExt cx="0" cy="0"/>
-        </a:xfrm>
-      </p:grpSpPr>
+      <p:grpSpPr/>
       <p:sp>
         <p:nvSpPr>
           <p:cNvPr id="2" name="TextBox 1"/>
@@ -7239,7 +6483,7 @@
           <a:noFill/>
         </p:spPr>
         <p:txBody>
-          <a:bodyPr wrap="square" lIns="0" tIns="0" rIns="0" bIns="0" anchor="t">
+          <a:bodyPr wrap="square" anchor="t" lIns="0" rIns="0" tIns="0" bIns="0">
             <a:spAutoFit/>
           </a:bodyPr>
           <a:lstStyle/>
@@ -7261,7 +6505,7 @@
               </a:spcBef>
             </a:pPr>
             <a:r>
-              <a:rPr sz="1700" b="0" i="1">
+              <a:rPr sz="1800" b="0" i="1">
                 <a:solidFill>
                   <a:srgbClr val="D68E10"/>
                 </a:solidFill>
@@ -7313,7 +6557,6 @@
           <a:lstStyle/>
           <a:p>
             <a:pPr algn="ctr"/>
-            <a:endParaRPr/>
           </a:p>
         </p:txBody>
       </p:sp>
@@ -7334,7 +6577,7 @@
           <a:noFill/>
         </p:spPr>
         <p:txBody>
-          <a:bodyPr wrap="square" lIns="0" tIns="0" rIns="0" bIns="0" anchor="t">
+          <a:bodyPr wrap="square" anchor="t" lIns="0" rIns="0" tIns="0" bIns="0">
             <a:spAutoFit/>
           </a:bodyPr>
           <a:lstStyle/>
@@ -7450,7 +6693,16 @@
                 </a:solidFill>
                 <a:latin typeface="Roboto"/>
               </a:rPr>
-              <a:t>■  A CBA with no sensitivity check reads as overconfident.</a:t>
+              <a:t>■  </a:t>
+            </a:r>
+            <a:r>
+              <a:rPr sz="1800" b="1" i="0">
+                <a:solidFill>
+                  <a:srgbClr val="27B5CE"/>
+                </a:solidFill>
+                <a:latin typeface="Roboto"/>
+              </a:rPr>
+              <a:t>A CBA with no sensitivity check reads as overconfident.</a:t>
             </a:r>
           </a:p>
         </p:txBody>
@@ -7496,7 +6748,6 @@
           <a:lstStyle/>
           <a:p>
             <a:pPr algn="ctr"/>
-            <a:endParaRPr/>
           </a:p>
         </p:txBody>
       </p:sp>
@@ -7517,7 +6768,7 @@
           <a:noFill/>
         </p:spPr>
         <p:txBody>
-          <a:bodyPr wrap="square" lIns="0" tIns="0" rIns="0" bIns="0" anchor="t">
+          <a:bodyPr wrap="square" anchor="t" lIns="0" rIns="0" tIns="0" bIns="0">
             <a:spAutoFit/>
           </a:bodyPr>
           <a:lstStyle/>
@@ -7560,7 +6811,7 @@
           <a:noFill/>
         </p:spPr>
         <p:txBody>
-          <a:bodyPr wrap="square" lIns="0" tIns="0" rIns="0" bIns="0" anchor="t">
+          <a:bodyPr wrap="square" anchor="t" lIns="0" rIns="0" tIns="0" bIns="0">
             <a:spAutoFit/>
           </a:bodyPr>
           <a:lstStyle/>
@@ -7587,7 +6838,7 @@
 </file>
 
 <file path=ppt/slides/slide18.xml><?xml version="1.0" encoding="utf-8"?>
-<p:sld xmlns:a="http://schemas.openxmlformats.org/drawingml/2006/main" xmlns:r="http://schemas.openxmlformats.org/officeDocument/2006/relationships" xmlns:p="http://schemas.openxmlformats.org/presentationml/2006/main">
+<p:sld xmlns:a="http://schemas.openxmlformats.org/drawingml/2006/main" xmlns:p="http://schemas.openxmlformats.org/presentationml/2006/main" xmlns:r="http://schemas.openxmlformats.org/officeDocument/2006/relationships">
   <p:cSld>
     <p:bg>
       <p:bgPr>
@@ -7603,14 +6854,7 @@
         <p:cNvGrpSpPr/>
         <p:nvPr/>
       </p:nvGrpSpPr>
-      <p:grpSpPr>
-        <a:xfrm>
-          <a:off x="0" y="0"/>
-          <a:ext cx="0" cy="0"/>
-          <a:chOff x="0" y="0"/>
-          <a:chExt cx="0" cy="0"/>
-        </a:xfrm>
-      </p:grpSpPr>
+      <p:grpSpPr/>
       <p:sp>
         <p:nvSpPr>
           <p:cNvPr id="2" name="Rectangle 1"/>
@@ -7652,7 +6896,6 @@
           <a:lstStyle/>
           <a:p>
             <a:pPr algn="ctr"/>
-            <a:endParaRPr/>
           </a:p>
         </p:txBody>
       </p:sp>
@@ -7693,7 +6936,7 @@
           </a:fontRef>
         </p:style>
         <p:txBody>
-          <a:bodyPr wrap="none" rtlCol="0" anchor="ctr"/>
+          <a:bodyPr rtlCol="0" anchor="ctr"/>
           <a:lstStyle/>
           <a:p>
             <a:pPr algn="ctr"/>
@@ -7726,7 +6969,7 @@
           <a:noFill/>
         </p:spPr>
         <p:txBody>
-          <a:bodyPr wrap="square" lIns="0" tIns="0" rIns="0" bIns="0" anchor="ctr">
+          <a:bodyPr wrap="square" anchor="ctr" lIns="0" rIns="0" tIns="0" bIns="0">
             <a:spAutoFit/>
           </a:bodyPr>
           <a:lstStyle/>
@@ -7760,7 +7003,7 @@
           <a:noFill/>
         </p:spPr>
         <p:txBody>
-          <a:bodyPr wrap="square" lIns="0" tIns="0" rIns="0" bIns="0" anchor="t">
+          <a:bodyPr wrap="square" anchor="t" lIns="0" rIns="0" tIns="0" bIns="0">
             <a:spAutoFit/>
           </a:bodyPr>
           <a:lstStyle/>
@@ -8026,7 +7269,6 @@
           <a:lstStyle/>
           <a:p>
             <a:pPr algn="ctr"/>
-            <a:endParaRPr/>
           </a:p>
         </p:txBody>
       </p:sp>
@@ -8047,7 +7289,7 @@
           <a:noFill/>
         </p:spPr>
         <p:txBody>
-          <a:bodyPr wrap="square" lIns="0" tIns="0" rIns="0" bIns="0" anchor="ctr">
+          <a:bodyPr wrap="square" anchor="ctr" lIns="0" rIns="0" tIns="0" bIns="0">
             <a:spAutoFit/>
           </a:bodyPr>
           <a:lstStyle/>
@@ -8105,7 +7347,6 @@
           <a:lstStyle/>
           <a:p>
             <a:pPr algn="ctr"/>
-            <a:endParaRPr/>
           </a:p>
         </p:txBody>
       </p:sp>
@@ -8126,7 +7367,7 @@
           <a:noFill/>
         </p:spPr>
         <p:txBody>
-          <a:bodyPr wrap="square" lIns="0" tIns="0" rIns="0" bIns="0" anchor="t">
+          <a:bodyPr wrap="square" anchor="t" lIns="0" rIns="0" tIns="0" bIns="0">
             <a:spAutoFit/>
           </a:bodyPr>
           <a:lstStyle/>
@@ -8169,7 +7410,7 @@
           <a:noFill/>
         </p:spPr>
         <p:txBody>
-          <a:bodyPr wrap="square" lIns="0" tIns="0" rIns="0" bIns="0" anchor="t">
+          <a:bodyPr wrap="square" anchor="t" lIns="0" rIns="0" tIns="0" bIns="0">
             <a:spAutoFit/>
           </a:bodyPr>
           <a:lstStyle/>
@@ -8196,7 +7437,7 @@
 </file>
 
 <file path=ppt/slides/slide19.xml><?xml version="1.0" encoding="utf-8"?>
-<p:sld xmlns:a="http://schemas.openxmlformats.org/drawingml/2006/main" xmlns:r="http://schemas.openxmlformats.org/officeDocument/2006/relationships" xmlns:p="http://schemas.openxmlformats.org/presentationml/2006/main">
+<p:sld xmlns:a="http://schemas.openxmlformats.org/drawingml/2006/main" xmlns:p="http://schemas.openxmlformats.org/presentationml/2006/main" xmlns:r="http://schemas.openxmlformats.org/officeDocument/2006/relationships">
   <p:cSld>
     <p:bg>
       <p:bgPr>
@@ -8212,14 +7453,7 @@
         <p:cNvGrpSpPr/>
         <p:nvPr/>
       </p:nvGrpSpPr>
-      <p:grpSpPr>
-        <a:xfrm>
-          <a:off x="0" y="0"/>
-          <a:ext cx="0" cy="0"/>
-          <a:chOff x="0" y="0"/>
-          <a:chExt cx="0" cy="0"/>
-        </a:xfrm>
-      </p:grpSpPr>
+      <p:grpSpPr/>
       <p:sp>
         <p:nvSpPr>
           <p:cNvPr id="2" name="TextBox 1"/>
@@ -8237,7 +7471,7 @@
           <a:noFill/>
         </p:spPr>
         <p:txBody>
-          <a:bodyPr wrap="square" lIns="0" tIns="0" rIns="0" bIns="0" anchor="t">
+          <a:bodyPr wrap="square" anchor="t" lIns="0" rIns="0" tIns="0" bIns="0">
             <a:spAutoFit/>
           </a:bodyPr>
           <a:lstStyle/>
@@ -8311,7 +7545,6 @@
           <a:lstStyle/>
           <a:p>
             <a:pPr algn="ctr"/>
-            <a:endParaRPr/>
           </a:p>
         </p:txBody>
       </p:sp>
@@ -8358,7 +7591,6 @@
           <a:lstStyle/>
           <a:p>
             <a:pPr algn="ctr"/>
-            <a:endParaRPr/>
           </a:p>
         </p:txBody>
       </p:sp>
@@ -8403,7 +7635,6 @@
           <a:lstStyle/>
           <a:p>
             <a:pPr algn="ctr"/>
-            <a:endParaRPr/>
           </a:p>
         </p:txBody>
       </p:sp>
@@ -8424,7 +7655,7 @@
           <a:noFill/>
         </p:spPr>
         <p:txBody>
-          <a:bodyPr wrap="square" lIns="0" tIns="0" rIns="0" bIns="0" anchor="ctr">
+          <a:bodyPr wrap="square" anchor="ctr" lIns="0" rIns="0" tIns="0" bIns="0">
             <a:spAutoFit/>
           </a:bodyPr>
           <a:lstStyle/>
@@ -8489,7 +7720,6 @@
           <a:lstStyle/>
           <a:p>
             <a:pPr algn="ctr"/>
-            <a:endParaRPr/>
           </a:p>
         </p:txBody>
       </p:sp>
@@ -8534,7 +7764,6 @@
           <a:lstStyle/>
           <a:p>
             <a:pPr algn="ctr"/>
-            <a:endParaRPr/>
           </a:p>
         </p:txBody>
       </p:sp>
@@ -8555,7 +7784,7 @@
           <a:noFill/>
         </p:spPr>
         <p:txBody>
-          <a:bodyPr wrap="square" lIns="0" tIns="0" rIns="0" bIns="0" anchor="ctr">
+          <a:bodyPr wrap="square" anchor="ctr" lIns="0" rIns="0" tIns="0" bIns="0">
             <a:spAutoFit/>
           </a:bodyPr>
           <a:lstStyle/>
@@ -8620,7 +7849,6 @@
           <a:lstStyle/>
           <a:p>
             <a:pPr algn="ctr"/>
-            <a:endParaRPr/>
           </a:p>
         </p:txBody>
       </p:sp>
@@ -8665,7 +7893,6 @@
           <a:lstStyle/>
           <a:p>
             <a:pPr algn="ctr"/>
-            <a:endParaRPr/>
           </a:p>
         </p:txBody>
       </p:sp>
@@ -8686,7 +7913,7 @@
           <a:noFill/>
         </p:spPr>
         <p:txBody>
-          <a:bodyPr wrap="square" lIns="0" tIns="0" rIns="0" bIns="0" anchor="ctr">
+          <a:bodyPr wrap="square" anchor="ctr" lIns="0" rIns="0" tIns="0" bIns="0">
             <a:spAutoFit/>
           </a:bodyPr>
           <a:lstStyle/>
@@ -8751,7 +7978,6 @@
           <a:lstStyle/>
           <a:p>
             <a:pPr algn="ctr"/>
-            <a:endParaRPr/>
           </a:p>
         </p:txBody>
       </p:sp>
@@ -8796,7 +8022,6 @@
           <a:lstStyle/>
           <a:p>
             <a:pPr algn="ctr"/>
-            <a:endParaRPr/>
           </a:p>
         </p:txBody>
       </p:sp>
@@ -8817,7 +8042,7 @@
           <a:noFill/>
         </p:spPr>
         <p:txBody>
-          <a:bodyPr wrap="square" lIns="0" tIns="0" rIns="0" bIns="0" anchor="ctr">
+          <a:bodyPr wrap="square" anchor="ctr" lIns="0" rIns="0" tIns="0" bIns="0">
             <a:spAutoFit/>
           </a:bodyPr>
           <a:lstStyle/>
@@ -8880,7 +8105,6 @@
           <a:lstStyle/>
           <a:p>
             <a:pPr algn="ctr"/>
-            <a:endParaRPr/>
           </a:p>
         </p:txBody>
       </p:sp>
@@ -8901,7 +8125,7 @@
           <a:noFill/>
         </p:spPr>
         <p:txBody>
-          <a:bodyPr wrap="square" lIns="0" tIns="0" rIns="0" bIns="0" anchor="t">
+          <a:bodyPr wrap="square" anchor="t" lIns="0" rIns="0" tIns="0" bIns="0">
             <a:spAutoFit/>
           </a:bodyPr>
           <a:lstStyle/>
@@ -8944,7 +8168,7 @@
           <a:noFill/>
         </p:spPr>
         <p:txBody>
-          <a:bodyPr wrap="square" lIns="0" tIns="0" rIns="0" bIns="0" anchor="t">
+          <a:bodyPr wrap="square" anchor="t" lIns="0" rIns="0" tIns="0" bIns="0">
             <a:spAutoFit/>
           </a:bodyPr>
           <a:lstStyle/>
@@ -8971,7 +8195,7 @@
 </file>
 
 <file path=ppt/slides/slide2.xml><?xml version="1.0" encoding="utf-8"?>
-<p:sld xmlns:a="http://schemas.openxmlformats.org/drawingml/2006/main" xmlns:r="http://schemas.openxmlformats.org/officeDocument/2006/relationships" xmlns:p="http://schemas.openxmlformats.org/presentationml/2006/main">
+<p:sld xmlns:a="http://schemas.openxmlformats.org/drawingml/2006/main" xmlns:p="http://schemas.openxmlformats.org/presentationml/2006/main" xmlns:r="http://schemas.openxmlformats.org/officeDocument/2006/relationships">
   <p:cSld>
     <p:bg>
       <p:bgPr>
@@ -8987,14 +8211,7 @@
         <p:cNvGrpSpPr/>
         <p:nvPr/>
       </p:nvGrpSpPr>
-      <p:grpSpPr>
-        <a:xfrm>
-          <a:off x="0" y="0"/>
-          <a:ext cx="0" cy="0"/>
-          <a:chOff x="0" y="0"/>
-          <a:chExt cx="0" cy="0"/>
-        </a:xfrm>
-      </p:grpSpPr>
+      <p:grpSpPr/>
       <p:sp>
         <p:nvSpPr>
           <p:cNvPr id="2" name="TextBox 1"/>
@@ -9012,7 +8229,7 @@
           <a:noFill/>
         </p:spPr>
         <p:txBody>
-          <a:bodyPr wrap="square" lIns="0" tIns="0" rIns="0" bIns="0" anchor="t">
+          <a:bodyPr wrap="square" anchor="t" lIns="0" rIns="0" tIns="0" bIns="0">
             <a:spAutoFit/>
           </a:bodyPr>
           <a:lstStyle/>
@@ -9034,7 +8251,7 @@
               </a:spcBef>
             </a:pPr>
             <a:r>
-              <a:rPr sz="1700" b="0" i="1">
+              <a:rPr sz="1800" b="0" i="1">
                 <a:solidFill>
                   <a:srgbClr val="D68E10"/>
                 </a:solidFill>
@@ -9086,7 +8303,6 @@
           <a:lstStyle/>
           <a:p>
             <a:pPr algn="ctr"/>
-            <a:endParaRPr/>
           </a:p>
         </p:txBody>
       </p:sp>
@@ -9107,7 +8323,7 @@
           <a:noFill/>
         </p:spPr>
         <p:txBody>
-          <a:bodyPr wrap="square" lIns="0" tIns="0" rIns="0" bIns="0" anchor="t">
+          <a:bodyPr wrap="square" anchor="t" lIns="0" rIns="0" tIns="0" bIns="0">
             <a:spAutoFit/>
           </a:bodyPr>
           <a:lstStyle/>
@@ -9161,7 +8377,16 @@
                 </a:solidFill>
                 <a:latin typeface="Roboto"/>
               </a:rPr>
-              <a:t>■  Three moves: lay out the options → cost them over time → weigh the risks.</a:t>
+              <a:t>■  </a:t>
+            </a:r>
+            <a:r>
+              <a:rPr sz="1800" b="1" i="0">
+                <a:solidFill>
+                  <a:srgbClr val="92268F"/>
+                </a:solidFill>
+                <a:latin typeface="Roboto"/>
+              </a:rPr>
+              <a:t>Three moves: lay out the options → cost them over time → weigh the risks.</a:t>
             </a:r>
           </a:p>
           <a:p>
@@ -9269,7 +8494,6 @@
           <a:lstStyle/>
           <a:p>
             <a:pPr algn="ctr"/>
-            <a:endParaRPr/>
           </a:p>
         </p:txBody>
       </p:sp>
@@ -9290,7 +8514,7 @@
           <a:noFill/>
         </p:spPr>
         <p:txBody>
-          <a:bodyPr wrap="square" lIns="0" tIns="0" rIns="0" bIns="0" anchor="t">
+          <a:bodyPr wrap="square" anchor="t" lIns="0" rIns="0" tIns="0" bIns="0">
             <a:spAutoFit/>
           </a:bodyPr>
           <a:lstStyle/>
@@ -9333,7 +8557,7 @@
           <a:noFill/>
         </p:spPr>
         <p:txBody>
-          <a:bodyPr wrap="square" lIns="0" tIns="0" rIns="0" bIns="0" anchor="t">
+          <a:bodyPr wrap="square" anchor="t" lIns="0" rIns="0" tIns="0" bIns="0">
             <a:spAutoFit/>
           </a:bodyPr>
           <a:lstStyle/>
@@ -9360,7 +8584,7 @@
 </file>
 
 <file path=ppt/slides/slide20.xml><?xml version="1.0" encoding="utf-8"?>
-<p:sld xmlns:a="http://schemas.openxmlformats.org/drawingml/2006/main" xmlns:r="http://schemas.openxmlformats.org/officeDocument/2006/relationships" xmlns:p="http://schemas.openxmlformats.org/presentationml/2006/main">
+<p:sld xmlns:a="http://schemas.openxmlformats.org/drawingml/2006/main" xmlns:p="http://schemas.openxmlformats.org/presentationml/2006/main" xmlns:r="http://schemas.openxmlformats.org/officeDocument/2006/relationships">
   <p:cSld>
     <p:bg>
       <p:bgPr>
@@ -9376,14 +8600,7 @@
         <p:cNvGrpSpPr/>
         <p:nvPr/>
       </p:nvGrpSpPr>
-      <p:grpSpPr>
-        <a:xfrm>
-          <a:off x="0" y="0"/>
-          <a:ext cx="0" cy="0"/>
-          <a:chOff x="0" y="0"/>
-          <a:chExt cx="0" cy="0"/>
-        </a:xfrm>
-      </p:grpSpPr>
+      <p:grpSpPr/>
       <p:sp>
         <p:nvSpPr>
           <p:cNvPr id="2" name="Rectangle 1"/>
@@ -9425,7 +8642,6 @@
           <a:lstStyle/>
           <a:p>
             <a:pPr algn="ctr"/>
-            <a:endParaRPr/>
           </a:p>
         </p:txBody>
       </p:sp>
@@ -9446,7 +8662,7 @@
           <a:noFill/>
         </p:spPr>
         <p:txBody>
-          <a:bodyPr wrap="square" lIns="0" tIns="0" rIns="0" bIns="0" anchor="t">
+          <a:bodyPr wrap="square" anchor="t" lIns="0" rIns="0" tIns="0" bIns="0">
             <a:spAutoFit/>
           </a:bodyPr>
           <a:lstStyle/>
@@ -9480,7 +8696,7 @@
           <a:noFill/>
         </p:spPr>
         <p:txBody>
-          <a:bodyPr wrap="square" lIns="0" tIns="0" rIns="0" bIns="0" anchor="t">
+          <a:bodyPr wrap="square" anchor="t" lIns="0" rIns="0" tIns="0" bIns="0">
             <a:spAutoFit/>
           </a:bodyPr>
           <a:lstStyle/>
@@ -9570,7 +8786,6 @@
           <a:lstStyle/>
           <a:p>
             <a:pPr algn="ctr"/>
-            <a:endParaRPr/>
           </a:p>
         </p:txBody>
       </p:sp>
@@ -9591,7 +8806,7 @@
           <a:noFill/>
         </p:spPr>
         <p:txBody>
-          <a:bodyPr wrap="square" lIns="0" tIns="0" rIns="0" bIns="0" anchor="t">
+          <a:bodyPr wrap="square" anchor="t" lIns="0" rIns="0" tIns="0" bIns="0">
             <a:spAutoFit/>
           </a:bodyPr>
           <a:lstStyle/>
@@ -9634,13 +8849,21 @@
           <a:noFill/>
         </p:spPr>
         <p:txBody>
-          <a:bodyPr wrap="square" lIns="0" tIns="0" rIns="0" bIns="0" anchor="t">
+          <a:bodyPr wrap="square" anchor="t" lIns="0" rIns="0" tIns="0" bIns="0">
             <a:spAutoFit/>
           </a:bodyPr>
           <a:lstStyle/>
           <a:p>
             <a:pPr algn="r"/>
-            <a:endParaRPr/>
+            <a:r>
+              <a:rPr sz="1100" b="0" i="0">
+                <a:solidFill>
+                  <a:srgbClr val="7A7A7A"/>
+                </a:solidFill>
+                <a:latin typeface="Roboto"/>
+              </a:rPr>
+              <a:t/>
+            </a:r>
           </a:p>
         </p:txBody>
       </p:sp>
@@ -9653,7 +8876,7 @@
 </file>
 
 <file path=ppt/slides/slide21.xml><?xml version="1.0" encoding="utf-8"?>
-<p:sld xmlns:a="http://schemas.openxmlformats.org/drawingml/2006/main" xmlns:r="http://schemas.openxmlformats.org/officeDocument/2006/relationships" xmlns:p="http://schemas.openxmlformats.org/presentationml/2006/main">
+<p:sld xmlns:a="http://schemas.openxmlformats.org/drawingml/2006/main" xmlns:p="http://schemas.openxmlformats.org/presentationml/2006/main" xmlns:r="http://schemas.openxmlformats.org/officeDocument/2006/relationships">
   <p:cSld>
     <p:bg>
       <p:bgPr>
@@ -9669,14 +8892,7 @@
         <p:cNvGrpSpPr/>
         <p:nvPr/>
       </p:nvGrpSpPr>
-      <p:grpSpPr>
-        <a:xfrm>
-          <a:off x="0" y="0"/>
-          <a:ext cx="0" cy="0"/>
-          <a:chOff x="0" y="0"/>
-          <a:chExt cx="0" cy="0"/>
-        </a:xfrm>
-      </p:grpSpPr>
+      <p:grpSpPr/>
       <p:sp>
         <p:nvSpPr>
           <p:cNvPr id="2" name="TextBox 1"/>
@@ -9694,7 +8910,7 @@
           <a:noFill/>
         </p:spPr>
         <p:txBody>
-          <a:bodyPr wrap="square" lIns="0" tIns="0" rIns="0" bIns="0" anchor="t">
+          <a:bodyPr wrap="square" anchor="t" lIns="0" rIns="0" tIns="0" bIns="0">
             <a:spAutoFit/>
           </a:bodyPr>
           <a:lstStyle/>
@@ -9752,7 +8968,6 @@
           <a:lstStyle/>
           <a:p>
             <a:pPr algn="ctr"/>
-            <a:endParaRPr/>
           </a:p>
         </p:txBody>
       </p:sp>
@@ -9773,7 +8988,7 @@
           <a:noFill/>
         </p:spPr>
         <p:txBody>
-          <a:bodyPr wrap="square" lIns="0" tIns="0" rIns="0" bIns="0" anchor="t">
+          <a:bodyPr wrap="square" anchor="t" lIns="0" rIns="0" tIns="0" bIns="0">
             <a:spAutoFit/>
           </a:bodyPr>
           <a:lstStyle/>
@@ -9913,7 +9128,6 @@
           <a:lstStyle/>
           <a:p>
             <a:pPr algn="ctr"/>
-            <a:endParaRPr/>
           </a:p>
         </p:txBody>
       </p:sp>
@@ -9934,7 +9148,7 @@
           <a:noFill/>
         </p:spPr>
         <p:txBody>
-          <a:bodyPr wrap="square" lIns="0" tIns="0" rIns="0" bIns="0" anchor="t">
+          <a:bodyPr wrap="square" anchor="t" lIns="0" rIns="0" tIns="0" bIns="0">
             <a:spAutoFit/>
           </a:bodyPr>
           <a:lstStyle/>
@@ -9977,7 +9191,7 @@
           <a:noFill/>
         </p:spPr>
         <p:txBody>
-          <a:bodyPr wrap="square" lIns="0" tIns="0" rIns="0" bIns="0" anchor="t">
+          <a:bodyPr wrap="square" anchor="t" lIns="0" rIns="0" tIns="0" bIns="0">
             <a:spAutoFit/>
           </a:bodyPr>
           <a:lstStyle/>
@@ -10004,7 +9218,7 @@
 </file>
 
 <file path=ppt/slides/slide22.xml><?xml version="1.0" encoding="utf-8"?>
-<p:sld xmlns:a="http://schemas.openxmlformats.org/drawingml/2006/main" xmlns:r="http://schemas.openxmlformats.org/officeDocument/2006/relationships" xmlns:p="http://schemas.openxmlformats.org/presentationml/2006/main">
+<p:sld xmlns:a="http://schemas.openxmlformats.org/drawingml/2006/main" xmlns:p="http://schemas.openxmlformats.org/presentationml/2006/main" xmlns:r="http://schemas.openxmlformats.org/officeDocument/2006/relationships">
   <p:cSld>
     <p:bg>
       <p:bgPr>
@@ -10020,14 +9234,7 @@
         <p:cNvGrpSpPr/>
         <p:nvPr/>
       </p:nvGrpSpPr>
-      <p:grpSpPr>
-        <a:xfrm>
-          <a:off x="0" y="0"/>
-          <a:ext cx="0" cy="0"/>
-          <a:chOff x="0" y="0"/>
-          <a:chExt cx="0" cy="0"/>
-        </a:xfrm>
-      </p:grpSpPr>
+      <p:grpSpPr/>
       <p:sp>
         <p:nvSpPr>
           <p:cNvPr id="2" name="TextBox 1"/>
@@ -10045,7 +9252,7 @@
           <a:noFill/>
         </p:spPr>
         <p:txBody>
-          <a:bodyPr wrap="square" lIns="0" tIns="0" rIns="0" bIns="0" anchor="t">
+          <a:bodyPr wrap="square" anchor="t" lIns="0" rIns="0" tIns="0" bIns="0">
             <a:spAutoFit/>
           </a:bodyPr>
           <a:lstStyle/>
@@ -10067,7 +9274,7 @@
               </a:spcBef>
             </a:pPr>
             <a:r>
-              <a:rPr sz="1700" b="0" i="1">
+              <a:rPr sz="1800" b="0" i="1">
                 <a:solidFill>
                   <a:srgbClr val="D68E10"/>
                 </a:solidFill>
@@ -10119,7 +9326,6 @@
           <a:lstStyle/>
           <a:p>
             <a:pPr algn="ctr"/>
-            <a:endParaRPr/>
           </a:p>
         </p:txBody>
       </p:sp>
@@ -10140,7 +9346,7 @@
           <a:noFill/>
         </p:spPr>
         <p:txBody>
-          <a:bodyPr wrap="square" lIns="0" tIns="0" rIns="0" bIns="0" anchor="t">
+          <a:bodyPr wrap="square" anchor="t" lIns="0" rIns="0" tIns="0" bIns="0">
             <a:spAutoFit/>
           </a:bodyPr>
           <a:lstStyle/>
@@ -10256,7 +9462,16 @@
                 </a:solidFill>
                 <a:latin typeface="Roboto"/>
               </a:rPr>
-              <a:t>■  The cheaper option may carry the bigger intangible cost.</a:t>
+              <a:t>■  </a:t>
+            </a:r>
+            <a:r>
+              <a:rPr sz="1800" b="1" i="0">
+                <a:solidFill>
+                  <a:srgbClr val="205F61"/>
+                </a:solidFill>
+                <a:latin typeface="Roboto"/>
+              </a:rPr>
+              <a:t>The cheaper option may carry the bigger intangible cost.</a:t>
             </a:r>
           </a:p>
         </p:txBody>
@@ -10302,7 +9517,6 @@
           <a:lstStyle/>
           <a:p>
             <a:pPr algn="ctr"/>
-            <a:endParaRPr/>
           </a:p>
         </p:txBody>
       </p:sp>
@@ -10323,7 +9537,7 @@
           <a:noFill/>
         </p:spPr>
         <p:txBody>
-          <a:bodyPr wrap="square" lIns="0" tIns="0" rIns="0" bIns="0" anchor="t">
+          <a:bodyPr wrap="square" anchor="t" lIns="0" rIns="0" tIns="0" bIns="0">
             <a:spAutoFit/>
           </a:bodyPr>
           <a:lstStyle/>
@@ -10366,7 +9580,7 @@
           <a:noFill/>
         </p:spPr>
         <p:txBody>
-          <a:bodyPr wrap="square" lIns="0" tIns="0" rIns="0" bIns="0" anchor="t">
+          <a:bodyPr wrap="square" anchor="t" lIns="0" rIns="0" tIns="0" bIns="0">
             <a:spAutoFit/>
           </a:bodyPr>
           <a:lstStyle/>
@@ -10393,7 +9607,7 @@
 </file>
 
 <file path=ppt/slides/slide23.xml><?xml version="1.0" encoding="utf-8"?>
-<p:sld xmlns:a="http://schemas.openxmlformats.org/drawingml/2006/main" xmlns:r="http://schemas.openxmlformats.org/officeDocument/2006/relationships" xmlns:p="http://schemas.openxmlformats.org/presentationml/2006/main">
+<p:sld xmlns:a="http://schemas.openxmlformats.org/drawingml/2006/main" xmlns:p="http://schemas.openxmlformats.org/presentationml/2006/main" xmlns:r="http://schemas.openxmlformats.org/officeDocument/2006/relationships">
   <p:cSld>
     <p:bg>
       <p:bgPr>
@@ -10409,14 +9623,7 @@
         <p:cNvGrpSpPr/>
         <p:nvPr/>
       </p:nvGrpSpPr>
-      <p:grpSpPr>
-        <a:xfrm>
-          <a:off x="0" y="0"/>
-          <a:ext cx="0" cy="0"/>
-          <a:chOff x="0" y="0"/>
-          <a:chExt cx="0" cy="0"/>
-        </a:xfrm>
-      </p:grpSpPr>
+      <p:grpSpPr/>
       <p:sp>
         <p:nvSpPr>
           <p:cNvPr id="2" name="TextBox 1"/>
@@ -10434,7 +9641,7 @@
           <a:noFill/>
         </p:spPr>
         <p:txBody>
-          <a:bodyPr wrap="square" lIns="0" tIns="0" rIns="0" bIns="0" anchor="t">
+          <a:bodyPr wrap="square" anchor="t" lIns="0" rIns="0" tIns="0" bIns="0">
             <a:spAutoFit/>
           </a:bodyPr>
           <a:lstStyle/>
@@ -10492,7 +9699,6 @@
           <a:lstStyle/>
           <a:p>
             <a:pPr algn="ctr"/>
-            <a:endParaRPr/>
           </a:p>
         </p:txBody>
       </p:sp>
@@ -10513,7 +9719,7 @@
           <a:noFill/>
         </p:spPr>
         <p:txBody>
-          <a:bodyPr wrap="square" lIns="0" tIns="0" rIns="0" bIns="0" anchor="t">
+          <a:bodyPr wrap="square" anchor="t" lIns="0" rIns="0" tIns="0" bIns="0">
             <a:spAutoFit/>
           </a:bodyPr>
           <a:lstStyle/>
@@ -10629,7 +9835,16 @@
                 </a:solidFill>
                 <a:latin typeface="Roboto"/>
               </a:rPr>
-              <a:t>■  A risk with no mitigation is just a worry; a mitigation makes it manageable.</a:t>
+              <a:t>■  </a:t>
+            </a:r>
+            <a:r>
+              <a:rPr sz="1800" b="1" i="0">
+                <a:solidFill>
+                  <a:srgbClr val="205F61"/>
+                </a:solidFill>
+                <a:latin typeface="Roboto"/>
+              </a:rPr>
+              <a:t>A risk with no mitigation is just a worry; a mitigation makes it manageable.</a:t>
             </a:r>
           </a:p>
         </p:txBody>
@@ -10675,7 +9890,6 @@
           <a:lstStyle/>
           <a:p>
             <a:pPr algn="ctr"/>
-            <a:endParaRPr/>
           </a:p>
         </p:txBody>
       </p:sp>
@@ -10696,7 +9910,7 @@
           <a:noFill/>
         </p:spPr>
         <p:txBody>
-          <a:bodyPr wrap="square" lIns="0" tIns="0" rIns="0" bIns="0" anchor="t">
+          <a:bodyPr wrap="square" anchor="t" lIns="0" rIns="0" tIns="0" bIns="0">
             <a:spAutoFit/>
           </a:bodyPr>
           <a:lstStyle/>
@@ -10739,7 +9953,7 @@
           <a:noFill/>
         </p:spPr>
         <p:txBody>
-          <a:bodyPr wrap="square" lIns="0" tIns="0" rIns="0" bIns="0" anchor="t">
+          <a:bodyPr wrap="square" anchor="t" lIns="0" rIns="0" tIns="0" bIns="0">
             <a:spAutoFit/>
           </a:bodyPr>
           <a:lstStyle/>
@@ -10766,7 +9980,7 @@
 </file>
 
 <file path=ppt/slides/slide24.xml><?xml version="1.0" encoding="utf-8"?>
-<p:sld xmlns:a="http://schemas.openxmlformats.org/drawingml/2006/main" xmlns:r="http://schemas.openxmlformats.org/officeDocument/2006/relationships" xmlns:p="http://schemas.openxmlformats.org/presentationml/2006/main">
+<p:sld xmlns:a="http://schemas.openxmlformats.org/drawingml/2006/main" xmlns:p="http://schemas.openxmlformats.org/presentationml/2006/main" xmlns:r="http://schemas.openxmlformats.org/officeDocument/2006/relationships">
   <p:cSld>
     <p:bg>
       <p:bgPr>
@@ -10782,14 +9996,7 @@
         <p:cNvGrpSpPr/>
         <p:nvPr/>
       </p:nvGrpSpPr>
-      <p:grpSpPr>
-        <a:xfrm>
-          <a:off x="0" y="0"/>
-          <a:ext cx="0" cy="0"/>
-          <a:chOff x="0" y="0"/>
-          <a:chExt cx="0" cy="0"/>
-        </a:xfrm>
-      </p:grpSpPr>
+      <p:grpSpPr/>
       <p:sp>
         <p:nvSpPr>
           <p:cNvPr id="2" name="Rectangle 1"/>
@@ -10831,7 +10038,6 @@
           <a:lstStyle/>
           <a:p>
             <a:pPr algn="ctr"/>
-            <a:endParaRPr/>
           </a:p>
         </p:txBody>
       </p:sp>
@@ -10872,7 +10078,7 @@
           </a:fontRef>
         </p:style>
         <p:txBody>
-          <a:bodyPr wrap="none" rtlCol="0" anchor="ctr"/>
+          <a:bodyPr rtlCol="0" anchor="ctr"/>
           <a:lstStyle/>
           <a:p>
             <a:pPr algn="ctr"/>
@@ -10905,7 +10111,7 @@
           <a:noFill/>
         </p:spPr>
         <p:txBody>
-          <a:bodyPr wrap="square" lIns="0" tIns="0" rIns="0" bIns="0" anchor="ctr">
+          <a:bodyPr wrap="square" anchor="ctr" lIns="0" rIns="0" tIns="0" bIns="0">
             <a:spAutoFit/>
           </a:bodyPr>
           <a:lstStyle/>
@@ -10939,7 +10145,7 @@
           <a:noFill/>
         </p:spPr>
         <p:txBody>
-          <a:bodyPr wrap="square" lIns="0" tIns="0" rIns="0" bIns="0" anchor="t">
+          <a:bodyPr wrap="square" anchor="t" lIns="0" rIns="0" tIns="0" bIns="0">
             <a:spAutoFit/>
           </a:bodyPr>
           <a:lstStyle/>
@@ -11174,7 +10380,6 @@
           <a:lstStyle/>
           <a:p>
             <a:pPr algn="ctr"/>
-            <a:endParaRPr/>
           </a:p>
         </p:txBody>
       </p:sp>
@@ -11195,7 +10400,7 @@
           <a:noFill/>
         </p:spPr>
         <p:txBody>
-          <a:bodyPr wrap="square" lIns="0" tIns="0" rIns="0" bIns="0" anchor="ctr">
+          <a:bodyPr wrap="square" anchor="ctr" lIns="0" rIns="0" tIns="0" bIns="0">
             <a:spAutoFit/>
           </a:bodyPr>
           <a:lstStyle/>
@@ -11253,7 +10458,6 @@
           <a:lstStyle/>
           <a:p>
             <a:pPr algn="ctr"/>
-            <a:endParaRPr/>
           </a:p>
         </p:txBody>
       </p:sp>
@@ -11274,7 +10478,7 @@
           <a:noFill/>
         </p:spPr>
         <p:txBody>
-          <a:bodyPr wrap="square" lIns="0" tIns="0" rIns="0" bIns="0" anchor="t">
+          <a:bodyPr wrap="square" anchor="t" lIns="0" rIns="0" tIns="0" bIns="0">
             <a:spAutoFit/>
           </a:bodyPr>
           <a:lstStyle/>
@@ -11317,7 +10521,7 @@
           <a:noFill/>
         </p:spPr>
         <p:txBody>
-          <a:bodyPr wrap="square" lIns="0" tIns="0" rIns="0" bIns="0" anchor="t">
+          <a:bodyPr wrap="square" anchor="t" lIns="0" rIns="0" tIns="0" bIns="0">
             <a:spAutoFit/>
           </a:bodyPr>
           <a:lstStyle/>
@@ -11344,7 +10548,7 @@
 </file>
 
 <file path=ppt/slides/slide25.xml><?xml version="1.0" encoding="utf-8"?>
-<p:sld xmlns:a="http://schemas.openxmlformats.org/drawingml/2006/main" xmlns:r="http://schemas.openxmlformats.org/officeDocument/2006/relationships" xmlns:p="http://schemas.openxmlformats.org/presentationml/2006/main">
+<p:sld xmlns:a="http://schemas.openxmlformats.org/drawingml/2006/main" xmlns:p="http://schemas.openxmlformats.org/presentationml/2006/main" xmlns:r="http://schemas.openxmlformats.org/officeDocument/2006/relationships">
   <p:cSld>
     <p:bg>
       <p:bgPr>
@@ -11360,14 +10564,7 @@
         <p:cNvGrpSpPr/>
         <p:nvPr/>
       </p:nvGrpSpPr>
-      <p:grpSpPr>
-        <a:xfrm>
-          <a:off x="0" y="0"/>
-          <a:ext cx="0" cy="0"/>
-          <a:chOff x="0" y="0"/>
-          <a:chExt cx="0" cy="0"/>
-        </a:xfrm>
-      </p:grpSpPr>
+      <p:grpSpPr/>
       <p:sp>
         <p:nvSpPr>
           <p:cNvPr id="2" name="TextBox 1"/>
@@ -11385,7 +10582,7 @@
           <a:noFill/>
         </p:spPr>
         <p:txBody>
-          <a:bodyPr wrap="square" lIns="0" tIns="0" rIns="0" bIns="0" anchor="t">
+          <a:bodyPr wrap="square" anchor="t" lIns="0" rIns="0" tIns="0" bIns="0">
             <a:spAutoFit/>
           </a:bodyPr>
           <a:lstStyle/>
@@ -11459,7 +10656,6 @@
           <a:lstStyle/>
           <a:p>
             <a:pPr algn="ctr"/>
-            <a:endParaRPr/>
           </a:p>
         </p:txBody>
       </p:sp>
@@ -11506,7 +10702,6 @@
           <a:lstStyle/>
           <a:p>
             <a:pPr algn="ctr"/>
-            <a:endParaRPr/>
           </a:p>
         </p:txBody>
       </p:sp>
@@ -11551,7 +10746,6 @@
           <a:lstStyle/>
           <a:p>
             <a:pPr algn="ctr"/>
-            <a:endParaRPr/>
           </a:p>
         </p:txBody>
       </p:sp>
@@ -11572,7 +10766,7 @@
           <a:noFill/>
         </p:spPr>
         <p:txBody>
-          <a:bodyPr wrap="square" lIns="0" tIns="0" rIns="0" bIns="0" anchor="ctr">
+          <a:bodyPr wrap="square" anchor="ctr" lIns="0" rIns="0" tIns="0" bIns="0">
             <a:spAutoFit/>
           </a:bodyPr>
           <a:lstStyle/>
@@ -11637,7 +10831,6 @@
           <a:lstStyle/>
           <a:p>
             <a:pPr algn="ctr"/>
-            <a:endParaRPr/>
           </a:p>
         </p:txBody>
       </p:sp>
@@ -11682,7 +10875,6 @@
           <a:lstStyle/>
           <a:p>
             <a:pPr algn="ctr"/>
-            <a:endParaRPr/>
           </a:p>
         </p:txBody>
       </p:sp>
@@ -11703,7 +10895,7 @@
           <a:noFill/>
         </p:spPr>
         <p:txBody>
-          <a:bodyPr wrap="square" lIns="0" tIns="0" rIns="0" bIns="0" anchor="ctr">
+          <a:bodyPr wrap="square" anchor="ctr" lIns="0" rIns="0" tIns="0" bIns="0">
             <a:spAutoFit/>
           </a:bodyPr>
           <a:lstStyle/>
@@ -11768,7 +10960,6 @@
           <a:lstStyle/>
           <a:p>
             <a:pPr algn="ctr"/>
-            <a:endParaRPr/>
           </a:p>
         </p:txBody>
       </p:sp>
@@ -11813,7 +11004,6 @@
           <a:lstStyle/>
           <a:p>
             <a:pPr algn="ctr"/>
-            <a:endParaRPr/>
           </a:p>
         </p:txBody>
       </p:sp>
@@ -11834,7 +11024,7 @@
           <a:noFill/>
         </p:spPr>
         <p:txBody>
-          <a:bodyPr wrap="square" lIns="0" tIns="0" rIns="0" bIns="0" anchor="ctr">
+          <a:bodyPr wrap="square" anchor="ctr" lIns="0" rIns="0" tIns="0" bIns="0">
             <a:spAutoFit/>
           </a:bodyPr>
           <a:lstStyle/>
@@ -11897,7 +11087,6 @@
           <a:lstStyle/>
           <a:p>
             <a:pPr algn="ctr"/>
-            <a:endParaRPr/>
           </a:p>
         </p:txBody>
       </p:sp>
@@ -11918,7 +11107,7 @@
           <a:noFill/>
         </p:spPr>
         <p:txBody>
-          <a:bodyPr wrap="square" lIns="0" tIns="0" rIns="0" bIns="0" anchor="t">
+          <a:bodyPr wrap="square" anchor="t" lIns="0" rIns="0" tIns="0" bIns="0">
             <a:spAutoFit/>
           </a:bodyPr>
           <a:lstStyle/>
@@ -11961,7 +11150,7 @@
           <a:noFill/>
         </p:spPr>
         <p:txBody>
-          <a:bodyPr wrap="square" lIns="0" tIns="0" rIns="0" bIns="0" anchor="t">
+          <a:bodyPr wrap="square" anchor="t" lIns="0" rIns="0" tIns="0" bIns="0">
             <a:spAutoFit/>
           </a:bodyPr>
           <a:lstStyle/>
@@ -11988,7 +11177,7 @@
 </file>
 
 <file path=ppt/slides/slide26.xml><?xml version="1.0" encoding="utf-8"?>
-<p:sld xmlns:a="http://schemas.openxmlformats.org/drawingml/2006/main" xmlns:r="http://schemas.openxmlformats.org/officeDocument/2006/relationships" xmlns:p="http://schemas.openxmlformats.org/presentationml/2006/main">
+<p:sld xmlns:a="http://schemas.openxmlformats.org/drawingml/2006/main" xmlns:p="http://schemas.openxmlformats.org/presentationml/2006/main" xmlns:r="http://schemas.openxmlformats.org/officeDocument/2006/relationships">
   <p:cSld>
     <p:bg>
       <p:bgPr>
@@ -12004,14 +11193,7 @@
         <p:cNvGrpSpPr/>
         <p:nvPr/>
       </p:nvGrpSpPr>
-      <p:grpSpPr>
-        <a:xfrm>
-          <a:off x="0" y="0"/>
-          <a:ext cx="0" cy="0"/>
-          <a:chOff x="0" y="0"/>
-          <a:chExt cx="0" cy="0"/>
-        </a:xfrm>
-      </p:grpSpPr>
+      <p:grpSpPr/>
       <p:sp>
         <p:nvSpPr>
           <p:cNvPr id="2" name="Rectangle 1"/>
@@ -12053,7 +11235,6 @@
           <a:lstStyle/>
           <a:p>
             <a:pPr algn="ctr"/>
-            <a:endParaRPr/>
           </a:p>
         </p:txBody>
       </p:sp>
@@ -12074,7 +11255,7 @@
           <a:noFill/>
         </p:spPr>
         <p:txBody>
-          <a:bodyPr wrap="square" lIns="0" tIns="0" rIns="0" bIns="0" anchor="t">
+          <a:bodyPr wrap="square" anchor="t" lIns="0" rIns="0" tIns="0" bIns="0">
             <a:spAutoFit/>
           </a:bodyPr>
           <a:lstStyle/>
@@ -12176,7 +11357,7 @@
 </file>
 
 <file path=ppt/slides/slide3.xml><?xml version="1.0" encoding="utf-8"?>
-<p:sld xmlns:a="http://schemas.openxmlformats.org/drawingml/2006/main" xmlns:r="http://schemas.openxmlformats.org/officeDocument/2006/relationships" xmlns:p="http://schemas.openxmlformats.org/presentationml/2006/main">
+<p:sld xmlns:a="http://schemas.openxmlformats.org/drawingml/2006/main" xmlns:p="http://schemas.openxmlformats.org/presentationml/2006/main" xmlns:r="http://schemas.openxmlformats.org/officeDocument/2006/relationships">
   <p:cSld>
     <p:bg>
       <p:bgPr>
@@ -12192,14 +11373,7 @@
         <p:cNvGrpSpPr/>
         <p:nvPr/>
       </p:nvGrpSpPr>
-      <p:grpSpPr>
-        <a:xfrm>
-          <a:off x="0" y="0"/>
-          <a:ext cx="0" cy="0"/>
-          <a:chOff x="0" y="0"/>
-          <a:chExt cx="0" cy="0"/>
-        </a:xfrm>
-      </p:grpSpPr>
+      <p:grpSpPr/>
       <p:sp>
         <p:nvSpPr>
           <p:cNvPr id="2" name="Rectangle 1"/>
@@ -12241,7 +11415,6 @@
           <a:lstStyle/>
           <a:p>
             <a:pPr algn="ctr"/>
-            <a:endParaRPr/>
           </a:p>
         </p:txBody>
       </p:sp>
@@ -12262,7 +11435,7 @@
           <a:noFill/>
         </p:spPr>
         <p:txBody>
-          <a:bodyPr wrap="square" lIns="0" tIns="0" rIns="0" bIns="0" anchor="t">
+          <a:bodyPr wrap="square" anchor="t" lIns="0" rIns="0" tIns="0" bIns="0">
             <a:spAutoFit/>
           </a:bodyPr>
           <a:lstStyle/>
@@ -12296,7 +11469,7 @@
           <a:noFill/>
         </p:spPr>
         <p:txBody>
-          <a:bodyPr wrap="square" lIns="0" tIns="0" rIns="0" bIns="0" anchor="t">
+          <a:bodyPr wrap="square" anchor="t" lIns="0" rIns="0" tIns="0" bIns="0">
             <a:spAutoFit/>
           </a:bodyPr>
           <a:lstStyle/>
@@ -12386,7 +11559,6 @@
           <a:lstStyle/>
           <a:p>
             <a:pPr algn="ctr"/>
-            <a:endParaRPr/>
           </a:p>
         </p:txBody>
       </p:sp>
@@ -12407,7 +11579,7 @@
           <a:noFill/>
         </p:spPr>
         <p:txBody>
-          <a:bodyPr wrap="square" lIns="0" tIns="0" rIns="0" bIns="0" anchor="t">
+          <a:bodyPr wrap="square" anchor="t" lIns="0" rIns="0" tIns="0" bIns="0">
             <a:spAutoFit/>
           </a:bodyPr>
           <a:lstStyle/>
@@ -12450,13 +11622,21 @@
           <a:noFill/>
         </p:spPr>
         <p:txBody>
-          <a:bodyPr wrap="square" lIns="0" tIns="0" rIns="0" bIns="0" anchor="t">
+          <a:bodyPr wrap="square" anchor="t" lIns="0" rIns="0" tIns="0" bIns="0">
             <a:spAutoFit/>
           </a:bodyPr>
           <a:lstStyle/>
           <a:p>
             <a:pPr algn="r"/>
-            <a:endParaRPr/>
+            <a:r>
+              <a:rPr sz="1100" b="0" i="0">
+                <a:solidFill>
+                  <a:srgbClr val="7A7A7A"/>
+                </a:solidFill>
+                <a:latin typeface="Roboto"/>
+              </a:rPr>
+              <a:t/>
+            </a:r>
           </a:p>
         </p:txBody>
       </p:sp>
@@ -12469,7 +11649,7 @@
 </file>
 
 <file path=ppt/slides/slide4.xml><?xml version="1.0" encoding="utf-8"?>
-<p:sld xmlns:a="http://schemas.openxmlformats.org/drawingml/2006/main" xmlns:r="http://schemas.openxmlformats.org/officeDocument/2006/relationships" xmlns:p="http://schemas.openxmlformats.org/presentationml/2006/main">
+<p:sld xmlns:a="http://schemas.openxmlformats.org/drawingml/2006/main" xmlns:p="http://schemas.openxmlformats.org/presentationml/2006/main" xmlns:r="http://schemas.openxmlformats.org/officeDocument/2006/relationships">
   <p:cSld>
     <p:bg>
       <p:bgPr>
@@ -12485,14 +11665,7 @@
         <p:cNvGrpSpPr/>
         <p:nvPr/>
       </p:nvGrpSpPr>
-      <p:grpSpPr>
-        <a:xfrm>
-          <a:off x="0" y="0"/>
-          <a:ext cx="0" cy="0"/>
-          <a:chOff x="0" y="0"/>
-          <a:chExt cx="0" cy="0"/>
-        </a:xfrm>
-      </p:grpSpPr>
+      <p:grpSpPr/>
       <p:sp>
         <p:nvSpPr>
           <p:cNvPr id="2" name="TextBox 1"/>
@@ -12510,7 +11683,7 @@
           <a:noFill/>
         </p:spPr>
         <p:txBody>
-          <a:bodyPr wrap="square" lIns="0" tIns="0" rIns="0" bIns="0" anchor="t">
+          <a:bodyPr wrap="square" anchor="t" lIns="0" rIns="0" tIns="0" bIns="0">
             <a:spAutoFit/>
           </a:bodyPr>
           <a:lstStyle/>
@@ -12568,7 +11741,6 @@
           <a:lstStyle/>
           <a:p>
             <a:pPr algn="ctr"/>
-            <a:endParaRPr/>
           </a:p>
         </p:txBody>
       </p:sp>
@@ -12589,7 +11761,7 @@
           <a:noFill/>
         </p:spPr>
         <p:txBody>
-          <a:bodyPr wrap="square" lIns="0" tIns="0" rIns="0" bIns="0" anchor="t">
+          <a:bodyPr wrap="square" anchor="t" lIns="0" rIns="0" tIns="0" bIns="0">
             <a:spAutoFit/>
           </a:bodyPr>
           <a:lstStyle/>
@@ -12674,7 +11846,16 @@
                 </a:solidFill>
                 <a:latin typeface="Roboto"/>
               </a:rPr>
-              <a:t>■  Your job here: lay the options out and evaluate them — not pick one.</a:t>
+              <a:t>■  </a:t>
+            </a:r>
+            <a:r>
+              <a:rPr sz="1800" b="1" i="0">
+                <a:solidFill>
+                  <a:srgbClr val="92268F"/>
+                </a:solidFill>
+                <a:latin typeface="Roboto"/>
+              </a:rPr>
+              <a:t>Your job here: lay the options out and evaluate them — not pick one.</a:t>
             </a:r>
           </a:p>
         </p:txBody>
@@ -12720,7 +11901,6 @@
           <a:lstStyle/>
           <a:p>
             <a:pPr algn="ctr"/>
-            <a:endParaRPr/>
           </a:p>
         </p:txBody>
       </p:sp>
@@ -12741,7 +11921,7 @@
           <a:noFill/>
         </p:spPr>
         <p:txBody>
-          <a:bodyPr wrap="square" lIns="0" tIns="0" rIns="0" bIns="0" anchor="t">
+          <a:bodyPr wrap="square" anchor="t" lIns="0" rIns="0" tIns="0" bIns="0">
             <a:spAutoFit/>
           </a:bodyPr>
           <a:lstStyle/>
@@ -12784,7 +11964,7 @@
           <a:noFill/>
         </p:spPr>
         <p:txBody>
-          <a:bodyPr wrap="square" lIns="0" tIns="0" rIns="0" bIns="0" anchor="t">
+          <a:bodyPr wrap="square" anchor="t" lIns="0" rIns="0" tIns="0" bIns="0">
             <a:spAutoFit/>
           </a:bodyPr>
           <a:lstStyle/>
@@ -12811,7 +11991,7 @@
 </file>
 
 <file path=ppt/slides/slide5.xml><?xml version="1.0" encoding="utf-8"?>
-<p:sld xmlns:a="http://schemas.openxmlformats.org/drawingml/2006/main" xmlns:r="http://schemas.openxmlformats.org/officeDocument/2006/relationships" xmlns:p="http://schemas.openxmlformats.org/presentationml/2006/main">
+<p:sld xmlns:a="http://schemas.openxmlformats.org/drawingml/2006/main" xmlns:p="http://schemas.openxmlformats.org/presentationml/2006/main" xmlns:r="http://schemas.openxmlformats.org/officeDocument/2006/relationships">
   <p:cSld>
     <p:bg>
       <p:bgPr>
@@ -12827,14 +12007,7 @@
         <p:cNvGrpSpPr/>
         <p:nvPr/>
       </p:nvGrpSpPr>
-      <p:grpSpPr>
-        <a:xfrm>
-          <a:off x="0" y="0"/>
-          <a:ext cx="0" cy="0"/>
-          <a:chOff x="0" y="0"/>
-          <a:chExt cx="0" cy="0"/>
-        </a:xfrm>
-      </p:grpSpPr>
+      <p:grpSpPr/>
       <p:sp>
         <p:nvSpPr>
           <p:cNvPr id="2" name="TextBox 1"/>
@@ -12852,7 +12025,7 @@
           <a:noFill/>
         </p:spPr>
         <p:txBody>
-          <a:bodyPr wrap="square" lIns="0" tIns="0" rIns="0" bIns="0" anchor="t">
+          <a:bodyPr wrap="square" anchor="t" lIns="0" rIns="0" tIns="0" bIns="0">
             <a:spAutoFit/>
           </a:bodyPr>
           <a:lstStyle/>
@@ -12874,7 +12047,7 @@
               </a:spcBef>
             </a:pPr>
             <a:r>
-              <a:rPr sz="1700" b="0" i="1">
+              <a:rPr sz="1800" b="0" i="1">
                 <a:solidFill>
                   <a:srgbClr val="D68E10"/>
                 </a:solidFill>
@@ -12926,7 +12099,6 @@
           <a:lstStyle/>
           <a:p>
             <a:pPr algn="ctr"/>
-            <a:endParaRPr/>
           </a:p>
         </p:txBody>
       </p:sp>
@@ -12947,7 +12119,7 @@
           <a:noFill/>
         </p:spPr>
         <p:txBody>
-          <a:bodyPr wrap="square" lIns="0" tIns="0" rIns="0" bIns="0" anchor="t">
+          <a:bodyPr wrap="square" anchor="t" lIns="0" rIns="0" tIns="0" bIns="0">
             <a:spAutoFit/>
           </a:bodyPr>
           <a:lstStyle/>
@@ -13063,7 +12235,16 @@
                 </a:solidFill>
                 <a:latin typeface="Roboto"/>
               </a:rPr>
-              <a:t>■  Write it down first — it's the yardstick every option is measured against.</a:t>
+              <a:t>■  </a:t>
+            </a:r>
+            <a:r>
+              <a:rPr sz="1800" b="1" i="0">
+                <a:solidFill>
+                  <a:srgbClr val="92268F"/>
+                </a:solidFill>
+                <a:latin typeface="Roboto"/>
+              </a:rPr>
+              <a:t>Write it down first — it's the yardstick every option is measured against.</a:t>
             </a:r>
           </a:p>
         </p:txBody>
@@ -13109,7 +12290,6 @@
           <a:lstStyle/>
           <a:p>
             <a:pPr algn="ctr"/>
-            <a:endParaRPr/>
           </a:p>
         </p:txBody>
       </p:sp>
@@ -13130,7 +12310,7 @@
           <a:noFill/>
         </p:spPr>
         <p:txBody>
-          <a:bodyPr wrap="square" lIns="0" tIns="0" rIns="0" bIns="0" anchor="t">
+          <a:bodyPr wrap="square" anchor="t" lIns="0" rIns="0" tIns="0" bIns="0">
             <a:spAutoFit/>
           </a:bodyPr>
           <a:lstStyle/>
@@ -13173,7 +12353,7 @@
           <a:noFill/>
         </p:spPr>
         <p:txBody>
-          <a:bodyPr wrap="square" lIns="0" tIns="0" rIns="0" bIns="0" anchor="t">
+          <a:bodyPr wrap="square" anchor="t" lIns="0" rIns="0" tIns="0" bIns="0">
             <a:spAutoFit/>
           </a:bodyPr>
           <a:lstStyle/>
@@ -13200,7 +12380,7 @@
 </file>
 
 <file path=ppt/slides/slide6.xml><?xml version="1.0" encoding="utf-8"?>
-<p:sld xmlns:a="http://schemas.openxmlformats.org/drawingml/2006/main" xmlns:r="http://schemas.openxmlformats.org/officeDocument/2006/relationships" xmlns:p="http://schemas.openxmlformats.org/presentationml/2006/main">
+<p:sld xmlns:a="http://schemas.openxmlformats.org/drawingml/2006/main" xmlns:p="http://schemas.openxmlformats.org/presentationml/2006/main" xmlns:r="http://schemas.openxmlformats.org/officeDocument/2006/relationships">
   <p:cSld>
     <p:bg>
       <p:bgPr>
@@ -13216,14 +12396,7 @@
         <p:cNvGrpSpPr/>
         <p:nvPr/>
       </p:nvGrpSpPr>
-      <p:grpSpPr>
-        <a:xfrm>
-          <a:off x="0" y="0"/>
-          <a:ext cx="0" cy="0"/>
-          <a:chOff x="0" y="0"/>
-          <a:chExt cx="0" cy="0"/>
-        </a:xfrm>
-      </p:grpSpPr>
+      <p:grpSpPr/>
       <p:sp>
         <p:nvSpPr>
           <p:cNvPr id="2" name="TextBox 1"/>
@@ -13241,7 +12414,7 @@
           <a:noFill/>
         </p:spPr>
         <p:txBody>
-          <a:bodyPr wrap="square" lIns="0" tIns="0" rIns="0" bIns="0" anchor="t">
+          <a:bodyPr wrap="square" anchor="t" lIns="0" rIns="0" tIns="0" bIns="0">
             <a:spAutoFit/>
           </a:bodyPr>
           <a:lstStyle/>
@@ -13299,7 +12472,6 @@
           <a:lstStyle/>
           <a:p>
             <a:pPr algn="ctr"/>
-            <a:endParaRPr/>
           </a:p>
         </p:txBody>
       </p:sp>
@@ -13320,7 +12492,7 @@
           <a:noFill/>
         </p:spPr>
         <p:txBody>
-          <a:bodyPr wrap="square" lIns="0" tIns="0" rIns="0" bIns="0" anchor="t">
+          <a:bodyPr wrap="square" anchor="t" lIns="0" rIns="0" tIns="0" bIns="0">
             <a:spAutoFit/>
           </a:bodyPr>
           <a:lstStyle/>
@@ -13467,7 +12639,16 @@
                 </a:solidFill>
                 <a:latin typeface="Roboto"/>
               </a:rPr>
-              <a:t>■  Every comparison needs the status-quo option — or “moving” has nothing to beat.</a:t>
+              <a:t>■  </a:t>
+            </a:r>
+            <a:r>
+              <a:rPr sz="1800" b="1" i="0">
+                <a:solidFill>
+                  <a:srgbClr val="92268F"/>
+                </a:solidFill>
+                <a:latin typeface="Roboto"/>
+              </a:rPr>
+              <a:t>Every comparison needs the status-quo option — or “moving” has nothing to beat.</a:t>
             </a:r>
           </a:p>
         </p:txBody>
@@ -13513,7 +12694,6 @@
           <a:lstStyle/>
           <a:p>
             <a:pPr algn="ctr"/>
-            <a:endParaRPr/>
           </a:p>
         </p:txBody>
       </p:sp>
@@ -13534,7 +12714,7 @@
           <a:noFill/>
         </p:spPr>
         <p:txBody>
-          <a:bodyPr wrap="square" lIns="0" tIns="0" rIns="0" bIns="0" anchor="t">
+          <a:bodyPr wrap="square" anchor="t" lIns="0" rIns="0" tIns="0" bIns="0">
             <a:spAutoFit/>
           </a:bodyPr>
           <a:lstStyle/>
@@ -13577,7 +12757,7 @@
           <a:noFill/>
         </p:spPr>
         <p:txBody>
-          <a:bodyPr wrap="square" lIns="0" tIns="0" rIns="0" bIns="0" anchor="t">
+          <a:bodyPr wrap="square" anchor="t" lIns="0" rIns="0" tIns="0" bIns="0">
             <a:spAutoFit/>
           </a:bodyPr>
           <a:lstStyle/>
@@ -13604,7 +12784,7 @@
 </file>
 
 <file path=ppt/slides/slide7.xml><?xml version="1.0" encoding="utf-8"?>
-<p:sld xmlns:a="http://schemas.openxmlformats.org/drawingml/2006/main" xmlns:r="http://schemas.openxmlformats.org/officeDocument/2006/relationships" xmlns:p="http://schemas.openxmlformats.org/presentationml/2006/main">
+<p:sld xmlns:a="http://schemas.openxmlformats.org/drawingml/2006/main" xmlns:p="http://schemas.openxmlformats.org/presentationml/2006/main" xmlns:r="http://schemas.openxmlformats.org/officeDocument/2006/relationships">
   <p:cSld>
     <p:bg>
       <p:bgPr>
@@ -13620,14 +12800,7 @@
         <p:cNvGrpSpPr/>
         <p:nvPr/>
       </p:nvGrpSpPr>
-      <p:grpSpPr>
-        <a:xfrm>
-          <a:off x="0" y="0"/>
-          <a:ext cx="0" cy="0"/>
-          <a:chOff x="0" y="0"/>
-          <a:chExt cx="0" cy="0"/>
-        </a:xfrm>
-      </p:grpSpPr>
+      <p:grpSpPr/>
       <p:sp>
         <p:nvSpPr>
           <p:cNvPr id="2" name="TextBox 1"/>
@@ -13645,7 +12818,7 @@
           <a:noFill/>
         </p:spPr>
         <p:txBody>
-          <a:bodyPr wrap="square" lIns="0" tIns="0" rIns="0" bIns="0" anchor="t">
+          <a:bodyPr wrap="square" anchor="t" lIns="0" rIns="0" tIns="0" bIns="0">
             <a:spAutoFit/>
           </a:bodyPr>
           <a:lstStyle/>
@@ -13667,7 +12840,7 @@
               </a:spcBef>
             </a:pPr>
             <a:r>
-              <a:rPr sz="1700" b="0" i="1">
+              <a:rPr sz="1800" b="0" i="1">
                 <a:solidFill>
                   <a:srgbClr val="D68E10"/>
                 </a:solidFill>
@@ -13719,7 +12892,6 @@
           <a:lstStyle/>
           <a:p>
             <a:pPr algn="ctr"/>
-            <a:endParaRPr/>
           </a:p>
         </p:txBody>
       </p:sp>
@@ -13740,7 +12912,7 @@
           <a:noFill/>
         </p:spPr>
         <p:txBody>
-          <a:bodyPr wrap="square" lIns="0" tIns="0" rIns="0" bIns="0" anchor="t">
+          <a:bodyPr wrap="square" anchor="t" lIns="0" rIns="0" tIns="0" bIns="0">
             <a:spAutoFit/>
           </a:bodyPr>
           <a:lstStyle/>
@@ -13911,7 +13083,6 @@
           <a:lstStyle/>
           <a:p>
             <a:pPr algn="ctr"/>
-            <a:endParaRPr/>
           </a:p>
         </p:txBody>
       </p:sp>
@@ -13932,7 +13103,7 @@
           <a:noFill/>
         </p:spPr>
         <p:txBody>
-          <a:bodyPr wrap="square" lIns="0" tIns="0" rIns="0" bIns="0" anchor="t">
+          <a:bodyPr wrap="square" anchor="t" lIns="0" rIns="0" tIns="0" bIns="0">
             <a:spAutoFit/>
           </a:bodyPr>
           <a:lstStyle/>
@@ -13975,7 +13146,7 @@
           <a:noFill/>
         </p:spPr>
         <p:txBody>
-          <a:bodyPr wrap="square" lIns="0" tIns="0" rIns="0" bIns="0" anchor="t">
+          <a:bodyPr wrap="square" anchor="t" lIns="0" rIns="0" tIns="0" bIns="0">
             <a:spAutoFit/>
           </a:bodyPr>
           <a:lstStyle/>
@@ -14002,7 +13173,7 @@
 </file>
 
 <file path=ppt/slides/slide8.xml><?xml version="1.0" encoding="utf-8"?>
-<p:sld xmlns:a="http://schemas.openxmlformats.org/drawingml/2006/main" xmlns:r="http://schemas.openxmlformats.org/officeDocument/2006/relationships" xmlns:p="http://schemas.openxmlformats.org/presentationml/2006/main">
+<p:sld xmlns:a="http://schemas.openxmlformats.org/drawingml/2006/main" xmlns:p="http://schemas.openxmlformats.org/presentationml/2006/main" xmlns:r="http://schemas.openxmlformats.org/officeDocument/2006/relationships">
   <p:cSld>
     <p:bg>
       <p:bgPr>
@@ -14018,14 +13189,7 @@
         <p:cNvGrpSpPr/>
         <p:nvPr/>
       </p:nvGrpSpPr>
-      <p:grpSpPr>
-        <a:xfrm>
-          <a:off x="0" y="0"/>
-          <a:ext cx="0" cy="0"/>
-          <a:chOff x="0" y="0"/>
-          <a:chExt cx="0" cy="0"/>
-        </a:xfrm>
-      </p:grpSpPr>
+      <p:grpSpPr/>
       <p:sp>
         <p:nvSpPr>
           <p:cNvPr id="2" name="TextBox 1"/>
@@ -14043,7 +13207,7 @@
           <a:noFill/>
         </p:spPr>
         <p:txBody>
-          <a:bodyPr wrap="square" lIns="0" tIns="0" rIns="0" bIns="0" anchor="t">
+          <a:bodyPr wrap="square" anchor="t" lIns="0" rIns="0" tIns="0" bIns="0">
             <a:spAutoFit/>
           </a:bodyPr>
           <a:lstStyle/>
@@ -14101,7 +13265,6 @@
           <a:lstStyle/>
           <a:p>
             <a:pPr algn="ctr"/>
-            <a:endParaRPr/>
           </a:p>
         </p:txBody>
       </p:sp>
@@ -14122,7 +13285,7 @@
           <a:noFill/>
         </p:spPr>
         <p:txBody>
-          <a:bodyPr wrap="square" lIns="0" tIns="0" rIns="0" bIns="0" anchor="t">
+          <a:bodyPr wrap="square" anchor="t" lIns="0" rIns="0" tIns="0" bIns="0">
             <a:spAutoFit/>
           </a:bodyPr>
           <a:lstStyle/>
@@ -14238,7 +13401,16 @@
                 </a:solidFill>
                 <a:latin typeface="Roboto"/>
               </a:rPr>
-              <a:t>■  This is the qualitative shortlist — the CBA and risk sections test it next.</a:t>
+              <a:t>■  </a:t>
+            </a:r>
+            <a:r>
+              <a:rPr sz="1800" b="1" i="0">
+                <a:solidFill>
+                  <a:srgbClr val="92268F"/>
+                </a:solidFill>
+                <a:latin typeface="Roboto"/>
+              </a:rPr>
+              <a:t>This is the qualitative shortlist — the CBA and risk sections test it next.</a:t>
             </a:r>
           </a:p>
         </p:txBody>
@@ -14284,7 +13456,6 @@
           <a:lstStyle/>
           <a:p>
             <a:pPr algn="ctr"/>
-            <a:endParaRPr/>
           </a:p>
         </p:txBody>
       </p:sp>
@@ -14305,7 +13476,7 @@
           <a:noFill/>
         </p:spPr>
         <p:txBody>
-          <a:bodyPr wrap="square" lIns="0" tIns="0" rIns="0" bIns="0" anchor="t">
+          <a:bodyPr wrap="square" anchor="t" lIns="0" rIns="0" tIns="0" bIns="0">
             <a:spAutoFit/>
           </a:bodyPr>
           <a:lstStyle/>
@@ -14348,7 +13519,7 @@
           <a:noFill/>
         </p:spPr>
         <p:txBody>
-          <a:bodyPr wrap="square" lIns="0" tIns="0" rIns="0" bIns="0" anchor="t">
+          <a:bodyPr wrap="square" anchor="t" lIns="0" rIns="0" tIns="0" bIns="0">
             <a:spAutoFit/>
           </a:bodyPr>
           <a:lstStyle/>
@@ -14375,7 +13546,7 @@
 </file>
 
 <file path=ppt/slides/slide9.xml><?xml version="1.0" encoding="utf-8"?>
-<p:sld xmlns:a="http://schemas.openxmlformats.org/drawingml/2006/main" xmlns:r="http://schemas.openxmlformats.org/officeDocument/2006/relationships" xmlns:p="http://schemas.openxmlformats.org/presentationml/2006/main">
+<p:sld xmlns:a="http://schemas.openxmlformats.org/drawingml/2006/main" xmlns:p="http://schemas.openxmlformats.org/presentationml/2006/main" xmlns:r="http://schemas.openxmlformats.org/officeDocument/2006/relationships">
   <p:cSld>
     <p:bg>
       <p:bgPr>
@@ -14391,14 +13562,7 @@
         <p:cNvGrpSpPr/>
         <p:nvPr/>
       </p:nvGrpSpPr>
-      <p:grpSpPr>
-        <a:xfrm>
-          <a:off x="0" y="0"/>
-          <a:ext cx="0" cy="0"/>
-          <a:chOff x="0" y="0"/>
-          <a:chExt cx="0" cy="0"/>
-        </a:xfrm>
-      </p:grpSpPr>
+      <p:grpSpPr/>
       <p:sp>
         <p:nvSpPr>
           <p:cNvPr id="2" name="Rectangle 1"/>
@@ -14440,7 +13604,6 @@
           <a:lstStyle/>
           <a:p>
             <a:pPr algn="ctr"/>
-            <a:endParaRPr/>
           </a:p>
         </p:txBody>
       </p:sp>
@@ -14481,7 +13644,7 @@
           </a:fontRef>
         </p:style>
         <p:txBody>
-          <a:bodyPr wrap="none" rtlCol="0" anchor="ctr"/>
+          <a:bodyPr rtlCol="0" anchor="ctr"/>
           <a:lstStyle/>
           <a:p>
             <a:pPr algn="ctr"/>
@@ -14514,7 +13677,7 @@
           <a:noFill/>
         </p:spPr>
         <p:txBody>
-          <a:bodyPr wrap="square" lIns="0" tIns="0" rIns="0" bIns="0" anchor="ctr">
+          <a:bodyPr wrap="square" anchor="ctr" lIns="0" rIns="0" tIns="0" bIns="0">
             <a:spAutoFit/>
           </a:bodyPr>
           <a:lstStyle/>
@@ -14548,7 +13711,7 @@
           <a:noFill/>
         </p:spPr>
         <p:txBody>
-          <a:bodyPr wrap="square" lIns="0" tIns="0" rIns="0" bIns="0" anchor="t">
+          <a:bodyPr wrap="square" anchor="t" lIns="0" rIns="0" tIns="0" bIns="0">
             <a:spAutoFit/>
           </a:bodyPr>
           <a:lstStyle/>
@@ -14814,7 +13977,6 @@
           <a:lstStyle/>
           <a:p>
             <a:pPr algn="ctr"/>
-            <a:endParaRPr/>
           </a:p>
         </p:txBody>
       </p:sp>
@@ -14835,7 +13997,7 @@
           <a:noFill/>
         </p:spPr>
         <p:txBody>
-          <a:bodyPr wrap="square" lIns="0" tIns="0" rIns="0" bIns="0" anchor="ctr">
+          <a:bodyPr wrap="square" anchor="ctr" lIns="0" rIns="0" tIns="0" bIns="0">
             <a:spAutoFit/>
           </a:bodyPr>
           <a:lstStyle/>
@@ -14893,7 +14055,6 @@
           <a:lstStyle/>
           <a:p>
             <a:pPr algn="ctr"/>
-            <a:endParaRPr/>
           </a:p>
         </p:txBody>
       </p:sp>
@@ -14914,7 +14075,7 @@
           <a:noFill/>
         </p:spPr>
         <p:txBody>
-          <a:bodyPr wrap="square" lIns="0" tIns="0" rIns="0" bIns="0" anchor="t">
+          <a:bodyPr wrap="square" anchor="t" lIns="0" rIns="0" tIns="0" bIns="0">
             <a:spAutoFit/>
           </a:bodyPr>
           <a:lstStyle/>
@@ -14957,7 +14118,7 @@
           <a:noFill/>
         </p:spPr>
         <p:txBody>
-          <a:bodyPr wrap="square" lIns="0" tIns="0" rIns="0" bIns="0" anchor="t">
+          <a:bodyPr wrap="square" anchor="t" lIns="0" rIns="0" tIns="0" bIns="0">
             <a:spAutoFit/>
           </a:bodyPr>
           <a:lstStyle/>
@@ -15301,319 +14462,4 @@
   </a:objectDefaults>
   <a:extraClrSchemeLst/>
 </a:theme>
-</file>
-
-<file path=ppt/theme/theme2.xml><?xml version="1.0" encoding="utf-8"?>
-<a:theme xmlns:a="http://schemas.openxmlformats.org/drawingml/2006/main" name="Office Theme">
-  <a:themeElements>
-    <a:clrScheme name="Office">
-      <a:dk1>
-        <a:sysClr val="windowText" lastClr="000000"/>
-      </a:dk1>
-      <a:lt1>
-        <a:sysClr val="window" lastClr="FFFFFF"/>
-      </a:lt1>
-      <a:dk2>
-        <a:srgbClr val="0E2841"/>
-      </a:dk2>
-      <a:lt2>
-        <a:srgbClr val="E8E8E8"/>
-      </a:lt2>
-      <a:accent1>
-        <a:srgbClr val="156082"/>
-      </a:accent1>
-      <a:accent2>
-        <a:srgbClr val="E97132"/>
-      </a:accent2>
-      <a:accent3>
-        <a:srgbClr val="196B24"/>
-      </a:accent3>
-      <a:accent4>
-        <a:srgbClr val="0F9ED5"/>
-      </a:accent4>
-      <a:accent5>
-        <a:srgbClr val="A02B93"/>
-      </a:accent5>
-      <a:accent6>
-        <a:srgbClr val="4EA72E"/>
-      </a:accent6>
-      <a:hlink>
-        <a:srgbClr val="467886"/>
-      </a:hlink>
-      <a:folHlink>
-        <a:srgbClr val="96607D"/>
-      </a:folHlink>
-    </a:clrScheme>
-    <a:fontScheme name="Office">
-      <a:majorFont>
-        <a:latin typeface="Aptos Display" panose="02110004020202020204"/>
-        <a:ea typeface=""/>
-        <a:cs typeface=""/>
-        <a:font script="Jpan" typeface="游ゴシック Light"/>
-        <a:font script="Hang" typeface="맑은 고딕"/>
-        <a:font script="Hans" typeface="等线 Light"/>
-        <a:font script="Hant" typeface="新細明體"/>
-        <a:font script="Arab" typeface="Times New Roman"/>
-        <a:font script="Hebr" typeface="Times New Roman"/>
-        <a:font script="Thai" typeface="Angsana New"/>
-        <a:font script="Ethi" typeface="Nyala"/>
-        <a:font script="Beng" typeface="Vrinda"/>
-        <a:font script="Gujr" typeface="Shruti"/>
-        <a:font script="Khmr" typeface="MoolBoran"/>
-        <a:font script="Knda" typeface="Tunga"/>
-        <a:font script="Guru" typeface="Raavi"/>
-        <a:font script="Cans" typeface="Euphemia"/>
-        <a:font script="Cher" typeface="Plantagenet Cherokee"/>
-        <a:font script="Yiii" typeface="Microsoft Yi Baiti"/>
-        <a:font script="Tibt" typeface="Microsoft Himalaya"/>
-        <a:font script="Thaa" typeface="MV Boli"/>
-        <a:font script="Deva" typeface="Mangal"/>
-        <a:font script="Telu" typeface="Gautami"/>
-        <a:font script="Taml" typeface="Latha"/>
-        <a:font script="Syrc" typeface="Estrangelo Edessa"/>
-        <a:font script="Orya" typeface="Kalinga"/>
-        <a:font script="Mlym" typeface="Kartika"/>
-        <a:font script="Laoo" typeface="DokChampa"/>
-        <a:font script="Sinh" typeface="Iskoola Pota"/>
-        <a:font script="Mong" typeface="Mongolian Baiti"/>
-        <a:font script="Viet" typeface="Times New Roman"/>
-        <a:font script="Uigh" typeface="Microsoft Uighur"/>
-        <a:font script="Geor" typeface="Sylfaen"/>
-        <a:font script="Armn" typeface="Arial"/>
-        <a:font script="Bugi" typeface="Leelawadee UI"/>
-        <a:font script="Bopo" typeface="Microsoft JhengHei"/>
-        <a:font script="Java" typeface="Javanese Text"/>
-        <a:font script="Lisu" typeface="Segoe UI"/>
-        <a:font script="Mymr" typeface="Myanmar Text"/>
-        <a:font script="Nkoo" typeface="Ebrima"/>
-        <a:font script="Olck" typeface="Nirmala UI"/>
-        <a:font script="Osma" typeface="Ebrima"/>
-        <a:font script="Phag" typeface="Phagspa"/>
-        <a:font script="Syrn" typeface="Estrangelo Edessa"/>
-        <a:font script="Syrj" typeface="Estrangelo Edessa"/>
-        <a:font script="Syre" typeface="Estrangelo Edessa"/>
-        <a:font script="Sora" typeface="Nirmala UI"/>
-        <a:font script="Tale" typeface="Microsoft Tai Le"/>
-        <a:font script="Talu" typeface="Microsoft New Tai Lue"/>
-        <a:font script="Tfng" typeface="Ebrima"/>
-      </a:majorFont>
-      <a:minorFont>
-        <a:latin typeface="Aptos" panose="02110004020202020204"/>
-        <a:ea typeface=""/>
-        <a:cs typeface=""/>
-        <a:font script="Jpan" typeface="游ゴシック"/>
-        <a:font script="Hang" typeface="맑은 고딕"/>
-        <a:font script="Hans" typeface="等线"/>
-        <a:font script="Hant" typeface="新細明體"/>
-        <a:font script="Arab" typeface="Arial"/>
-        <a:font script="Hebr" typeface="Arial"/>
-        <a:font script="Thai" typeface="Cordia New"/>
-        <a:font script="Ethi" typeface="Nyala"/>
-        <a:font script="Beng" typeface="Vrinda"/>
-        <a:font script="Gujr" typeface="Shruti"/>
-        <a:font script="Khmr" typeface="DaunPenh"/>
-        <a:font script="Knda" typeface="Tunga"/>
-        <a:font script="Guru" typeface="Raavi"/>
-        <a:font script="Cans" typeface="Euphemia"/>
-        <a:font script="Cher" typeface="Plantagenet Cherokee"/>
-        <a:font script="Yiii" typeface="Microsoft Yi Baiti"/>
-        <a:font script="Tibt" typeface="Microsoft Himalaya"/>
-        <a:font script="Thaa" typeface="MV Boli"/>
-        <a:font script="Deva" typeface="Mangal"/>
-        <a:font script="Telu" typeface="Gautami"/>
-        <a:font script="Taml" typeface="Latha"/>
-        <a:font script="Syrc" typeface="Estrangelo Edessa"/>
-        <a:font script="Orya" typeface="Kalinga"/>
-        <a:font script="Mlym" typeface="Kartika"/>
-        <a:font script="Laoo" typeface="DokChampa"/>
-        <a:font script="Sinh" typeface="Iskoola Pota"/>
-        <a:font script="Mong" typeface="Mongolian Baiti"/>
-        <a:font script="Viet" typeface="Arial"/>
-        <a:font script="Uigh" typeface="Microsoft Uighur"/>
-        <a:font script="Geor" typeface="Sylfaen"/>
-        <a:font script="Armn" typeface="Arial"/>
-        <a:font script="Bugi" typeface="Leelawadee UI"/>
-        <a:font script="Bopo" typeface="Microsoft JhengHei"/>
-        <a:font script="Java" typeface="Javanese Text"/>
-        <a:font script="Lisu" typeface="Segoe UI"/>
-        <a:font script="Mymr" typeface="Myanmar Text"/>
-        <a:font script="Nkoo" typeface="Ebrima"/>
-        <a:font script="Olck" typeface="Nirmala UI"/>
-        <a:font script="Osma" typeface="Ebrima"/>
-        <a:font script="Phag" typeface="Phagspa"/>
-        <a:font script="Syrn" typeface="Estrangelo Edessa"/>
-        <a:font script="Syrj" typeface="Estrangelo Edessa"/>
-        <a:font script="Syre" typeface="Estrangelo Edessa"/>
-        <a:font script="Sora" typeface="Nirmala UI"/>
-        <a:font script="Tale" typeface="Microsoft Tai Le"/>
-        <a:font script="Talu" typeface="Microsoft New Tai Lue"/>
-        <a:font script="Tfng" typeface="Ebrima"/>
-      </a:minorFont>
-    </a:fontScheme>
-    <a:fmtScheme name="Office">
-      <a:fillStyleLst>
-        <a:solidFill>
-          <a:schemeClr val="phClr"/>
-        </a:solidFill>
-        <a:gradFill rotWithShape="1">
-          <a:gsLst>
-            <a:gs pos="0">
-              <a:schemeClr val="phClr">
-                <a:lumMod val="110000"/>
-                <a:satMod val="105000"/>
-                <a:tint val="67000"/>
-              </a:schemeClr>
-            </a:gs>
-            <a:gs pos="50000">
-              <a:schemeClr val="phClr">
-                <a:lumMod val="105000"/>
-                <a:satMod val="103000"/>
-                <a:tint val="73000"/>
-              </a:schemeClr>
-            </a:gs>
-            <a:gs pos="100000">
-              <a:schemeClr val="phClr">
-                <a:lumMod val="105000"/>
-                <a:satMod val="109000"/>
-                <a:tint val="81000"/>
-              </a:schemeClr>
-            </a:gs>
-          </a:gsLst>
-          <a:lin ang="5400000" scaled="0"/>
-        </a:gradFill>
-        <a:gradFill rotWithShape="1">
-          <a:gsLst>
-            <a:gs pos="0">
-              <a:schemeClr val="phClr">
-                <a:satMod val="103000"/>
-                <a:lumMod val="102000"/>
-                <a:tint val="94000"/>
-              </a:schemeClr>
-            </a:gs>
-            <a:gs pos="50000">
-              <a:schemeClr val="phClr">
-                <a:satMod val="110000"/>
-                <a:lumMod val="100000"/>
-                <a:shade val="100000"/>
-              </a:schemeClr>
-            </a:gs>
-            <a:gs pos="100000">
-              <a:schemeClr val="phClr">
-                <a:lumMod val="99000"/>
-                <a:satMod val="120000"/>
-                <a:shade val="78000"/>
-              </a:schemeClr>
-            </a:gs>
-          </a:gsLst>
-          <a:lin ang="5400000" scaled="0"/>
-        </a:gradFill>
-      </a:fillStyleLst>
-      <a:lnStyleLst>
-        <a:ln w="12700" cap="flat" cmpd="sng" algn="ctr">
-          <a:solidFill>
-            <a:schemeClr val="phClr"/>
-          </a:solidFill>
-          <a:prstDash val="solid"/>
-          <a:miter lim="800000"/>
-        </a:ln>
-        <a:ln w="19050" cap="flat" cmpd="sng" algn="ctr">
-          <a:solidFill>
-            <a:schemeClr val="phClr"/>
-          </a:solidFill>
-          <a:prstDash val="solid"/>
-          <a:miter lim="800000"/>
-        </a:ln>
-        <a:ln w="25400" cap="flat" cmpd="sng" algn="ctr">
-          <a:solidFill>
-            <a:schemeClr val="phClr"/>
-          </a:solidFill>
-          <a:prstDash val="solid"/>
-          <a:miter lim="800000"/>
-        </a:ln>
-      </a:lnStyleLst>
-      <a:effectStyleLst>
-        <a:effectStyle>
-          <a:effectLst/>
-        </a:effectStyle>
-        <a:effectStyle>
-          <a:effectLst/>
-        </a:effectStyle>
-        <a:effectStyle>
-          <a:effectLst>
-            <a:outerShdw blurRad="57150" dist="19050" dir="5400000" algn="ctr" rotWithShape="0">
-              <a:srgbClr val="000000">
-                <a:alpha val="63000"/>
-              </a:srgbClr>
-            </a:outerShdw>
-          </a:effectLst>
-        </a:effectStyle>
-      </a:effectStyleLst>
-      <a:bgFillStyleLst>
-        <a:solidFill>
-          <a:schemeClr val="phClr"/>
-        </a:solidFill>
-        <a:solidFill>
-          <a:schemeClr val="phClr">
-            <a:tint val="95000"/>
-            <a:satMod val="170000"/>
-          </a:schemeClr>
-        </a:solidFill>
-        <a:gradFill rotWithShape="1">
-          <a:gsLst>
-            <a:gs pos="0">
-              <a:schemeClr val="phClr">
-                <a:tint val="93000"/>
-                <a:satMod val="150000"/>
-                <a:shade val="98000"/>
-                <a:lumMod val="102000"/>
-              </a:schemeClr>
-            </a:gs>
-            <a:gs pos="50000">
-              <a:schemeClr val="phClr">
-                <a:tint val="98000"/>
-                <a:satMod val="130000"/>
-                <a:shade val="90000"/>
-                <a:lumMod val="103000"/>
-              </a:schemeClr>
-            </a:gs>
-            <a:gs pos="100000">
-              <a:schemeClr val="phClr">
-                <a:shade val="63000"/>
-                <a:satMod val="120000"/>
-              </a:schemeClr>
-            </a:gs>
-          </a:gsLst>
-          <a:lin ang="5400000" scaled="0"/>
-        </a:gradFill>
-      </a:bgFillStyleLst>
-    </a:fmtScheme>
-  </a:themeElements>
-  <a:objectDefaults>
-    <a:lnDef>
-      <a:spPr/>
-      <a:bodyPr/>
-      <a:lstStyle/>
-      <a:style>
-        <a:lnRef idx="2">
-          <a:schemeClr val="accent1"/>
-        </a:lnRef>
-        <a:fillRef idx="0">
-          <a:schemeClr val="accent1"/>
-        </a:fillRef>
-        <a:effectRef idx="1">
-          <a:schemeClr val="accent1"/>
-        </a:effectRef>
-        <a:fontRef idx="minor">
-          <a:schemeClr val="tx1"/>
-        </a:fontRef>
-      </a:style>
-    </a:lnDef>
-  </a:objectDefaults>
-  <a:extraClrSchemeLst/>
-  <a:extLst>
-    <a:ext uri="{05A4C25C-085E-4340-85A3-A5531E510DB2}">
-      <thm15:themeFamily xmlns:thm15="http://schemas.microsoft.com/office/thememl/2012/main" name="Office Theme" id="{2E142A2C-CD16-42D6-873A-C26D2A0506FA}" vid="{1BDDFF52-6CD6-40A5-AB3C-68EB2F1E4D0A}"/>
-    </a:ext>
-  </a:extLst>
-</a:theme>
 </file>
</xml_diff>

<commit_message>
manual edits to topics 1 to 5 made as a result of actual classromm delivery revealing needed changes
</commit_message>
<xml_diff>
--- a/S1-CL1-Cloud-Design-Build/delivery/topic_03/Topic_03_Slides.pptx
+++ b/S1-CL1-Cloud-Design-Build/delivery/topic_03/Topic_03_Slides.pptx
@@ -4,35 +4,38 @@
   <p:sldMasterIdLst>
     <p:sldMasterId id="2147483648" r:id="rId1"/>
   </p:sldMasterIdLst>
+  <p:notesMasterIdLst>
+    <p:notesMasterId r:id="rId28"/>
+  </p:notesMasterIdLst>
   <p:sldIdLst>
-    <p:sldId id="256" r:id="rId7"/>
-    <p:sldId id="257" r:id="rId8"/>
-    <p:sldId id="258" r:id="rId10"/>
-    <p:sldId id="259" r:id="rId11"/>
-    <p:sldId id="260" r:id="rId12"/>
-    <p:sldId id="261" r:id="rId13"/>
-    <p:sldId id="262" r:id="rId14"/>
-    <p:sldId id="263" r:id="rId15"/>
-    <p:sldId id="264" r:id="rId16"/>
-    <p:sldId id="265" r:id="rId17"/>
-    <p:sldId id="266" r:id="rId18"/>
-    <p:sldId id="267" r:id="rId19"/>
-    <p:sldId id="268" r:id="rId20"/>
-    <p:sldId id="269" r:id="rId21"/>
-    <p:sldId id="270" r:id="rId22"/>
-    <p:sldId id="271" r:id="rId23"/>
-    <p:sldId id="272" r:id="rId24"/>
-    <p:sldId id="273" r:id="rId25"/>
-    <p:sldId id="274" r:id="rId26"/>
-    <p:sldId id="275" r:id="rId27"/>
-    <p:sldId id="276" r:id="rId28"/>
-    <p:sldId id="277" r:id="rId29"/>
-    <p:sldId id="278" r:id="rId30"/>
-    <p:sldId id="279" r:id="rId31"/>
-    <p:sldId id="280" r:id="rId32"/>
-    <p:sldId id="281" r:id="rId33"/>
+    <p:sldId id="256" r:id="rId2"/>
+    <p:sldId id="257" r:id="rId3"/>
+    <p:sldId id="258" r:id="rId4"/>
+    <p:sldId id="259" r:id="rId5"/>
+    <p:sldId id="260" r:id="rId6"/>
+    <p:sldId id="261" r:id="rId7"/>
+    <p:sldId id="262" r:id="rId8"/>
+    <p:sldId id="263" r:id="rId9"/>
+    <p:sldId id="264" r:id="rId10"/>
+    <p:sldId id="265" r:id="rId11"/>
+    <p:sldId id="266" r:id="rId12"/>
+    <p:sldId id="267" r:id="rId13"/>
+    <p:sldId id="268" r:id="rId14"/>
+    <p:sldId id="269" r:id="rId15"/>
+    <p:sldId id="270" r:id="rId16"/>
+    <p:sldId id="271" r:id="rId17"/>
+    <p:sldId id="272" r:id="rId18"/>
+    <p:sldId id="273" r:id="rId19"/>
+    <p:sldId id="274" r:id="rId20"/>
+    <p:sldId id="275" r:id="rId21"/>
+    <p:sldId id="276" r:id="rId22"/>
+    <p:sldId id="277" r:id="rId23"/>
+    <p:sldId id="278" r:id="rId24"/>
+    <p:sldId id="279" r:id="rId25"/>
+    <p:sldId id="280" r:id="rId26"/>
+    <p:sldId id="281" r:id="rId27"/>
   </p:sldIdLst>
-  <p:sldSz cx="12191695" cy="6858000" type="screen4x3"/>
+  <p:sldSz cx="12192000" cy="6858000"/>
   <p:notesSz cx="6858000" cy="9144000"/>
   <p:defaultTextStyle>
     <a:defPPr>
@@ -129,11 +132,27 @@
       </a:defRPr>
     </a:lvl9pPr>
   </p:defaultTextStyle>
+  <p:extLst>
+    <p:ext uri="{EFAFB233-063F-42B5-8137-9DF3F51BA10A}">
+      <p15:sldGuideLst xmlns:p15="http://schemas.microsoft.com/office/powerpoint/2012/main">
+        <p15:guide id="1" orient="horz" pos="2160">
+          <p15:clr>
+            <a:srgbClr val="A4A3A4"/>
+          </p15:clr>
+        </p15:guide>
+        <p15:guide id="2" pos="2880">
+          <p15:clr>
+            <a:srgbClr val="A4A3A4"/>
+          </p15:clr>
+        </p15:guide>
+      </p15:sldGuideLst>
+    </p:ext>
+  </p:extLst>
 </p:presentation>
 </file>
 
 <file path=ppt/notesMasters/notesMaster1.xml><?xml version="1.0" encoding="utf-8"?>
-<p:notesMaster xmlns:a="http://schemas.openxmlformats.org/drawingml/2006/main" xmlns:p="http://schemas.openxmlformats.org/presentationml/2006/main" xmlns:r="http://schemas.openxmlformats.org/officeDocument/2006/relationships">
+<p:notesMaster xmlns:a="http://schemas.openxmlformats.org/drawingml/2006/main" xmlns:r="http://schemas.openxmlformats.org/officeDocument/2006/relationships" xmlns:p="http://schemas.openxmlformats.org/presentationml/2006/main">
   <p:cSld>
     <p:bg>
       <p:bgRef idx="1001">
@@ -167,7 +186,7 @@
         <p:spPr>
           <a:xfrm>
             <a:off x="0" y="0"/>
-            <a:ext cx="2971800" cy="457200"/>
+            <a:ext cx="2971800" cy="458788"/>
           </a:xfrm>
           <a:prstGeom prst="rect">
             <a:avLst/>
@@ -198,7 +217,7 @@
         <p:spPr>
           <a:xfrm>
             <a:off x="3884613" y="0"/>
-            <a:ext cx="2971800" cy="457200"/>
+            <a:ext cx="2971800" cy="458788"/>
           </a:xfrm>
           <a:prstGeom prst="rect">
             <a:avLst/>
@@ -212,9 +231,9 @@
             </a:lvl1pPr>
           </a:lstStyle>
           <a:p>
-            <a:fld id="{0F89C1C7-3DCD-1040-A9CF-14679D8B5DDD}" type="datetimeFigureOut">
+            <a:fld id="{4AEAA820-9D35-4E42-9A95-DC6E38A82369}" type="datetimeFigureOut">
               <a:rPr lang="en-US" smtClean="0"/>
-              <a:t>10/17/16</a:t>
+              <a:t>7/16/26</a:t>
             </a:fld>
             <a:endParaRPr lang="en-US"/>
           </a:p>
@@ -232,8 +251,8 @@
         </p:nvSpPr>
         <p:spPr>
           <a:xfrm>
-            <a:off x="1143000" y="685800"/>
-            <a:ext cx="4572000" cy="3429000"/>
+            <a:off x="685800" y="1143000"/>
+            <a:ext cx="5486400" cy="3086100"/>
           </a:xfrm>
           <a:prstGeom prst="rect">
             <a:avLst/>
@@ -265,8 +284,8 @@
         </p:nvSpPr>
         <p:spPr>
           <a:xfrm>
-            <a:off x="685800" y="4343400"/>
-            <a:ext cx="5486400" cy="4114800"/>
+            <a:off x="685800" y="4400550"/>
+            <a:ext cx="5486400" cy="3600450"/>
           </a:xfrm>
           <a:prstGeom prst="rect">
             <a:avLst/>
@@ -278,35 +297,35 @@
           <a:p>
             <a:pPr lvl="0"/>
             <a:r>
-              <a:rPr lang="en-US" smtClean="0"/>
+              <a:rPr lang="en-GB"/>
               <a:t>Click to edit Master text styles</a:t>
             </a:r>
           </a:p>
           <a:p>
             <a:pPr lvl="1"/>
             <a:r>
-              <a:rPr lang="en-US" smtClean="0"/>
+              <a:rPr lang="en-GB"/>
               <a:t>Second level</a:t>
             </a:r>
           </a:p>
           <a:p>
             <a:pPr lvl="2"/>
             <a:r>
-              <a:rPr lang="en-US" smtClean="0"/>
+              <a:rPr lang="en-GB"/>
               <a:t>Third level</a:t>
             </a:r>
           </a:p>
           <a:p>
             <a:pPr lvl="3"/>
             <a:r>
-              <a:rPr lang="en-US" smtClean="0"/>
+              <a:rPr lang="en-GB"/>
               <a:t>Fourth level</a:t>
             </a:r>
           </a:p>
           <a:p>
             <a:pPr lvl="4"/>
             <a:r>
-              <a:rPr lang="en-US" smtClean="0"/>
+              <a:rPr lang="en-GB"/>
               <a:t>Fifth level</a:t>
             </a:r>
             <a:endParaRPr lang="en-US"/>
@@ -326,7 +345,7 @@
         <p:spPr>
           <a:xfrm>
             <a:off x="0" y="8685213"/>
-            <a:ext cx="2971800" cy="457200"/>
+            <a:ext cx="2971800" cy="458787"/>
           </a:xfrm>
           <a:prstGeom prst="rect">
             <a:avLst/>
@@ -357,7 +376,7 @@
         <p:spPr>
           <a:xfrm>
             <a:off x="3884613" y="8685213"/>
-            <a:ext cx="2971800" cy="457200"/>
+            <a:ext cx="2971800" cy="458787"/>
           </a:xfrm>
           <a:prstGeom prst="rect">
             <a:avLst/>
@@ -371,7 +390,7 @@
             </a:lvl1pPr>
           </a:lstStyle>
           <a:p>
-            <a:fld id="{BB5E49A5-4136-284D-997B-48E1D791AD67}" type="slidenum">
+            <a:fld id="{EE5782C4-4E3F-4B45-B848-237C9BDA8D91}" type="slidenum">
               <a:rPr lang="en-US" smtClean="0"/>
               <a:t>‹#›</a:t>
             </a:fld>
@@ -382,13 +401,13 @@
     </p:spTree>
     <p:extLst>
       <p:ext uri="{BB962C8B-B14F-4D97-AF65-F5344CB8AC3E}">
-        <p14:creationId xmlns:p14="http://schemas.microsoft.com/office/powerpoint/2010/main" val="2623252185"/>
+        <p14:creationId xmlns:p14="http://schemas.microsoft.com/office/powerpoint/2010/main" val="887740670"/>
       </p:ext>
     </p:extLst>
   </p:cSld>
   <p:clrMap bg1="lt1" tx1="dk1" bg2="lt2" tx2="dk2" accent1="accent1" accent2="accent2" accent3="accent3" accent4="accent4" accent5="accent5" accent6="accent6" hlink="hlink" folHlink="folHlink"/>
   <p:notesStyle>
-    <a:lvl1pPr marL="0" algn="l" defTabSz="457200" rtl="0" eaLnBrk="1" latinLnBrk="0" hangingPunct="1">
+    <a:lvl1pPr marL="0" algn="l" defTabSz="914400" rtl="0" eaLnBrk="1" latinLnBrk="0" hangingPunct="1">
       <a:defRPr sz="1200" kern="1200">
         <a:solidFill>
           <a:schemeClr val="tx1"/>
@@ -398,7 +417,7 @@
         <a:cs typeface="+mn-cs"/>
       </a:defRPr>
     </a:lvl1pPr>
-    <a:lvl2pPr marL="457200" algn="l" defTabSz="457200" rtl="0" eaLnBrk="1" latinLnBrk="0" hangingPunct="1">
+    <a:lvl2pPr marL="457200" algn="l" defTabSz="914400" rtl="0" eaLnBrk="1" latinLnBrk="0" hangingPunct="1">
       <a:defRPr sz="1200" kern="1200">
         <a:solidFill>
           <a:schemeClr val="tx1"/>
@@ -408,7 +427,7 @@
         <a:cs typeface="+mn-cs"/>
       </a:defRPr>
     </a:lvl2pPr>
-    <a:lvl3pPr marL="914400" algn="l" defTabSz="457200" rtl="0" eaLnBrk="1" latinLnBrk="0" hangingPunct="1">
+    <a:lvl3pPr marL="914400" algn="l" defTabSz="914400" rtl="0" eaLnBrk="1" latinLnBrk="0" hangingPunct="1">
       <a:defRPr sz="1200" kern="1200">
         <a:solidFill>
           <a:schemeClr val="tx1"/>
@@ -418,7 +437,7 @@
         <a:cs typeface="+mn-cs"/>
       </a:defRPr>
     </a:lvl3pPr>
-    <a:lvl4pPr marL="1371600" algn="l" defTabSz="457200" rtl="0" eaLnBrk="1" latinLnBrk="0" hangingPunct="1">
+    <a:lvl4pPr marL="1371600" algn="l" defTabSz="914400" rtl="0" eaLnBrk="1" latinLnBrk="0" hangingPunct="1">
       <a:defRPr sz="1200" kern="1200">
         <a:solidFill>
           <a:schemeClr val="tx1"/>
@@ -428,7 +447,7 @@
         <a:cs typeface="+mn-cs"/>
       </a:defRPr>
     </a:lvl4pPr>
-    <a:lvl5pPr marL="1828800" algn="l" defTabSz="457200" rtl="0" eaLnBrk="1" latinLnBrk="0" hangingPunct="1">
+    <a:lvl5pPr marL="1828800" algn="l" defTabSz="914400" rtl="0" eaLnBrk="1" latinLnBrk="0" hangingPunct="1">
       <a:defRPr sz="1200" kern="1200">
         <a:solidFill>
           <a:schemeClr val="tx1"/>
@@ -438,7 +457,7 @@
         <a:cs typeface="+mn-cs"/>
       </a:defRPr>
     </a:lvl5pPr>
-    <a:lvl6pPr marL="2286000" algn="l" defTabSz="457200" rtl="0" eaLnBrk="1" latinLnBrk="0" hangingPunct="1">
+    <a:lvl6pPr marL="2286000" algn="l" defTabSz="914400" rtl="0" eaLnBrk="1" latinLnBrk="0" hangingPunct="1">
       <a:defRPr sz="1200" kern="1200">
         <a:solidFill>
           <a:schemeClr val="tx1"/>
@@ -448,7 +467,7 @@
         <a:cs typeface="+mn-cs"/>
       </a:defRPr>
     </a:lvl6pPr>
-    <a:lvl7pPr marL="2743200" algn="l" defTabSz="457200" rtl="0" eaLnBrk="1" latinLnBrk="0" hangingPunct="1">
+    <a:lvl7pPr marL="2743200" algn="l" defTabSz="914400" rtl="0" eaLnBrk="1" latinLnBrk="0" hangingPunct="1">
       <a:defRPr sz="1200" kern="1200">
         <a:solidFill>
           <a:schemeClr val="tx1"/>
@@ -458,7 +477,7 @@
         <a:cs typeface="+mn-cs"/>
       </a:defRPr>
     </a:lvl7pPr>
-    <a:lvl8pPr marL="3200400" algn="l" defTabSz="457200" rtl="0" eaLnBrk="1" latinLnBrk="0" hangingPunct="1">
+    <a:lvl8pPr marL="3200400" algn="l" defTabSz="914400" rtl="0" eaLnBrk="1" latinLnBrk="0" hangingPunct="1">
       <a:defRPr sz="1200" kern="1200">
         <a:solidFill>
           <a:schemeClr val="tx1"/>
@@ -468,7 +487,7 @@
         <a:cs typeface="+mn-cs"/>
       </a:defRPr>
     </a:lvl8pPr>
-    <a:lvl9pPr marL="3657600" algn="l" defTabSz="457200" rtl="0" eaLnBrk="1" latinLnBrk="0" hangingPunct="1">
+    <a:lvl9pPr marL="3657600" algn="l" defTabSz="914400" rtl="0" eaLnBrk="1" latinLnBrk="0" hangingPunct="1">
       <a:defRPr sz="1200" kern="1200">
         <a:solidFill>
           <a:schemeClr val="tx1"/>
@@ -483,7 +502,7 @@
 </file>
 
 <file path=ppt/notesSlides/notesSlide1.xml><?xml version="1.0" encoding="utf-8"?>
-<p:notes xmlns:a="http://schemas.openxmlformats.org/drawingml/2006/main" xmlns:p="http://schemas.openxmlformats.org/presentationml/2006/main" xmlns:r="http://schemas.openxmlformats.org/officeDocument/2006/relationships">
+<p:notes xmlns:a="http://schemas.openxmlformats.org/drawingml/2006/main" xmlns:r="http://schemas.openxmlformats.org/officeDocument/2006/relationships" xmlns:p="http://schemas.openxmlformats.org/presentationml/2006/main">
   <p:cSld>
     <p:spTree>
       <p:nvGrpSpPr>
@@ -503,7 +522,7 @@
         <p:nvSpPr>
           <p:cNvPr id="2" name="Slide Image Placeholder 1"/>
           <p:cNvSpPr>
-            <a:spLocks noGrp="1"/>
+            <a:spLocks noGrp="1" noRot="1" noChangeAspect="1"/>
           </p:cNvSpPr>
           <p:nvPr>
             <p:ph type="sldImg" idx="2"/>
@@ -518,7 +537,7 @@
             <a:spLocks noGrp="1"/>
           </p:cNvSpPr>
           <p:nvPr>
-            <p:ph type="body" idx="3" sz="quarter"/>
+            <p:ph type="body" sz="quarter" idx="3"/>
           </p:nvPr>
         </p:nvSpPr>
         <p:spPr/>
@@ -609,7 +628,7 @@
             <a:spLocks noGrp="1"/>
           </p:cNvSpPr>
           <p:nvPr>
-            <p:ph type="sldNum" idx="5" sz="quarter"/>
+            <p:ph type="sldNum" sz="quarter" idx="5"/>
           </p:nvPr>
         </p:nvSpPr>
         <p:spPr/>
@@ -623,7 +642,7 @@
 </file>
 
 <file path=ppt/notesSlides/notesSlide10.xml><?xml version="1.0" encoding="utf-8"?>
-<p:notes xmlns:a="http://schemas.openxmlformats.org/drawingml/2006/main" xmlns:p="http://schemas.openxmlformats.org/presentationml/2006/main" xmlns:r="http://schemas.openxmlformats.org/officeDocument/2006/relationships">
+<p:notes xmlns:a="http://schemas.openxmlformats.org/drawingml/2006/main" xmlns:r="http://schemas.openxmlformats.org/officeDocument/2006/relationships" xmlns:p="http://schemas.openxmlformats.org/presentationml/2006/main">
   <p:cSld>
     <p:spTree>
       <p:nvGrpSpPr>
@@ -643,7 +662,7 @@
         <p:nvSpPr>
           <p:cNvPr id="2" name="Slide Image Placeholder 1"/>
           <p:cNvSpPr>
-            <a:spLocks noGrp="1"/>
+            <a:spLocks noGrp="1" noRot="1" noChangeAspect="1"/>
           </p:cNvSpPr>
           <p:nvPr>
             <p:ph type="sldImg" idx="2"/>
@@ -658,7 +677,7 @@
             <a:spLocks noGrp="1"/>
           </p:cNvSpPr>
           <p:nvPr>
-            <p:ph type="body" idx="3" sz="quarter"/>
+            <p:ph type="body" sz="quarter" idx="3"/>
           </p:nvPr>
         </p:nvSpPr>
         <p:spPr/>
@@ -734,7 +753,7 @@
             <a:spLocks noGrp="1"/>
           </p:cNvSpPr>
           <p:nvPr>
-            <p:ph type="sldNum" idx="5" sz="quarter"/>
+            <p:ph type="sldNum" sz="quarter" idx="5"/>
           </p:nvPr>
         </p:nvSpPr>
         <p:spPr/>
@@ -748,7 +767,7 @@
 </file>
 
 <file path=ppt/notesSlides/notesSlide11.xml><?xml version="1.0" encoding="utf-8"?>
-<p:notes xmlns:a="http://schemas.openxmlformats.org/drawingml/2006/main" xmlns:p="http://schemas.openxmlformats.org/presentationml/2006/main" xmlns:r="http://schemas.openxmlformats.org/officeDocument/2006/relationships">
+<p:notes xmlns:a="http://schemas.openxmlformats.org/drawingml/2006/main" xmlns:r="http://schemas.openxmlformats.org/officeDocument/2006/relationships" xmlns:p="http://schemas.openxmlformats.org/presentationml/2006/main">
   <p:cSld>
     <p:spTree>
       <p:nvGrpSpPr>
@@ -768,7 +787,7 @@
         <p:nvSpPr>
           <p:cNvPr id="2" name="Slide Image Placeholder 1"/>
           <p:cNvSpPr>
-            <a:spLocks noGrp="1"/>
+            <a:spLocks noGrp="1" noRot="1" noChangeAspect="1"/>
           </p:cNvSpPr>
           <p:nvPr>
             <p:ph type="sldImg" idx="2"/>
@@ -783,7 +802,7 @@
             <a:spLocks noGrp="1"/>
           </p:cNvSpPr>
           <p:nvPr>
-            <p:ph type="body" idx="3" sz="quarter"/>
+            <p:ph type="body" sz="quarter" idx="3"/>
           </p:nvPr>
         </p:nvSpPr>
         <p:spPr/>
@@ -864,7 +883,7 @@
             <a:spLocks noGrp="1"/>
           </p:cNvSpPr>
           <p:nvPr>
-            <p:ph type="sldNum" idx="5" sz="quarter"/>
+            <p:ph type="sldNum" sz="quarter" idx="5"/>
           </p:nvPr>
         </p:nvSpPr>
         <p:spPr/>
@@ -878,7 +897,7 @@
 </file>
 
 <file path=ppt/notesSlides/notesSlide12.xml><?xml version="1.0" encoding="utf-8"?>
-<p:notes xmlns:a="http://schemas.openxmlformats.org/drawingml/2006/main" xmlns:p="http://schemas.openxmlformats.org/presentationml/2006/main" xmlns:r="http://schemas.openxmlformats.org/officeDocument/2006/relationships">
+<p:notes xmlns:a="http://schemas.openxmlformats.org/drawingml/2006/main" xmlns:r="http://schemas.openxmlformats.org/officeDocument/2006/relationships" xmlns:p="http://schemas.openxmlformats.org/presentationml/2006/main">
   <p:cSld>
     <p:spTree>
       <p:nvGrpSpPr>
@@ -898,7 +917,7 @@
         <p:nvSpPr>
           <p:cNvPr id="2" name="Slide Image Placeholder 1"/>
           <p:cNvSpPr>
-            <a:spLocks noGrp="1"/>
+            <a:spLocks noGrp="1" noRot="1" noChangeAspect="1"/>
           </p:cNvSpPr>
           <p:nvPr>
             <p:ph type="sldImg" idx="2"/>
@@ -913,7 +932,7 @@
             <a:spLocks noGrp="1"/>
           </p:cNvSpPr>
           <p:nvPr>
-            <p:ph type="body" idx="3" sz="quarter"/>
+            <p:ph type="body" sz="quarter" idx="3"/>
           </p:nvPr>
         </p:nvSpPr>
         <p:spPr/>
@@ -1004,7 +1023,7 @@
             <a:spLocks noGrp="1"/>
           </p:cNvSpPr>
           <p:nvPr>
-            <p:ph type="sldNum" idx="5" sz="quarter"/>
+            <p:ph type="sldNum" sz="quarter" idx="5"/>
           </p:nvPr>
         </p:nvSpPr>
         <p:spPr/>
@@ -1018,7 +1037,7 @@
 </file>
 
 <file path=ppt/notesSlides/notesSlide13.xml><?xml version="1.0" encoding="utf-8"?>
-<p:notes xmlns:a="http://schemas.openxmlformats.org/drawingml/2006/main" xmlns:p="http://schemas.openxmlformats.org/presentationml/2006/main" xmlns:r="http://schemas.openxmlformats.org/officeDocument/2006/relationships">
+<p:notes xmlns:a="http://schemas.openxmlformats.org/drawingml/2006/main" xmlns:r="http://schemas.openxmlformats.org/officeDocument/2006/relationships" xmlns:p="http://schemas.openxmlformats.org/presentationml/2006/main">
   <p:cSld>
     <p:spTree>
       <p:nvGrpSpPr>
@@ -1038,7 +1057,7 @@
         <p:nvSpPr>
           <p:cNvPr id="2" name="Slide Image Placeholder 1"/>
           <p:cNvSpPr>
-            <a:spLocks noGrp="1"/>
+            <a:spLocks noGrp="1" noRot="1" noChangeAspect="1"/>
           </p:cNvSpPr>
           <p:nvPr>
             <p:ph type="sldImg" idx="2"/>
@@ -1053,7 +1072,7 @@
             <a:spLocks noGrp="1"/>
           </p:cNvSpPr>
           <p:nvPr>
-            <p:ph type="body" idx="3" sz="quarter"/>
+            <p:ph type="body" sz="quarter" idx="3"/>
           </p:nvPr>
         </p:nvSpPr>
         <p:spPr/>
@@ -1134,7 +1153,7 @@
             <a:spLocks noGrp="1"/>
           </p:cNvSpPr>
           <p:nvPr>
-            <p:ph type="sldNum" idx="5" sz="quarter"/>
+            <p:ph type="sldNum" sz="quarter" idx="5"/>
           </p:nvPr>
         </p:nvSpPr>
         <p:spPr/>
@@ -1148,7 +1167,7 @@
 </file>
 
 <file path=ppt/notesSlides/notesSlide14.xml><?xml version="1.0" encoding="utf-8"?>
-<p:notes xmlns:a="http://schemas.openxmlformats.org/drawingml/2006/main" xmlns:p="http://schemas.openxmlformats.org/presentationml/2006/main" xmlns:r="http://schemas.openxmlformats.org/officeDocument/2006/relationships">
+<p:notes xmlns:a="http://schemas.openxmlformats.org/drawingml/2006/main" xmlns:r="http://schemas.openxmlformats.org/officeDocument/2006/relationships" xmlns:p="http://schemas.openxmlformats.org/presentationml/2006/main">
   <p:cSld>
     <p:spTree>
       <p:nvGrpSpPr>
@@ -1168,7 +1187,7 @@
         <p:nvSpPr>
           <p:cNvPr id="2" name="Slide Image Placeholder 1"/>
           <p:cNvSpPr>
-            <a:spLocks noGrp="1"/>
+            <a:spLocks noGrp="1" noRot="1" noChangeAspect="1"/>
           </p:cNvSpPr>
           <p:nvPr>
             <p:ph type="sldImg" idx="2"/>
@@ -1183,7 +1202,7 @@
             <a:spLocks noGrp="1"/>
           </p:cNvSpPr>
           <p:nvPr>
-            <p:ph type="body" idx="3" sz="quarter"/>
+            <p:ph type="body" sz="quarter" idx="3"/>
           </p:nvPr>
         </p:nvSpPr>
         <p:spPr/>
@@ -1274,7 +1293,7 @@
             <a:spLocks noGrp="1"/>
           </p:cNvSpPr>
           <p:nvPr>
-            <p:ph type="sldNum" idx="5" sz="quarter"/>
+            <p:ph type="sldNum" sz="quarter" idx="5"/>
           </p:nvPr>
         </p:nvSpPr>
         <p:spPr/>
@@ -1288,7 +1307,7 @@
 </file>
 
 <file path=ppt/notesSlides/notesSlide15.xml><?xml version="1.0" encoding="utf-8"?>
-<p:notes xmlns:a="http://schemas.openxmlformats.org/drawingml/2006/main" xmlns:p="http://schemas.openxmlformats.org/presentationml/2006/main" xmlns:r="http://schemas.openxmlformats.org/officeDocument/2006/relationships">
+<p:notes xmlns:a="http://schemas.openxmlformats.org/drawingml/2006/main" xmlns:r="http://schemas.openxmlformats.org/officeDocument/2006/relationships" xmlns:p="http://schemas.openxmlformats.org/presentationml/2006/main">
   <p:cSld>
     <p:spTree>
       <p:nvGrpSpPr>
@@ -1308,7 +1327,7 @@
         <p:nvSpPr>
           <p:cNvPr id="2" name="Slide Image Placeholder 1"/>
           <p:cNvSpPr>
-            <a:spLocks noGrp="1"/>
+            <a:spLocks noGrp="1" noRot="1" noChangeAspect="1"/>
           </p:cNvSpPr>
           <p:nvPr>
             <p:ph type="sldImg" idx="2"/>
@@ -1323,7 +1342,7 @@
             <a:spLocks noGrp="1"/>
           </p:cNvSpPr>
           <p:nvPr>
-            <p:ph type="body" idx="3" sz="quarter"/>
+            <p:ph type="body" sz="quarter" idx="3"/>
           </p:nvPr>
         </p:nvSpPr>
         <p:spPr/>
@@ -1399,7 +1418,7 @@
             <a:spLocks noGrp="1"/>
           </p:cNvSpPr>
           <p:nvPr>
-            <p:ph type="sldNum" idx="5" sz="quarter"/>
+            <p:ph type="sldNum" sz="quarter" idx="5"/>
           </p:nvPr>
         </p:nvSpPr>
         <p:spPr/>
@@ -1413,7 +1432,7 @@
 </file>
 
 <file path=ppt/notesSlides/notesSlide16.xml><?xml version="1.0" encoding="utf-8"?>
-<p:notes xmlns:a="http://schemas.openxmlformats.org/drawingml/2006/main" xmlns:p="http://schemas.openxmlformats.org/presentationml/2006/main" xmlns:r="http://schemas.openxmlformats.org/officeDocument/2006/relationships">
+<p:notes xmlns:a="http://schemas.openxmlformats.org/drawingml/2006/main" xmlns:r="http://schemas.openxmlformats.org/officeDocument/2006/relationships" xmlns:p="http://schemas.openxmlformats.org/presentationml/2006/main">
   <p:cSld>
     <p:spTree>
       <p:nvGrpSpPr>
@@ -1433,7 +1452,7 @@
         <p:nvSpPr>
           <p:cNvPr id="2" name="Slide Image Placeholder 1"/>
           <p:cNvSpPr>
-            <a:spLocks noGrp="1"/>
+            <a:spLocks noGrp="1" noRot="1" noChangeAspect="1"/>
           </p:cNvSpPr>
           <p:nvPr>
             <p:ph type="sldImg" idx="2"/>
@@ -1448,7 +1467,7 @@
             <a:spLocks noGrp="1"/>
           </p:cNvSpPr>
           <p:nvPr>
-            <p:ph type="body" idx="3" sz="quarter"/>
+            <p:ph type="body" sz="quarter" idx="3"/>
           </p:nvPr>
         </p:nvSpPr>
         <p:spPr/>
@@ -1524,7 +1543,7 @@
             <a:spLocks noGrp="1"/>
           </p:cNvSpPr>
           <p:nvPr>
-            <p:ph type="sldNum" idx="5" sz="quarter"/>
+            <p:ph type="sldNum" sz="quarter" idx="5"/>
           </p:nvPr>
         </p:nvSpPr>
         <p:spPr/>
@@ -1538,7 +1557,7 @@
 </file>
 
 <file path=ppt/notesSlides/notesSlide17.xml><?xml version="1.0" encoding="utf-8"?>
-<p:notes xmlns:a="http://schemas.openxmlformats.org/drawingml/2006/main" xmlns:p="http://schemas.openxmlformats.org/presentationml/2006/main" xmlns:r="http://schemas.openxmlformats.org/officeDocument/2006/relationships">
+<p:notes xmlns:a="http://schemas.openxmlformats.org/drawingml/2006/main" xmlns:r="http://schemas.openxmlformats.org/officeDocument/2006/relationships" xmlns:p="http://schemas.openxmlformats.org/presentationml/2006/main">
   <p:cSld>
     <p:spTree>
       <p:nvGrpSpPr>
@@ -1558,7 +1577,7 @@
         <p:nvSpPr>
           <p:cNvPr id="2" name="Slide Image Placeholder 1"/>
           <p:cNvSpPr>
-            <a:spLocks noGrp="1"/>
+            <a:spLocks noGrp="1" noRot="1" noChangeAspect="1"/>
           </p:cNvSpPr>
           <p:nvPr>
             <p:ph type="sldImg" idx="2"/>
@@ -1573,7 +1592,7 @@
             <a:spLocks noGrp="1"/>
           </p:cNvSpPr>
           <p:nvPr>
-            <p:ph type="body" idx="3" sz="quarter"/>
+            <p:ph type="body" sz="quarter" idx="3"/>
           </p:nvPr>
         </p:nvSpPr>
         <p:spPr/>
@@ -1649,7 +1668,7 @@
             <a:spLocks noGrp="1"/>
           </p:cNvSpPr>
           <p:nvPr>
-            <p:ph type="sldNum" idx="5" sz="quarter"/>
+            <p:ph type="sldNum" sz="quarter" idx="5"/>
           </p:nvPr>
         </p:nvSpPr>
         <p:spPr/>
@@ -1663,7 +1682,7 @@
 </file>
 
 <file path=ppt/notesSlides/notesSlide18.xml><?xml version="1.0" encoding="utf-8"?>
-<p:notes xmlns:a="http://schemas.openxmlformats.org/drawingml/2006/main" xmlns:p="http://schemas.openxmlformats.org/presentationml/2006/main" xmlns:r="http://schemas.openxmlformats.org/officeDocument/2006/relationships">
+<p:notes xmlns:a="http://schemas.openxmlformats.org/drawingml/2006/main" xmlns:r="http://schemas.openxmlformats.org/officeDocument/2006/relationships" xmlns:p="http://schemas.openxmlformats.org/presentationml/2006/main">
   <p:cSld>
     <p:spTree>
       <p:nvGrpSpPr>
@@ -1683,7 +1702,7 @@
         <p:nvSpPr>
           <p:cNvPr id="2" name="Slide Image Placeholder 1"/>
           <p:cNvSpPr>
-            <a:spLocks noGrp="1"/>
+            <a:spLocks noGrp="1" noRot="1" noChangeAspect="1"/>
           </p:cNvSpPr>
           <p:nvPr>
             <p:ph type="sldImg" idx="2"/>
@@ -1698,7 +1717,7 @@
             <a:spLocks noGrp="1"/>
           </p:cNvSpPr>
           <p:nvPr>
-            <p:ph type="body" idx="3" sz="quarter"/>
+            <p:ph type="body" sz="quarter" idx="3"/>
           </p:nvPr>
         </p:nvSpPr>
         <p:spPr/>
@@ -1789,7 +1808,7 @@
             <a:spLocks noGrp="1"/>
           </p:cNvSpPr>
           <p:nvPr>
-            <p:ph type="sldNum" idx="5" sz="quarter"/>
+            <p:ph type="sldNum" sz="quarter" idx="5"/>
           </p:nvPr>
         </p:nvSpPr>
         <p:spPr/>
@@ -1803,7 +1822,7 @@
 </file>
 
 <file path=ppt/notesSlides/notesSlide2.xml><?xml version="1.0" encoding="utf-8"?>
-<p:notes xmlns:a="http://schemas.openxmlformats.org/drawingml/2006/main" xmlns:p="http://schemas.openxmlformats.org/presentationml/2006/main" xmlns:r="http://schemas.openxmlformats.org/officeDocument/2006/relationships">
+<p:notes xmlns:a="http://schemas.openxmlformats.org/drawingml/2006/main" xmlns:r="http://schemas.openxmlformats.org/officeDocument/2006/relationships" xmlns:p="http://schemas.openxmlformats.org/presentationml/2006/main">
   <p:cSld>
     <p:spTree>
       <p:nvGrpSpPr>
@@ -1823,7 +1842,7 @@
         <p:nvSpPr>
           <p:cNvPr id="2" name="Slide Image Placeholder 1"/>
           <p:cNvSpPr>
-            <a:spLocks noGrp="1"/>
+            <a:spLocks noGrp="1" noRot="1" noChangeAspect="1"/>
           </p:cNvSpPr>
           <p:nvPr>
             <p:ph type="sldImg" idx="2"/>
@@ -1838,7 +1857,7 @@
             <a:spLocks noGrp="1"/>
           </p:cNvSpPr>
           <p:nvPr>
-            <p:ph type="body" idx="3" sz="quarter"/>
+            <p:ph type="body" sz="quarter" idx="3"/>
           </p:nvPr>
         </p:nvSpPr>
         <p:spPr/>
@@ -1914,7 +1933,7 @@
             <a:spLocks noGrp="1"/>
           </p:cNvSpPr>
           <p:nvPr>
-            <p:ph type="sldNum" idx="5" sz="quarter"/>
+            <p:ph type="sldNum" sz="quarter" idx="5"/>
           </p:nvPr>
         </p:nvSpPr>
         <p:spPr/>
@@ -1928,7 +1947,7 @@
 </file>
 
 <file path=ppt/notesSlides/notesSlide3.xml><?xml version="1.0" encoding="utf-8"?>
-<p:notes xmlns:a="http://schemas.openxmlformats.org/drawingml/2006/main" xmlns:p="http://schemas.openxmlformats.org/presentationml/2006/main" xmlns:r="http://schemas.openxmlformats.org/officeDocument/2006/relationships">
+<p:notes xmlns:a="http://schemas.openxmlformats.org/drawingml/2006/main" xmlns:r="http://schemas.openxmlformats.org/officeDocument/2006/relationships" xmlns:p="http://schemas.openxmlformats.org/presentationml/2006/main">
   <p:cSld>
     <p:spTree>
       <p:nvGrpSpPr>
@@ -1948,7 +1967,7 @@
         <p:nvSpPr>
           <p:cNvPr id="2" name="Slide Image Placeholder 1"/>
           <p:cNvSpPr>
-            <a:spLocks noGrp="1"/>
+            <a:spLocks noGrp="1" noRot="1" noChangeAspect="1"/>
           </p:cNvSpPr>
           <p:nvPr>
             <p:ph type="sldImg" idx="2"/>
@@ -1963,7 +1982,7 @@
             <a:spLocks noGrp="1"/>
           </p:cNvSpPr>
           <p:nvPr>
-            <p:ph type="body" idx="3" sz="quarter"/>
+            <p:ph type="body" sz="quarter" idx="3"/>
           </p:nvPr>
         </p:nvSpPr>
         <p:spPr/>
@@ -2049,7 +2068,7 @@
             <a:spLocks noGrp="1"/>
           </p:cNvSpPr>
           <p:nvPr>
-            <p:ph type="sldNum" idx="5" sz="quarter"/>
+            <p:ph type="sldNum" sz="quarter" idx="5"/>
           </p:nvPr>
         </p:nvSpPr>
         <p:spPr/>
@@ -2063,7 +2082,7 @@
 </file>
 
 <file path=ppt/notesSlides/notesSlide4.xml><?xml version="1.0" encoding="utf-8"?>
-<p:notes xmlns:a="http://schemas.openxmlformats.org/drawingml/2006/main" xmlns:p="http://schemas.openxmlformats.org/presentationml/2006/main" xmlns:r="http://schemas.openxmlformats.org/officeDocument/2006/relationships">
+<p:notes xmlns:a="http://schemas.openxmlformats.org/drawingml/2006/main" xmlns:r="http://schemas.openxmlformats.org/officeDocument/2006/relationships" xmlns:p="http://schemas.openxmlformats.org/presentationml/2006/main">
   <p:cSld>
     <p:spTree>
       <p:nvGrpSpPr>
@@ -2083,7 +2102,7 @@
         <p:nvSpPr>
           <p:cNvPr id="2" name="Slide Image Placeholder 1"/>
           <p:cNvSpPr>
-            <a:spLocks noGrp="1"/>
+            <a:spLocks noGrp="1" noRot="1" noChangeAspect="1"/>
           </p:cNvSpPr>
           <p:nvPr>
             <p:ph type="sldImg" idx="2"/>
@@ -2098,7 +2117,7 @@
             <a:spLocks noGrp="1"/>
           </p:cNvSpPr>
           <p:nvPr>
-            <p:ph type="body" idx="3" sz="quarter"/>
+            <p:ph type="body" sz="quarter" idx="3"/>
           </p:nvPr>
         </p:nvSpPr>
         <p:spPr/>
@@ -2174,7 +2193,7 @@
             <a:spLocks noGrp="1"/>
           </p:cNvSpPr>
           <p:nvPr>
-            <p:ph type="sldNum" idx="5" sz="quarter"/>
+            <p:ph type="sldNum" sz="quarter" idx="5"/>
           </p:nvPr>
         </p:nvSpPr>
         <p:spPr/>
@@ -2188,7 +2207,7 @@
 </file>
 
 <file path=ppt/notesSlides/notesSlide5.xml><?xml version="1.0" encoding="utf-8"?>
-<p:notes xmlns:a="http://schemas.openxmlformats.org/drawingml/2006/main" xmlns:p="http://schemas.openxmlformats.org/presentationml/2006/main" xmlns:r="http://schemas.openxmlformats.org/officeDocument/2006/relationships">
+<p:notes xmlns:a="http://schemas.openxmlformats.org/drawingml/2006/main" xmlns:r="http://schemas.openxmlformats.org/officeDocument/2006/relationships" xmlns:p="http://schemas.openxmlformats.org/presentationml/2006/main">
   <p:cSld>
     <p:spTree>
       <p:nvGrpSpPr>
@@ -2208,7 +2227,7 @@
         <p:nvSpPr>
           <p:cNvPr id="2" name="Slide Image Placeholder 1"/>
           <p:cNvSpPr>
-            <a:spLocks noGrp="1"/>
+            <a:spLocks noGrp="1" noRot="1" noChangeAspect="1"/>
           </p:cNvSpPr>
           <p:nvPr>
             <p:ph type="sldImg" idx="2"/>
@@ -2223,7 +2242,7 @@
             <a:spLocks noGrp="1"/>
           </p:cNvSpPr>
           <p:nvPr>
-            <p:ph type="body" idx="3" sz="quarter"/>
+            <p:ph type="body" sz="quarter" idx="3"/>
           </p:nvPr>
         </p:nvSpPr>
         <p:spPr/>
@@ -2299,7 +2318,7 @@
             <a:spLocks noGrp="1"/>
           </p:cNvSpPr>
           <p:nvPr>
-            <p:ph type="sldNum" idx="5" sz="quarter"/>
+            <p:ph type="sldNum" sz="quarter" idx="5"/>
           </p:nvPr>
         </p:nvSpPr>
         <p:spPr/>
@@ -2313,7 +2332,7 @@
 </file>
 
 <file path=ppt/notesSlides/notesSlide6.xml><?xml version="1.0" encoding="utf-8"?>
-<p:notes xmlns:a="http://schemas.openxmlformats.org/drawingml/2006/main" xmlns:p="http://schemas.openxmlformats.org/presentationml/2006/main" xmlns:r="http://schemas.openxmlformats.org/officeDocument/2006/relationships">
+<p:notes xmlns:a="http://schemas.openxmlformats.org/drawingml/2006/main" xmlns:r="http://schemas.openxmlformats.org/officeDocument/2006/relationships" xmlns:p="http://schemas.openxmlformats.org/presentationml/2006/main">
   <p:cSld>
     <p:spTree>
       <p:nvGrpSpPr>
@@ -2333,7 +2352,7 @@
         <p:nvSpPr>
           <p:cNvPr id="2" name="Slide Image Placeholder 1"/>
           <p:cNvSpPr>
-            <a:spLocks noGrp="1"/>
+            <a:spLocks noGrp="1" noRot="1" noChangeAspect="1"/>
           </p:cNvSpPr>
           <p:nvPr>
             <p:ph type="sldImg" idx="2"/>
@@ -2348,7 +2367,7 @@
             <a:spLocks noGrp="1"/>
           </p:cNvSpPr>
           <p:nvPr>
-            <p:ph type="body" idx="3" sz="quarter"/>
+            <p:ph type="body" sz="quarter" idx="3"/>
           </p:nvPr>
         </p:nvSpPr>
         <p:spPr/>
@@ -2424,7 +2443,7 @@
             <a:spLocks noGrp="1"/>
           </p:cNvSpPr>
           <p:nvPr>
-            <p:ph type="sldNum" idx="5" sz="quarter"/>
+            <p:ph type="sldNum" sz="quarter" idx="5"/>
           </p:nvPr>
         </p:nvSpPr>
         <p:spPr/>
@@ -2438,7 +2457,7 @@
 </file>
 
 <file path=ppt/notesSlides/notesSlide7.xml><?xml version="1.0" encoding="utf-8"?>
-<p:notes xmlns:a="http://schemas.openxmlformats.org/drawingml/2006/main" xmlns:p="http://schemas.openxmlformats.org/presentationml/2006/main" xmlns:r="http://schemas.openxmlformats.org/officeDocument/2006/relationships">
+<p:notes xmlns:a="http://schemas.openxmlformats.org/drawingml/2006/main" xmlns:r="http://schemas.openxmlformats.org/officeDocument/2006/relationships" xmlns:p="http://schemas.openxmlformats.org/presentationml/2006/main">
   <p:cSld>
     <p:spTree>
       <p:nvGrpSpPr>
@@ -2458,7 +2477,7 @@
         <p:nvSpPr>
           <p:cNvPr id="2" name="Slide Image Placeholder 1"/>
           <p:cNvSpPr>
-            <a:spLocks noGrp="1"/>
+            <a:spLocks noGrp="1" noRot="1" noChangeAspect="1"/>
           </p:cNvSpPr>
           <p:nvPr>
             <p:ph type="sldImg" idx="2"/>
@@ -2473,7 +2492,7 @@
             <a:spLocks noGrp="1"/>
           </p:cNvSpPr>
           <p:nvPr>
-            <p:ph type="body" idx="3" sz="quarter"/>
+            <p:ph type="body" sz="quarter" idx="3"/>
           </p:nvPr>
         </p:nvSpPr>
         <p:spPr/>
@@ -2564,7 +2583,7 @@
             <a:spLocks noGrp="1"/>
           </p:cNvSpPr>
           <p:nvPr>
-            <p:ph type="sldNum" idx="5" sz="quarter"/>
+            <p:ph type="sldNum" sz="quarter" idx="5"/>
           </p:nvPr>
         </p:nvSpPr>
         <p:spPr/>
@@ -2578,7 +2597,7 @@
 </file>
 
 <file path=ppt/notesSlides/notesSlide8.xml><?xml version="1.0" encoding="utf-8"?>
-<p:notes xmlns:a="http://schemas.openxmlformats.org/drawingml/2006/main" xmlns:p="http://schemas.openxmlformats.org/presentationml/2006/main" xmlns:r="http://schemas.openxmlformats.org/officeDocument/2006/relationships">
+<p:notes xmlns:a="http://schemas.openxmlformats.org/drawingml/2006/main" xmlns:r="http://schemas.openxmlformats.org/officeDocument/2006/relationships" xmlns:p="http://schemas.openxmlformats.org/presentationml/2006/main">
   <p:cSld>
     <p:spTree>
       <p:nvGrpSpPr>
@@ -2598,7 +2617,7 @@
         <p:nvSpPr>
           <p:cNvPr id="2" name="Slide Image Placeholder 1"/>
           <p:cNvSpPr>
-            <a:spLocks noGrp="1"/>
+            <a:spLocks noGrp="1" noRot="1" noChangeAspect="1"/>
           </p:cNvSpPr>
           <p:nvPr>
             <p:ph type="sldImg" idx="2"/>
@@ -2613,7 +2632,7 @@
             <a:spLocks noGrp="1"/>
           </p:cNvSpPr>
           <p:nvPr>
-            <p:ph type="body" idx="3" sz="quarter"/>
+            <p:ph type="body" sz="quarter" idx="3"/>
           </p:nvPr>
         </p:nvSpPr>
         <p:spPr/>
@@ -2689,7 +2708,7 @@
             <a:spLocks noGrp="1"/>
           </p:cNvSpPr>
           <p:nvPr>
-            <p:ph type="sldNum" idx="5" sz="quarter"/>
+            <p:ph type="sldNum" sz="quarter" idx="5"/>
           </p:nvPr>
         </p:nvSpPr>
         <p:spPr/>
@@ -2703,7 +2722,7 @@
 </file>
 
 <file path=ppt/notesSlides/notesSlide9.xml><?xml version="1.0" encoding="utf-8"?>
-<p:notes xmlns:a="http://schemas.openxmlformats.org/drawingml/2006/main" xmlns:p="http://schemas.openxmlformats.org/presentationml/2006/main" xmlns:r="http://schemas.openxmlformats.org/officeDocument/2006/relationships">
+<p:notes xmlns:a="http://schemas.openxmlformats.org/drawingml/2006/main" xmlns:r="http://schemas.openxmlformats.org/officeDocument/2006/relationships" xmlns:p="http://schemas.openxmlformats.org/presentationml/2006/main">
   <p:cSld>
     <p:spTree>
       <p:nvGrpSpPr>
@@ -2723,7 +2742,7 @@
         <p:nvSpPr>
           <p:cNvPr id="2" name="Slide Image Placeholder 1"/>
           <p:cNvSpPr>
-            <a:spLocks noGrp="1"/>
+            <a:spLocks noGrp="1" noRot="1" noChangeAspect="1"/>
           </p:cNvSpPr>
           <p:nvPr>
             <p:ph type="sldImg" idx="2"/>
@@ -2738,7 +2757,7 @@
             <a:spLocks noGrp="1"/>
           </p:cNvSpPr>
           <p:nvPr>
-            <p:ph type="body" idx="3" sz="quarter"/>
+            <p:ph type="body" sz="quarter" idx="3"/>
           </p:nvPr>
         </p:nvSpPr>
         <p:spPr/>
@@ -2814,7 +2833,7 @@
             <a:spLocks noGrp="1"/>
           </p:cNvSpPr>
           <p:nvPr>
-            <p:ph type="sldNum" idx="5" sz="quarter"/>
+            <p:ph type="sldNum" sz="quarter" idx="5"/>
           </p:nvPr>
         </p:nvSpPr>
         <p:spPr/>
@@ -2865,10 +2884,9 @@
           <a:lstStyle/>
           <a:p>
             <a:r>
-              <a:rPr lang="en-US" smtClean="0"/>
+              <a:rPr lang="en-US"/>
               <a:t>Click to edit Master title style</a:t>
             </a:r>
-            <a:endParaRPr lang="en-US"/>
           </a:p>
         </p:txBody>
       </p:sp>
@@ -2984,10 +3002,9 @@
           </a:lstStyle>
           <a:p>
             <a:r>
-              <a:rPr lang="en-US" smtClean="0"/>
+              <a:rPr lang="en-US"/>
               <a:t>Click to edit Master subtitle style</a:t>
             </a:r>
-            <a:endParaRPr lang="en-US"/>
           </a:p>
         </p:txBody>
       </p:sp>
@@ -3008,7 +3025,7 @@
           <a:p>
             <a:fld id="{5BCAD085-E8A6-8845-BD4E-CB4CCA059FC4}" type="datetimeFigureOut">
               <a:rPr lang="en-US" smtClean="0"/>
-              <a:t>1/27/13</a:t>
+              <a:t>7/16/26</a:t>
             </a:fld>
             <a:endParaRPr lang="en-US"/>
           </a:p>
@@ -3102,10 +3119,9 @@
           <a:lstStyle/>
           <a:p>
             <a:r>
-              <a:rPr lang="en-US" smtClean="0"/>
+              <a:rPr lang="en-US"/>
               <a:t>Click to edit Master title style</a:t>
             </a:r>
-            <a:endParaRPr lang="en-US"/>
           </a:p>
         </p:txBody>
       </p:sp>
@@ -3126,38 +3142,37 @@
           <a:p>
             <a:pPr lvl="0"/>
             <a:r>
-              <a:rPr lang="en-US" smtClean="0"/>
+              <a:rPr lang="en-US"/>
               <a:t>Click to edit Master text styles</a:t>
             </a:r>
           </a:p>
           <a:p>
             <a:pPr lvl="1"/>
             <a:r>
-              <a:rPr lang="en-US" smtClean="0"/>
+              <a:rPr lang="en-US"/>
               <a:t>Second level</a:t>
             </a:r>
           </a:p>
           <a:p>
             <a:pPr lvl="2"/>
             <a:r>
-              <a:rPr lang="en-US" smtClean="0"/>
+              <a:rPr lang="en-US"/>
               <a:t>Third level</a:t>
             </a:r>
           </a:p>
           <a:p>
             <a:pPr lvl="3"/>
             <a:r>
-              <a:rPr lang="en-US" smtClean="0"/>
+              <a:rPr lang="en-US"/>
               <a:t>Fourth level</a:t>
             </a:r>
           </a:p>
           <a:p>
             <a:pPr lvl="4"/>
             <a:r>
-              <a:rPr lang="en-US" smtClean="0"/>
+              <a:rPr lang="en-US"/>
               <a:t>Fifth level</a:t>
             </a:r>
-            <a:endParaRPr lang="en-US"/>
           </a:p>
         </p:txBody>
       </p:sp>
@@ -3178,7 +3193,7 @@
           <a:p>
             <a:fld id="{5BCAD085-E8A6-8845-BD4E-CB4CCA059FC4}" type="datetimeFigureOut">
               <a:rPr lang="en-US" smtClean="0"/>
-              <a:t>1/27/13</a:t>
+              <a:t>7/16/26</a:t>
             </a:fld>
             <a:endParaRPr lang="en-US"/>
           </a:p>
@@ -3277,10 +3292,9 @@
           <a:lstStyle/>
           <a:p>
             <a:r>
-              <a:rPr lang="en-US" smtClean="0"/>
+              <a:rPr lang="en-US"/>
               <a:t>Click to edit Master title style</a:t>
             </a:r>
-            <a:endParaRPr lang="en-US"/>
           </a:p>
         </p:txBody>
       </p:sp>
@@ -3306,38 +3320,37 @@
           <a:p>
             <a:pPr lvl="0"/>
             <a:r>
-              <a:rPr lang="en-US" smtClean="0"/>
+              <a:rPr lang="en-US"/>
               <a:t>Click to edit Master text styles</a:t>
             </a:r>
           </a:p>
           <a:p>
             <a:pPr lvl="1"/>
             <a:r>
-              <a:rPr lang="en-US" smtClean="0"/>
+              <a:rPr lang="en-US"/>
               <a:t>Second level</a:t>
             </a:r>
           </a:p>
           <a:p>
             <a:pPr lvl="2"/>
             <a:r>
-              <a:rPr lang="en-US" smtClean="0"/>
+              <a:rPr lang="en-US"/>
               <a:t>Third level</a:t>
             </a:r>
           </a:p>
           <a:p>
             <a:pPr lvl="3"/>
             <a:r>
-              <a:rPr lang="en-US" smtClean="0"/>
+              <a:rPr lang="en-US"/>
               <a:t>Fourth level</a:t>
             </a:r>
           </a:p>
           <a:p>
             <a:pPr lvl="4"/>
             <a:r>
-              <a:rPr lang="en-US" smtClean="0"/>
+              <a:rPr lang="en-US"/>
               <a:t>Fifth level</a:t>
             </a:r>
-            <a:endParaRPr lang="en-US"/>
           </a:p>
         </p:txBody>
       </p:sp>
@@ -3358,7 +3371,7 @@
           <a:p>
             <a:fld id="{5BCAD085-E8A6-8845-BD4E-CB4CCA059FC4}" type="datetimeFigureOut">
               <a:rPr lang="en-US" smtClean="0"/>
-              <a:t>1/27/13</a:t>
+              <a:t>7/16/26</a:t>
             </a:fld>
             <a:endParaRPr lang="en-US"/>
           </a:p>
@@ -3452,10 +3465,9 @@
           <a:lstStyle/>
           <a:p>
             <a:r>
-              <a:rPr lang="en-US" smtClean="0"/>
+              <a:rPr lang="en-US"/>
               <a:t>Click to edit Master title style</a:t>
             </a:r>
-            <a:endParaRPr lang="en-US"/>
           </a:p>
         </p:txBody>
       </p:sp>
@@ -3476,38 +3488,37 @@
           <a:p>
             <a:pPr lvl="0"/>
             <a:r>
-              <a:rPr lang="en-US" smtClean="0"/>
+              <a:rPr lang="en-US"/>
               <a:t>Click to edit Master text styles</a:t>
             </a:r>
           </a:p>
           <a:p>
             <a:pPr lvl="1"/>
             <a:r>
-              <a:rPr lang="en-US" smtClean="0"/>
+              <a:rPr lang="en-US"/>
               <a:t>Second level</a:t>
             </a:r>
           </a:p>
           <a:p>
             <a:pPr lvl="2"/>
             <a:r>
-              <a:rPr lang="en-US" smtClean="0"/>
+              <a:rPr lang="en-US"/>
               <a:t>Third level</a:t>
             </a:r>
           </a:p>
           <a:p>
             <a:pPr lvl="3"/>
             <a:r>
-              <a:rPr lang="en-US" smtClean="0"/>
+              <a:rPr lang="en-US"/>
               <a:t>Fourth level</a:t>
             </a:r>
           </a:p>
           <a:p>
             <a:pPr lvl="4"/>
             <a:r>
-              <a:rPr lang="en-US" smtClean="0"/>
+              <a:rPr lang="en-US"/>
               <a:t>Fifth level</a:t>
             </a:r>
-            <a:endParaRPr lang="en-US"/>
           </a:p>
         </p:txBody>
       </p:sp>
@@ -3528,7 +3539,7 @@
           <a:p>
             <a:fld id="{5BCAD085-E8A6-8845-BD4E-CB4CCA059FC4}" type="datetimeFigureOut">
               <a:rPr lang="en-US" smtClean="0"/>
-              <a:t>1/27/13</a:t>
+              <a:t>7/16/26</a:t>
             </a:fld>
             <a:endParaRPr lang="en-US"/>
           </a:p>
@@ -3631,10 +3642,9 @@
           </a:lstStyle>
           <a:p>
             <a:r>
-              <a:rPr lang="en-US" smtClean="0"/>
+              <a:rPr lang="en-US"/>
               <a:t>Click to edit Master title style</a:t>
             </a:r>
-            <a:endParaRPr lang="en-US"/>
           </a:p>
         </p:txBody>
       </p:sp>
@@ -3751,7 +3761,7 @@
           <a:p>
             <a:pPr lvl="0"/>
             <a:r>
-              <a:rPr lang="en-US" smtClean="0"/>
+              <a:rPr lang="en-US"/>
               <a:t>Click to edit Master text styles</a:t>
             </a:r>
           </a:p>
@@ -3774,7 +3784,7 @@
           <a:p>
             <a:fld id="{5BCAD085-E8A6-8845-BD4E-CB4CCA059FC4}" type="datetimeFigureOut">
               <a:rPr lang="en-US" smtClean="0"/>
-              <a:t>1/27/13</a:t>
+              <a:t>7/16/26</a:t>
             </a:fld>
             <a:endParaRPr lang="en-US"/>
           </a:p>
@@ -3868,10 +3878,9 @@
           <a:lstStyle/>
           <a:p>
             <a:r>
-              <a:rPr lang="en-US" smtClean="0"/>
+              <a:rPr lang="en-US"/>
               <a:t>Click to edit Master title style</a:t>
             </a:r>
-            <a:endParaRPr lang="en-US"/>
           </a:p>
         </p:txBody>
       </p:sp>
@@ -3925,38 +3934,37 @@
           <a:p>
             <a:pPr lvl="0"/>
             <a:r>
-              <a:rPr lang="en-US" smtClean="0"/>
+              <a:rPr lang="en-US"/>
               <a:t>Click to edit Master text styles</a:t>
             </a:r>
           </a:p>
           <a:p>
             <a:pPr lvl="1"/>
             <a:r>
-              <a:rPr lang="en-US" smtClean="0"/>
+              <a:rPr lang="en-US"/>
               <a:t>Second level</a:t>
             </a:r>
           </a:p>
           <a:p>
             <a:pPr lvl="2"/>
             <a:r>
-              <a:rPr lang="en-US" smtClean="0"/>
+              <a:rPr lang="en-US"/>
               <a:t>Third level</a:t>
             </a:r>
           </a:p>
           <a:p>
             <a:pPr lvl="3"/>
             <a:r>
-              <a:rPr lang="en-US" smtClean="0"/>
+              <a:rPr lang="en-US"/>
               <a:t>Fourth level</a:t>
             </a:r>
           </a:p>
           <a:p>
             <a:pPr lvl="4"/>
             <a:r>
-              <a:rPr lang="en-US" smtClean="0"/>
+              <a:rPr lang="en-US"/>
               <a:t>Fifth level</a:t>
             </a:r>
-            <a:endParaRPr lang="en-US"/>
           </a:p>
         </p:txBody>
       </p:sp>
@@ -4010,38 +4018,37 @@
           <a:p>
             <a:pPr lvl="0"/>
             <a:r>
-              <a:rPr lang="en-US" smtClean="0"/>
+              <a:rPr lang="en-US"/>
               <a:t>Click to edit Master text styles</a:t>
             </a:r>
           </a:p>
           <a:p>
             <a:pPr lvl="1"/>
             <a:r>
-              <a:rPr lang="en-US" smtClean="0"/>
+              <a:rPr lang="en-US"/>
               <a:t>Second level</a:t>
             </a:r>
           </a:p>
           <a:p>
             <a:pPr lvl="2"/>
             <a:r>
-              <a:rPr lang="en-US" smtClean="0"/>
+              <a:rPr lang="en-US"/>
               <a:t>Third level</a:t>
             </a:r>
           </a:p>
           <a:p>
             <a:pPr lvl="3"/>
             <a:r>
-              <a:rPr lang="en-US" smtClean="0"/>
+              <a:rPr lang="en-US"/>
               <a:t>Fourth level</a:t>
             </a:r>
           </a:p>
           <a:p>
             <a:pPr lvl="4"/>
             <a:r>
-              <a:rPr lang="en-US" smtClean="0"/>
+              <a:rPr lang="en-US"/>
               <a:t>Fifth level</a:t>
             </a:r>
-            <a:endParaRPr lang="en-US"/>
           </a:p>
         </p:txBody>
       </p:sp>
@@ -4062,7 +4069,7 @@
           <a:p>
             <a:fld id="{5BCAD085-E8A6-8845-BD4E-CB4CCA059FC4}" type="datetimeFigureOut">
               <a:rPr lang="en-US" smtClean="0"/>
-              <a:t>1/27/13</a:t>
+              <a:t>7/16/26</a:t>
             </a:fld>
             <a:endParaRPr lang="en-US"/>
           </a:p>
@@ -4160,10 +4167,9 @@
           </a:lstStyle>
           <a:p>
             <a:r>
-              <a:rPr lang="en-US" smtClean="0"/>
+              <a:rPr lang="en-US"/>
               <a:t>Click to edit Master title style</a:t>
             </a:r>
-            <a:endParaRPr lang="en-US"/>
           </a:p>
         </p:txBody>
       </p:sp>
@@ -4226,7 +4232,7 @@
           <a:p>
             <a:pPr lvl="0"/>
             <a:r>
-              <a:rPr lang="en-US" smtClean="0"/>
+              <a:rPr lang="en-US"/>
               <a:t>Click to edit Master text styles</a:t>
             </a:r>
           </a:p>
@@ -4282,38 +4288,37 @@
           <a:p>
             <a:pPr lvl="0"/>
             <a:r>
-              <a:rPr lang="en-US" smtClean="0"/>
+              <a:rPr lang="en-US"/>
               <a:t>Click to edit Master text styles</a:t>
             </a:r>
           </a:p>
           <a:p>
             <a:pPr lvl="1"/>
             <a:r>
-              <a:rPr lang="en-US" smtClean="0"/>
+              <a:rPr lang="en-US"/>
               <a:t>Second level</a:t>
             </a:r>
           </a:p>
           <a:p>
             <a:pPr lvl="2"/>
             <a:r>
-              <a:rPr lang="en-US" smtClean="0"/>
+              <a:rPr lang="en-US"/>
               <a:t>Third level</a:t>
             </a:r>
           </a:p>
           <a:p>
             <a:pPr lvl="3"/>
             <a:r>
-              <a:rPr lang="en-US" smtClean="0"/>
+              <a:rPr lang="en-US"/>
               <a:t>Fourth level</a:t>
             </a:r>
           </a:p>
           <a:p>
             <a:pPr lvl="4"/>
             <a:r>
-              <a:rPr lang="en-US" smtClean="0"/>
+              <a:rPr lang="en-US"/>
               <a:t>Fifth level</a:t>
             </a:r>
-            <a:endParaRPr lang="en-US"/>
           </a:p>
         </p:txBody>
       </p:sp>
@@ -4376,7 +4381,7 @@
           <a:p>
             <a:pPr lvl="0"/>
             <a:r>
-              <a:rPr lang="en-US" smtClean="0"/>
+              <a:rPr lang="en-US"/>
               <a:t>Click to edit Master text styles</a:t>
             </a:r>
           </a:p>
@@ -4432,38 +4437,37 @@
           <a:p>
             <a:pPr lvl="0"/>
             <a:r>
-              <a:rPr lang="en-US" smtClean="0"/>
+              <a:rPr lang="en-US"/>
               <a:t>Click to edit Master text styles</a:t>
             </a:r>
           </a:p>
           <a:p>
             <a:pPr lvl="1"/>
             <a:r>
-              <a:rPr lang="en-US" smtClean="0"/>
+              <a:rPr lang="en-US"/>
               <a:t>Second level</a:t>
             </a:r>
           </a:p>
           <a:p>
             <a:pPr lvl="2"/>
             <a:r>
-              <a:rPr lang="en-US" smtClean="0"/>
+              <a:rPr lang="en-US"/>
               <a:t>Third level</a:t>
             </a:r>
           </a:p>
           <a:p>
             <a:pPr lvl="3"/>
             <a:r>
-              <a:rPr lang="en-US" smtClean="0"/>
+              <a:rPr lang="en-US"/>
               <a:t>Fourth level</a:t>
             </a:r>
           </a:p>
           <a:p>
             <a:pPr lvl="4"/>
             <a:r>
-              <a:rPr lang="en-US" smtClean="0"/>
+              <a:rPr lang="en-US"/>
               <a:t>Fifth level</a:t>
             </a:r>
-            <a:endParaRPr lang="en-US"/>
           </a:p>
         </p:txBody>
       </p:sp>
@@ -4484,7 +4488,7 @@
           <a:p>
             <a:fld id="{5BCAD085-E8A6-8845-BD4E-CB4CCA059FC4}" type="datetimeFigureOut">
               <a:rPr lang="en-US" smtClean="0"/>
-              <a:t>1/27/13</a:t>
+              <a:t>7/16/26</a:t>
             </a:fld>
             <a:endParaRPr lang="en-US"/>
           </a:p>
@@ -4578,10 +4582,9 @@
           <a:lstStyle/>
           <a:p>
             <a:r>
-              <a:rPr lang="en-US" smtClean="0"/>
+              <a:rPr lang="en-US"/>
               <a:t>Click to edit Master title style</a:t>
             </a:r>
-            <a:endParaRPr lang="en-US"/>
           </a:p>
         </p:txBody>
       </p:sp>
@@ -4602,7 +4605,7 @@
           <a:p>
             <a:fld id="{5BCAD085-E8A6-8845-BD4E-CB4CCA059FC4}" type="datetimeFigureOut">
               <a:rPr lang="en-US" smtClean="0"/>
-              <a:t>1/27/13</a:t>
+              <a:t>7/16/26</a:t>
             </a:fld>
             <a:endParaRPr lang="en-US"/>
           </a:p>
@@ -4697,7 +4700,7 @@
           <a:p>
             <a:fld id="{5BCAD085-E8A6-8845-BD4E-CB4CCA059FC4}" type="datetimeFigureOut">
               <a:rPr lang="en-US" smtClean="0"/>
-              <a:t>1/27/13</a:t>
+              <a:t>7/16/26</a:t>
             </a:fld>
             <a:endParaRPr lang="en-US"/>
           </a:p>
@@ -4800,10 +4803,9 @@
           </a:lstStyle>
           <a:p>
             <a:r>
-              <a:rPr lang="en-US" smtClean="0"/>
+              <a:rPr lang="en-US"/>
               <a:t>Click to edit Master title style</a:t>
             </a:r>
-            <a:endParaRPr lang="en-US"/>
           </a:p>
         </p:txBody>
       </p:sp>
@@ -4857,38 +4859,37 @@
           <a:p>
             <a:pPr lvl="0"/>
             <a:r>
-              <a:rPr lang="en-US" smtClean="0"/>
+              <a:rPr lang="en-US"/>
               <a:t>Click to edit Master text styles</a:t>
             </a:r>
           </a:p>
           <a:p>
             <a:pPr lvl="1"/>
             <a:r>
-              <a:rPr lang="en-US" smtClean="0"/>
+              <a:rPr lang="en-US"/>
               <a:t>Second level</a:t>
             </a:r>
           </a:p>
           <a:p>
             <a:pPr lvl="2"/>
             <a:r>
-              <a:rPr lang="en-US" smtClean="0"/>
+              <a:rPr lang="en-US"/>
               <a:t>Third level</a:t>
             </a:r>
           </a:p>
           <a:p>
             <a:pPr lvl="3"/>
             <a:r>
-              <a:rPr lang="en-US" smtClean="0"/>
+              <a:rPr lang="en-US"/>
               <a:t>Fourth level</a:t>
             </a:r>
           </a:p>
           <a:p>
             <a:pPr lvl="4"/>
             <a:r>
-              <a:rPr lang="en-US" smtClean="0"/>
+              <a:rPr lang="en-US"/>
               <a:t>Fifth level</a:t>
             </a:r>
-            <a:endParaRPr lang="en-US"/>
           </a:p>
         </p:txBody>
       </p:sp>
@@ -4951,7 +4952,7 @@
           <a:p>
             <a:pPr lvl="0"/>
             <a:r>
-              <a:rPr lang="en-US" smtClean="0"/>
+              <a:rPr lang="en-US"/>
               <a:t>Click to edit Master text styles</a:t>
             </a:r>
           </a:p>
@@ -4974,7 +4975,7 @@
           <a:p>
             <a:fld id="{5BCAD085-E8A6-8845-BD4E-CB4CCA059FC4}" type="datetimeFigureOut">
               <a:rPr lang="en-US" smtClean="0"/>
-              <a:t>1/27/13</a:t>
+              <a:t>7/16/26</a:t>
             </a:fld>
             <a:endParaRPr lang="en-US"/>
           </a:p>
@@ -5077,10 +5078,9 @@
           </a:lstStyle>
           <a:p>
             <a:r>
-              <a:rPr lang="en-US" smtClean="0"/>
+              <a:rPr lang="en-US"/>
               <a:t>Click to edit Master title style</a:t>
             </a:r>
-            <a:endParaRPr lang="en-US"/>
           </a:p>
         </p:txBody>
       </p:sp>
@@ -5204,7 +5204,7 @@
           <a:p>
             <a:pPr lvl="0"/>
             <a:r>
-              <a:rPr lang="en-US" smtClean="0"/>
+              <a:rPr lang="en-US"/>
               <a:t>Click to edit Master text styles</a:t>
             </a:r>
           </a:p>
@@ -5227,7 +5227,7 @@
           <a:p>
             <a:fld id="{5BCAD085-E8A6-8845-BD4E-CB4CCA059FC4}" type="datetimeFigureOut">
               <a:rPr lang="en-US" smtClean="0"/>
-              <a:t>1/27/13</a:t>
+              <a:t>7/16/26</a:t>
             </a:fld>
             <a:endParaRPr lang="en-US"/>
           </a:p>
@@ -5336,10 +5336,9 @@
           <a:lstStyle/>
           <a:p>
             <a:r>
-              <a:rPr lang="en-US" smtClean="0"/>
+              <a:rPr lang="en-US"/>
               <a:t>Click to edit Master title style</a:t>
             </a:r>
-            <a:endParaRPr lang="en-US"/>
           </a:p>
         </p:txBody>
       </p:sp>
@@ -5370,38 +5369,37 @@
           <a:p>
             <a:pPr lvl="0"/>
             <a:r>
-              <a:rPr lang="en-US" smtClean="0"/>
+              <a:rPr lang="en-US"/>
               <a:t>Click to edit Master text styles</a:t>
             </a:r>
           </a:p>
           <a:p>
             <a:pPr lvl="1"/>
             <a:r>
-              <a:rPr lang="en-US" smtClean="0"/>
+              <a:rPr lang="en-US"/>
               <a:t>Second level</a:t>
             </a:r>
           </a:p>
           <a:p>
             <a:pPr lvl="2"/>
             <a:r>
-              <a:rPr lang="en-US" smtClean="0"/>
+              <a:rPr lang="en-US"/>
               <a:t>Third level</a:t>
             </a:r>
           </a:p>
           <a:p>
             <a:pPr lvl="3"/>
             <a:r>
-              <a:rPr lang="en-US" smtClean="0"/>
+              <a:rPr lang="en-US"/>
               <a:t>Fourth level</a:t>
             </a:r>
           </a:p>
           <a:p>
             <a:pPr lvl="4"/>
             <a:r>
-              <a:rPr lang="en-US" smtClean="0"/>
+              <a:rPr lang="en-US"/>
               <a:t>Fifth level</a:t>
             </a:r>
-            <a:endParaRPr lang="en-US"/>
           </a:p>
         </p:txBody>
       </p:sp>
@@ -5440,7 +5438,7 @@
           <a:p>
             <a:fld id="{5BCAD085-E8A6-8845-BD4E-CB4CCA059FC4}" type="datetimeFigureOut">
               <a:rPr lang="en-US" smtClean="0"/>
-              <a:t>1/27/13</a:t>
+              <a:t>7/16/26</a:t>
             </a:fld>
             <a:endParaRPr lang="en-US"/>
           </a:p>
@@ -5799,7 +5797,7 @@
 </file>
 
 <file path=ppt/slides/slide1.xml><?xml version="1.0" encoding="utf-8"?>
-<p:sld xmlns:a="http://schemas.openxmlformats.org/drawingml/2006/main" xmlns:p="http://schemas.openxmlformats.org/presentationml/2006/main" xmlns:r="http://schemas.openxmlformats.org/officeDocument/2006/relationships">
+<p:sld xmlns:a="http://schemas.openxmlformats.org/drawingml/2006/main" xmlns:r="http://schemas.openxmlformats.org/officeDocument/2006/relationships" xmlns:p="http://schemas.openxmlformats.org/presentationml/2006/main">
   <p:cSld>
     <p:bg>
       <p:bgPr>
@@ -5815,7 +5813,14 @@
         <p:cNvGrpSpPr/>
         <p:nvPr/>
       </p:nvGrpSpPr>
-      <p:grpSpPr/>
+      <p:grpSpPr>
+        <a:xfrm>
+          <a:off x="0" y="0"/>
+          <a:ext cx="0" cy="0"/>
+          <a:chOff x="0" y="0"/>
+          <a:chExt cx="0" cy="0"/>
+        </a:xfrm>
+      </p:grpSpPr>
       <p:sp>
         <p:nvSpPr>
           <p:cNvPr id="2" name="Rectangle 1"/>
@@ -5857,6 +5862,7 @@
           <a:lstStyle/>
           <a:p>
             <a:pPr algn="ctr"/>
+            <a:endParaRPr/>
           </a:p>
         </p:txBody>
       </p:sp>
@@ -5877,7 +5883,7 @@
           <a:noFill/>
         </p:spPr>
         <p:txBody>
-          <a:bodyPr wrap="square" anchor="t" lIns="0" rIns="0" tIns="0" bIns="0">
+          <a:bodyPr wrap="square" lIns="0" tIns="0" rIns="0" bIns="0" anchor="t">
             <a:spAutoFit/>
           </a:bodyPr>
           <a:lstStyle/>
@@ -5943,7 +5949,7 @@
           <a:noFill/>
         </p:spPr>
         <p:txBody>
-          <a:bodyPr wrap="square" anchor="t" lIns="0" rIns="0" tIns="0" bIns="0">
+          <a:bodyPr wrap="square" lIns="0" tIns="0" rIns="0" bIns="0" anchor="t">
             <a:spAutoFit/>
           </a:bodyPr>
           <a:lstStyle/>
@@ -5978,7 +5984,7 @@
 </file>
 
 <file path=ppt/slides/slide10.xml><?xml version="1.0" encoding="utf-8"?>
-<p:sld xmlns:a="http://schemas.openxmlformats.org/drawingml/2006/main" xmlns:p="http://schemas.openxmlformats.org/presentationml/2006/main" xmlns:r="http://schemas.openxmlformats.org/officeDocument/2006/relationships">
+<p:sld xmlns:a="http://schemas.openxmlformats.org/drawingml/2006/main" xmlns:r="http://schemas.openxmlformats.org/officeDocument/2006/relationships" xmlns:p="http://schemas.openxmlformats.org/presentationml/2006/main">
   <p:cSld>
     <p:bg>
       <p:bgPr>
@@ -5994,7 +6000,14 @@
         <p:cNvGrpSpPr/>
         <p:nvPr/>
       </p:nvGrpSpPr>
-      <p:grpSpPr/>
+      <p:grpSpPr>
+        <a:xfrm>
+          <a:off x="0" y="0"/>
+          <a:ext cx="0" cy="0"/>
+          <a:chOff x="0" y="0"/>
+          <a:chExt cx="0" cy="0"/>
+        </a:xfrm>
+      </p:grpSpPr>
       <p:sp>
         <p:nvSpPr>
           <p:cNvPr id="2" name="TextBox 1"/>
@@ -6012,7 +6025,7 @@
           <a:noFill/>
         </p:spPr>
         <p:txBody>
-          <a:bodyPr wrap="square" anchor="t" lIns="0" rIns="0" tIns="0" bIns="0">
+          <a:bodyPr wrap="square" lIns="0" tIns="0" rIns="0" bIns="0" anchor="t">
             <a:spAutoFit/>
           </a:bodyPr>
           <a:lstStyle/>
@@ -6086,6 +6099,7 @@
           <a:lstStyle/>
           <a:p>
             <a:pPr algn="ctr"/>
+            <a:endParaRPr/>
           </a:p>
         </p:txBody>
       </p:sp>
@@ -6132,6 +6146,7 @@
           <a:lstStyle/>
           <a:p>
             <a:pPr algn="ctr"/>
+            <a:endParaRPr/>
           </a:p>
         </p:txBody>
       </p:sp>
@@ -6176,6 +6191,7 @@
           <a:lstStyle/>
           <a:p>
             <a:pPr algn="ctr"/>
+            <a:endParaRPr/>
           </a:p>
         </p:txBody>
       </p:sp>
@@ -6196,7 +6212,7 @@
           <a:noFill/>
         </p:spPr>
         <p:txBody>
-          <a:bodyPr wrap="square" anchor="ctr" lIns="0" rIns="0" tIns="0" bIns="0">
+          <a:bodyPr wrap="square" lIns="0" tIns="0" rIns="0" bIns="0" anchor="ctr">
             <a:spAutoFit/>
           </a:bodyPr>
           <a:lstStyle/>
@@ -6261,6 +6277,7 @@
           <a:lstStyle/>
           <a:p>
             <a:pPr algn="ctr"/>
+            <a:endParaRPr/>
           </a:p>
         </p:txBody>
       </p:sp>
@@ -6305,6 +6322,7 @@
           <a:lstStyle/>
           <a:p>
             <a:pPr algn="ctr"/>
+            <a:endParaRPr/>
           </a:p>
         </p:txBody>
       </p:sp>
@@ -6325,7 +6343,7 @@
           <a:noFill/>
         </p:spPr>
         <p:txBody>
-          <a:bodyPr wrap="square" anchor="ctr" lIns="0" rIns="0" tIns="0" bIns="0">
+          <a:bodyPr wrap="square" lIns="0" tIns="0" rIns="0" bIns="0" anchor="ctr">
             <a:spAutoFit/>
           </a:bodyPr>
           <a:lstStyle/>
@@ -6390,6 +6408,7 @@
           <a:lstStyle/>
           <a:p>
             <a:pPr algn="ctr"/>
+            <a:endParaRPr/>
           </a:p>
         </p:txBody>
       </p:sp>
@@ -6434,6 +6453,7 @@
           <a:lstStyle/>
           <a:p>
             <a:pPr algn="ctr"/>
+            <a:endParaRPr/>
           </a:p>
         </p:txBody>
       </p:sp>
@@ -6454,7 +6474,7 @@
           <a:noFill/>
         </p:spPr>
         <p:txBody>
-          <a:bodyPr wrap="square" anchor="ctr" lIns="0" rIns="0" tIns="0" bIns="0">
+          <a:bodyPr wrap="square" lIns="0" tIns="0" rIns="0" bIns="0" anchor="ctr">
             <a:spAutoFit/>
           </a:bodyPr>
           <a:lstStyle/>
@@ -6519,6 +6539,7 @@
           <a:lstStyle/>
           <a:p>
             <a:pPr algn="ctr"/>
+            <a:endParaRPr/>
           </a:p>
         </p:txBody>
       </p:sp>
@@ -6563,6 +6584,7 @@
           <a:lstStyle/>
           <a:p>
             <a:pPr algn="ctr"/>
+            <a:endParaRPr/>
           </a:p>
         </p:txBody>
       </p:sp>
@@ -6583,7 +6605,7 @@
           <a:noFill/>
         </p:spPr>
         <p:txBody>
-          <a:bodyPr wrap="square" anchor="ctr" lIns="0" rIns="0" tIns="0" bIns="0">
+          <a:bodyPr wrap="square" lIns="0" tIns="0" rIns="0" bIns="0" anchor="ctr">
             <a:spAutoFit/>
           </a:bodyPr>
           <a:lstStyle/>
@@ -6646,6 +6668,7 @@
           <a:lstStyle/>
           <a:p>
             <a:pPr algn="ctr"/>
+            <a:endParaRPr/>
           </a:p>
         </p:txBody>
       </p:sp>
@@ -6666,7 +6689,7 @@
           <a:noFill/>
         </p:spPr>
         <p:txBody>
-          <a:bodyPr wrap="square" anchor="t" lIns="0" rIns="0" tIns="0" bIns="0">
+          <a:bodyPr wrap="square" lIns="0" tIns="0" rIns="0" bIns="0" anchor="t">
             <a:spAutoFit/>
           </a:bodyPr>
           <a:lstStyle/>
@@ -6709,7 +6732,7 @@
           <a:noFill/>
         </p:spPr>
         <p:txBody>
-          <a:bodyPr wrap="square" anchor="t" lIns="0" rIns="0" tIns="0" bIns="0">
+          <a:bodyPr wrap="square" lIns="0" tIns="0" rIns="0" bIns="0" anchor="t">
             <a:spAutoFit/>
           </a:bodyPr>
           <a:lstStyle/>
@@ -6736,7 +6759,7 @@
 </file>
 
 <file path=ppt/slides/slide11.xml><?xml version="1.0" encoding="utf-8"?>
-<p:sld xmlns:a="http://schemas.openxmlformats.org/drawingml/2006/main" xmlns:p="http://schemas.openxmlformats.org/presentationml/2006/main" xmlns:r="http://schemas.openxmlformats.org/officeDocument/2006/relationships">
+<p:sld xmlns:a="http://schemas.openxmlformats.org/drawingml/2006/main" xmlns:r="http://schemas.openxmlformats.org/officeDocument/2006/relationships" xmlns:p="http://schemas.openxmlformats.org/presentationml/2006/main">
   <p:cSld>
     <p:bg>
       <p:bgPr>
@@ -6752,7 +6775,14 @@
         <p:cNvGrpSpPr/>
         <p:nvPr/>
       </p:nvGrpSpPr>
-      <p:grpSpPr/>
+      <p:grpSpPr>
+        <a:xfrm>
+          <a:off x="0" y="0"/>
+          <a:ext cx="0" cy="0"/>
+          <a:chOff x="0" y="0"/>
+          <a:chExt cx="0" cy="0"/>
+        </a:xfrm>
+      </p:grpSpPr>
       <p:sp>
         <p:nvSpPr>
           <p:cNvPr id="2" name="Rectangle 1"/>
@@ -6794,6 +6824,7 @@
           <a:lstStyle/>
           <a:p>
             <a:pPr algn="ctr"/>
+            <a:endParaRPr/>
           </a:p>
         </p:txBody>
       </p:sp>
@@ -6814,7 +6845,7 @@
           <a:noFill/>
         </p:spPr>
         <p:txBody>
-          <a:bodyPr wrap="square" anchor="t" lIns="0" rIns="0" tIns="0" bIns="0">
+          <a:bodyPr wrap="square" lIns="0" tIns="0" rIns="0" bIns="0" anchor="t">
             <a:spAutoFit/>
           </a:bodyPr>
           <a:lstStyle/>
@@ -6848,7 +6879,7 @@
           <a:noFill/>
         </p:spPr>
         <p:txBody>
-          <a:bodyPr wrap="square" anchor="t" lIns="0" rIns="0" tIns="0" bIns="0">
+          <a:bodyPr wrap="square" lIns="0" tIns="0" rIns="0" bIns="0" anchor="t">
             <a:spAutoFit/>
           </a:bodyPr>
           <a:lstStyle/>
@@ -6938,6 +6969,7 @@
           <a:lstStyle/>
           <a:p>
             <a:pPr algn="ctr"/>
+            <a:endParaRPr/>
           </a:p>
         </p:txBody>
       </p:sp>
@@ -6958,7 +6990,7 @@
           <a:noFill/>
         </p:spPr>
         <p:txBody>
-          <a:bodyPr wrap="square" anchor="t" lIns="0" rIns="0" tIns="0" bIns="0">
+          <a:bodyPr wrap="square" lIns="0" tIns="0" rIns="0" bIns="0" anchor="t">
             <a:spAutoFit/>
           </a:bodyPr>
           <a:lstStyle/>
@@ -7001,21 +7033,13 @@
           <a:noFill/>
         </p:spPr>
         <p:txBody>
-          <a:bodyPr wrap="square" anchor="t" lIns="0" rIns="0" tIns="0" bIns="0">
+          <a:bodyPr wrap="square" lIns="0" tIns="0" rIns="0" bIns="0" anchor="t">
             <a:spAutoFit/>
           </a:bodyPr>
           <a:lstStyle/>
           <a:p>
             <a:pPr algn="r"/>
-            <a:r>
-              <a:rPr sz="1100" b="0" i="0">
-                <a:solidFill>
-                  <a:srgbClr val="7A7A7A"/>
-                </a:solidFill>
-                <a:latin typeface="Roboto"/>
-              </a:rPr>
-              <a:t/>
-            </a:r>
+            <a:endParaRPr/>
           </a:p>
         </p:txBody>
       </p:sp>
@@ -7028,7 +7052,7 @@
 </file>
 
 <file path=ppt/slides/slide12.xml><?xml version="1.0" encoding="utf-8"?>
-<p:sld xmlns:a="http://schemas.openxmlformats.org/drawingml/2006/main" xmlns:p="http://schemas.openxmlformats.org/presentationml/2006/main" xmlns:r="http://schemas.openxmlformats.org/officeDocument/2006/relationships">
+<p:sld xmlns:a="http://schemas.openxmlformats.org/drawingml/2006/main" xmlns:r="http://schemas.openxmlformats.org/officeDocument/2006/relationships" xmlns:p="http://schemas.openxmlformats.org/presentationml/2006/main">
   <p:cSld>
     <p:bg>
       <p:bgPr>
@@ -7044,7 +7068,14 @@
         <p:cNvGrpSpPr/>
         <p:nvPr/>
       </p:nvGrpSpPr>
-      <p:grpSpPr/>
+      <p:grpSpPr>
+        <a:xfrm>
+          <a:off x="0" y="0"/>
+          <a:ext cx="0" cy="0"/>
+          <a:chOff x="0" y="0"/>
+          <a:chExt cx="0" cy="0"/>
+        </a:xfrm>
+      </p:grpSpPr>
       <p:sp>
         <p:nvSpPr>
           <p:cNvPr id="2" name="TextBox 1"/>
@@ -7062,7 +7093,7 @@
           <a:noFill/>
         </p:spPr>
         <p:txBody>
-          <a:bodyPr wrap="square" anchor="t" lIns="0" rIns="0" tIns="0" bIns="0">
+          <a:bodyPr wrap="square" lIns="0" tIns="0" rIns="0" bIns="0" anchor="t">
             <a:spAutoFit/>
           </a:bodyPr>
           <a:lstStyle/>
@@ -7120,6 +7151,7 @@
           <a:lstStyle/>
           <a:p>
             <a:pPr algn="ctr"/>
+            <a:endParaRPr/>
           </a:p>
         </p:txBody>
       </p:sp>
@@ -7140,7 +7172,7 @@
           <a:noFill/>
         </p:spPr>
         <p:txBody>
-          <a:bodyPr wrap="square" anchor="ctr" lIns="0" rIns="0" tIns="0" bIns="0">
+          <a:bodyPr wrap="square" lIns="0" tIns="0" rIns="0" bIns="0" anchor="ctr">
             <a:spAutoFit/>
           </a:bodyPr>
           <a:lstStyle/>
@@ -7280,6 +7312,7 @@
           <a:lstStyle/>
           <a:p>
             <a:pPr algn="ctr"/>
+            <a:endParaRPr/>
           </a:p>
         </p:txBody>
       </p:sp>
@@ -7300,7 +7333,7 @@
           <a:noFill/>
         </p:spPr>
         <p:txBody>
-          <a:bodyPr wrap="square" anchor="t" lIns="0" rIns="0" tIns="0" bIns="0">
+          <a:bodyPr wrap="square" lIns="0" tIns="0" rIns="0" bIns="0" anchor="t">
             <a:spAutoFit/>
           </a:bodyPr>
           <a:lstStyle/>
@@ -7343,7 +7376,7 @@
           <a:noFill/>
         </p:spPr>
         <p:txBody>
-          <a:bodyPr wrap="square" anchor="t" lIns="0" rIns="0" tIns="0" bIns="0">
+          <a:bodyPr wrap="square" lIns="0" tIns="0" rIns="0" bIns="0" anchor="t">
             <a:spAutoFit/>
           </a:bodyPr>
           <a:lstStyle/>
@@ -7370,7 +7403,7 @@
 </file>
 
 <file path=ppt/slides/slide13.xml><?xml version="1.0" encoding="utf-8"?>
-<p:sld xmlns:a="http://schemas.openxmlformats.org/drawingml/2006/main" xmlns:p="http://schemas.openxmlformats.org/presentationml/2006/main" xmlns:r="http://schemas.openxmlformats.org/officeDocument/2006/relationships">
+<p:sld xmlns:a="http://schemas.openxmlformats.org/drawingml/2006/main" xmlns:r="http://schemas.openxmlformats.org/officeDocument/2006/relationships" xmlns:p="http://schemas.openxmlformats.org/presentationml/2006/main">
   <p:cSld>
     <p:bg>
       <p:bgPr>
@@ -7386,7 +7419,14 @@
         <p:cNvGrpSpPr/>
         <p:nvPr/>
       </p:nvGrpSpPr>
-      <p:grpSpPr/>
+      <p:grpSpPr>
+        <a:xfrm>
+          <a:off x="0" y="0"/>
+          <a:ext cx="0" cy="0"/>
+          <a:chOff x="0" y="0"/>
+          <a:chExt cx="0" cy="0"/>
+        </a:xfrm>
+      </p:grpSpPr>
       <p:sp>
         <p:nvSpPr>
           <p:cNvPr id="2" name="TextBox 1"/>
@@ -7404,7 +7444,7 @@
           <a:noFill/>
         </p:spPr>
         <p:txBody>
-          <a:bodyPr wrap="square" anchor="t" lIns="0" rIns="0" tIns="0" bIns="0">
+          <a:bodyPr wrap="square" lIns="0" tIns="0" rIns="0" bIns="0" anchor="t">
             <a:spAutoFit/>
           </a:bodyPr>
           <a:lstStyle/>
@@ -7478,6 +7518,7 @@
           <a:lstStyle/>
           <a:p>
             <a:pPr algn="ctr"/>
+            <a:endParaRPr/>
           </a:p>
         </p:txBody>
       </p:sp>
@@ -7498,7 +7539,7 @@
           <a:noFill/>
         </p:spPr>
         <p:txBody>
-          <a:bodyPr wrap="square" anchor="ctr" lIns="0" rIns="0" tIns="0" bIns="0">
+          <a:bodyPr wrap="square" lIns="0" tIns="0" rIns="0" bIns="0" anchor="ctr">
             <a:spAutoFit/>
           </a:bodyPr>
           <a:lstStyle/>
@@ -7669,6 +7710,7 @@
           <a:lstStyle/>
           <a:p>
             <a:pPr algn="ctr"/>
+            <a:endParaRPr/>
           </a:p>
         </p:txBody>
       </p:sp>
@@ -7689,7 +7731,7 @@
           <a:noFill/>
         </p:spPr>
         <p:txBody>
-          <a:bodyPr wrap="square" anchor="t" lIns="0" rIns="0" tIns="0" bIns="0">
+          <a:bodyPr wrap="square" lIns="0" tIns="0" rIns="0" bIns="0" anchor="t">
             <a:spAutoFit/>
           </a:bodyPr>
           <a:lstStyle/>
@@ -7732,7 +7774,7 @@
           <a:noFill/>
         </p:spPr>
         <p:txBody>
-          <a:bodyPr wrap="square" anchor="t" lIns="0" rIns="0" tIns="0" bIns="0">
+          <a:bodyPr wrap="square" lIns="0" tIns="0" rIns="0" bIns="0" anchor="t">
             <a:spAutoFit/>
           </a:bodyPr>
           <a:lstStyle/>
@@ -7759,7 +7801,7 @@
 </file>
 
 <file path=ppt/slides/slide14.xml><?xml version="1.0" encoding="utf-8"?>
-<p:sld xmlns:a="http://schemas.openxmlformats.org/drawingml/2006/main" xmlns:p="http://schemas.openxmlformats.org/presentationml/2006/main" xmlns:r="http://schemas.openxmlformats.org/officeDocument/2006/relationships">
+<p:sld xmlns:a="http://schemas.openxmlformats.org/drawingml/2006/main" xmlns:r="http://schemas.openxmlformats.org/officeDocument/2006/relationships" xmlns:p="http://schemas.openxmlformats.org/presentationml/2006/main">
   <p:cSld>
     <p:bg>
       <p:bgPr>
@@ -7775,7 +7817,14 @@
         <p:cNvGrpSpPr/>
         <p:nvPr/>
       </p:nvGrpSpPr>
-      <p:grpSpPr/>
+      <p:grpSpPr>
+        <a:xfrm>
+          <a:off x="0" y="0"/>
+          <a:ext cx="0" cy="0"/>
+          <a:chOff x="0" y="0"/>
+          <a:chExt cx="0" cy="0"/>
+        </a:xfrm>
+      </p:grpSpPr>
       <p:sp>
         <p:nvSpPr>
           <p:cNvPr id="2" name="TextBox 1"/>
@@ -7793,7 +7842,7 @@
           <a:noFill/>
         </p:spPr>
         <p:txBody>
-          <a:bodyPr wrap="square" anchor="t" lIns="0" rIns="0" tIns="0" bIns="0">
+          <a:bodyPr wrap="square" lIns="0" tIns="0" rIns="0" bIns="0" anchor="t">
             <a:spAutoFit/>
           </a:bodyPr>
           <a:lstStyle/>
@@ -7851,6 +7900,7 @@
           <a:lstStyle/>
           <a:p>
             <a:pPr algn="ctr"/>
+            <a:endParaRPr/>
           </a:p>
         </p:txBody>
       </p:sp>
@@ -7871,7 +7921,7 @@
           <a:noFill/>
         </p:spPr>
         <p:txBody>
-          <a:bodyPr wrap="square" anchor="ctr" lIns="0" rIns="0" tIns="0" bIns="0">
+          <a:bodyPr wrap="square" lIns="0" tIns="0" rIns="0" bIns="0" anchor="ctr">
             <a:spAutoFit/>
           </a:bodyPr>
           <a:lstStyle/>
@@ -8011,6 +8061,7 @@
           <a:lstStyle/>
           <a:p>
             <a:pPr algn="ctr"/>
+            <a:endParaRPr/>
           </a:p>
         </p:txBody>
       </p:sp>
@@ -8031,7 +8082,7 @@
           <a:noFill/>
         </p:spPr>
         <p:txBody>
-          <a:bodyPr wrap="square" anchor="t" lIns="0" rIns="0" tIns="0" bIns="0">
+          <a:bodyPr wrap="square" lIns="0" tIns="0" rIns="0" bIns="0" anchor="t">
             <a:spAutoFit/>
           </a:bodyPr>
           <a:lstStyle/>
@@ -8074,7 +8125,7 @@
           <a:noFill/>
         </p:spPr>
         <p:txBody>
-          <a:bodyPr wrap="square" anchor="t" lIns="0" rIns="0" tIns="0" bIns="0">
+          <a:bodyPr wrap="square" lIns="0" tIns="0" rIns="0" bIns="0" anchor="t">
             <a:spAutoFit/>
           </a:bodyPr>
           <a:lstStyle/>
@@ -8101,7 +8152,7 @@
 </file>
 
 <file path=ppt/slides/slide15.xml><?xml version="1.0" encoding="utf-8"?>
-<p:sld xmlns:a="http://schemas.openxmlformats.org/drawingml/2006/main" xmlns:p="http://schemas.openxmlformats.org/presentationml/2006/main" xmlns:r="http://schemas.openxmlformats.org/officeDocument/2006/relationships">
+<p:sld xmlns:a="http://schemas.openxmlformats.org/drawingml/2006/main" xmlns:r="http://schemas.openxmlformats.org/officeDocument/2006/relationships" xmlns:p="http://schemas.openxmlformats.org/presentationml/2006/main">
   <p:cSld>
     <p:bg>
       <p:bgPr>
@@ -8117,7 +8168,14 @@
         <p:cNvGrpSpPr/>
         <p:nvPr/>
       </p:nvGrpSpPr>
-      <p:grpSpPr/>
+      <p:grpSpPr>
+        <a:xfrm>
+          <a:off x="0" y="0"/>
+          <a:ext cx="0" cy="0"/>
+          <a:chOff x="0" y="0"/>
+          <a:chExt cx="0" cy="0"/>
+        </a:xfrm>
+      </p:grpSpPr>
       <p:sp>
         <p:nvSpPr>
           <p:cNvPr id="2" name="TextBox 1"/>
@@ -8135,7 +8193,7 @@
           <a:noFill/>
         </p:spPr>
         <p:txBody>
-          <a:bodyPr wrap="square" anchor="t" lIns="0" rIns="0" tIns="0" bIns="0">
+          <a:bodyPr wrap="square" lIns="0" tIns="0" rIns="0" bIns="0" anchor="t">
             <a:spAutoFit/>
           </a:bodyPr>
           <a:lstStyle/>
@@ -8209,6 +8267,7 @@
           <a:lstStyle/>
           <a:p>
             <a:pPr algn="ctr"/>
+            <a:endParaRPr/>
           </a:p>
         </p:txBody>
       </p:sp>
@@ -8221,7 +8280,7 @@
         <p:spPr>
           <a:xfrm>
             <a:off x="658368" y="1737360"/>
-            <a:ext cx="5486400" cy="4297680"/>
+            <a:ext cx="5486400" cy="2691058"/>
           </a:xfrm>
           <a:prstGeom prst="rect">
             <a:avLst/>
@@ -8229,7 +8288,7 @@
           <a:noFill/>
         </p:spPr>
         <p:txBody>
-          <a:bodyPr wrap="square" anchor="t" lIns="0" rIns="0" tIns="0" bIns="0">
+          <a:bodyPr wrap="square" lIns="0" tIns="0" rIns="0" bIns="0" anchor="t">
             <a:spAutoFit/>
           </a:bodyPr>
           <a:lstStyle/>
@@ -8246,7 +8305,7 @@
               </a:spcAft>
             </a:pPr>
             <a:r>
-              <a:rPr sz="1700" b="1" i="0">
+              <a:rPr sz="2400" b="1" i="0" dirty="0">
                 <a:solidFill>
                   <a:srgbClr val="EDAB0C"/>
                 </a:solidFill>
@@ -8255,7 +8314,7 @@
               <a:t>■  </a:t>
             </a:r>
             <a:r>
-              <a:rPr sz="1700" b="0" i="0">
+              <a:rPr sz="2400" b="0" i="0" dirty="0">
                 <a:solidFill>
                   <a:srgbClr val="2A2929"/>
                 </a:solidFill>
@@ -8277,7 +8336,7 @@
               </a:spcAft>
             </a:pPr>
             <a:r>
-              <a:rPr sz="1400" b="0" i="0">
+              <a:rPr sz="2000" b="0" i="0" dirty="0">
                 <a:solidFill>
                   <a:srgbClr val="7A7A7A"/>
                 </a:solidFill>
@@ -8286,7 +8345,7 @@
               <a:t>–  </a:t>
             </a:r>
             <a:r>
-              <a:rPr sz="1400" b="0" i="0">
+              <a:rPr sz="2000" b="0" i="0" dirty="0">
                 <a:solidFill>
                   <a:srgbClr val="2A2929"/>
                 </a:solidFill>
@@ -8308,7 +8367,7 @@
               </a:spcAft>
             </a:pPr>
             <a:r>
-              <a:rPr sz="1400" b="0" i="0">
+              <a:rPr sz="2000" b="0" i="0" dirty="0">
                 <a:solidFill>
                   <a:srgbClr val="7A7A7A"/>
                 </a:solidFill>
@@ -8317,7 +8376,7 @@
               <a:t>–  </a:t>
             </a:r>
             <a:r>
-              <a:rPr sz="1400" b="0" i="0">
+              <a:rPr sz="2000" b="0" i="0" dirty="0">
                 <a:solidFill>
                   <a:srgbClr val="2A2929"/>
                 </a:solidFill>
@@ -8339,7 +8398,7 @@
               </a:spcAft>
             </a:pPr>
             <a:r>
-              <a:rPr sz="1400" b="0" i="0">
+              <a:rPr sz="2000" b="0" i="0" dirty="0">
                 <a:solidFill>
                   <a:srgbClr val="7A7A7A"/>
                 </a:solidFill>
@@ -8348,7 +8407,7 @@
               <a:t>–  </a:t>
             </a:r>
             <a:r>
-              <a:rPr sz="1400" b="0" i="0">
+              <a:rPr sz="2000" b="0" i="0" dirty="0">
                 <a:solidFill>
                   <a:srgbClr val="2A2929"/>
                 </a:solidFill>
@@ -8370,7 +8429,7 @@
               </a:spcAft>
             </a:pPr>
             <a:r>
-              <a:rPr sz="1700" b="1" i="0">
+              <a:rPr sz="2400" b="1" i="0" dirty="0">
                 <a:solidFill>
                   <a:srgbClr val="EDAB0C"/>
                 </a:solidFill>
@@ -8379,7 +8438,7 @@
               <a:t>■  </a:t>
             </a:r>
             <a:r>
-              <a:rPr sz="1700" b="0" i="0">
+              <a:rPr sz="2400" b="0" i="0" dirty="0" err="1">
                 <a:solidFill>
                   <a:srgbClr val="2A2929"/>
                 </a:solidFill>
@@ -8387,6 +8446,12 @@
               </a:rPr>
               <a:t>calculator.aws</a:t>
             </a:r>
+            <a:endParaRPr sz="2400" b="0" i="0" dirty="0">
+              <a:solidFill>
+                <a:srgbClr val="2A2929"/>
+              </a:solidFill>
+              <a:latin typeface="Roboto"/>
+            </a:endParaRPr>
           </a:p>
         </p:txBody>
       </p:sp>
@@ -8399,7 +8464,7 @@
           <p:nvPr/>
         </p:nvPicPr>
         <p:blipFill>
-          <a:blip r:embed="rId2"/>
+          <a:blip r:embed="rId3"/>
           <a:stretch>
             <a:fillRect/>
           </a:stretch>
@@ -8455,6 +8520,7 @@
           <a:lstStyle/>
           <a:p>
             <a:pPr algn="ctr"/>
+            <a:endParaRPr/>
           </a:p>
         </p:txBody>
       </p:sp>
@@ -8475,7 +8541,7 @@
           <a:noFill/>
         </p:spPr>
         <p:txBody>
-          <a:bodyPr wrap="square" anchor="t" lIns="0" rIns="0" tIns="0" bIns="0">
+          <a:bodyPr wrap="square" lIns="0" tIns="0" rIns="0" bIns="0" anchor="t">
             <a:spAutoFit/>
           </a:bodyPr>
           <a:lstStyle/>
@@ -8518,7 +8584,7 @@
           <a:noFill/>
         </p:spPr>
         <p:txBody>
-          <a:bodyPr wrap="square" anchor="t" lIns="0" rIns="0" tIns="0" bIns="0">
+          <a:bodyPr wrap="square" lIns="0" tIns="0" rIns="0" bIns="0" anchor="t">
             <a:spAutoFit/>
           </a:bodyPr>
           <a:lstStyle/>
@@ -8545,7 +8611,7 @@
 </file>
 
 <file path=ppt/slides/slide16.xml><?xml version="1.0" encoding="utf-8"?>
-<p:sld xmlns:a="http://schemas.openxmlformats.org/drawingml/2006/main" xmlns:p="http://schemas.openxmlformats.org/presentationml/2006/main" xmlns:r="http://schemas.openxmlformats.org/officeDocument/2006/relationships">
+<p:sld xmlns:a="http://schemas.openxmlformats.org/drawingml/2006/main" xmlns:r="http://schemas.openxmlformats.org/officeDocument/2006/relationships" xmlns:p="http://schemas.openxmlformats.org/presentationml/2006/main">
   <p:cSld>
     <p:bg>
       <p:bgPr>
@@ -8561,7 +8627,14 @@
         <p:cNvGrpSpPr/>
         <p:nvPr/>
       </p:nvGrpSpPr>
-      <p:grpSpPr/>
+      <p:grpSpPr>
+        <a:xfrm>
+          <a:off x="0" y="0"/>
+          <a:ext cx="0" cy="0"/>
+          <a:chOff x="0" y="0"/>
+          <a:chExt cx="0" cy="0"/>
+        </a:xfrm>
+      </p:grpSpPr>
       <p:sp>
         <p:nvSpPr>
           <p:cNvPr id="2" name="Rectangle 1"/>
@@ -8603,6 +8676,7 @@
           <a:lstStyle/>
           <a:p>
             <a:pPr algn="ctr"/>
+            <a:endParaRPr/>
           </a:p>
         </p:txBody>
       </p:sp>
@@ -8676,7 +8750,7 @@
           <a:noFill/>
         </p:spPr>
         <p:txBody>
-          <a:bodyPr wrap="square" anchor="ctr" lIns="0" rIns="0" tIns="0" bIns="0">
+          <a:bodyPr wrap="square" lIns="0" tIns="0" rIns="0" bIns="0" anchor="ctr">
             <a:spAutoFit/>
           </a:bodyPr>
           <a:lstStyle/>
@@ -8702,7 +8776,7 @@
         <p:spPr>
           <a:xfrm>
             <a:off x="658368" y="1554480"/>
-            <a:ext cx="10881360" cy="4297680"/>
+            <a:ext cx="10881360" cy="3054939"/>
           </a:xfrm>
           <a:prstGeom prst="rect">
             <a:avLst/>
@@ -8710,7 +8784,7 @@
           <a:noFill/>
         </p:spPr>
         <p:txBody>
-          <a:bodyPr wrap="square" anchor="t" lIns="0" rIns="0" tIns="0" bIns="0">
+          <a:bodyPr wrap="square" lIns="0" tIns="0" rIns="0" bIns="0" anchor="t">
             <a:spAutoFit/>
           </a:bodyPr>
           <a:lstStyle/>
@@ -8727,7 +8801,7 @@
               </a:spcAft>
             </a:pPr>
             <a:r>
-              <a:rPr sz="1700" b="1" i="0">
+              <a:rPr sz="2000" b="1" i="0" dirty="0">
                 <a:solidFill>
                   <a:srgbClr val="EDAB0C"/>
                 </a:solidFill>
@@ -8736,7 +8810,7 @@
               <a:t>■  </a:t>
             </a:r>
             <a:r>
-              <a:rPr sz="1700" b="0" i="0">
+              <a:rPr sz="2000" b="0" i="0" dirty="0">
                 <a:solidFill>
                   <a:srgbClr val="2A2929"/>
                 </a:solidFill>
@@ -8758,7 +8832,7 @@
               </a:spcAft>
             </a:pPr>
             <a:r>
-              <a:rPr sz="1700" b="1" i="0">
+              <a:rPr sz="2000" b="1" i="0" dirty="0">
                 <a:solidFill>
                   <a:srgbClr val="EDAB0C"/>
                 </a:solidFill>
@@ -8767,7 +8841,7 @@
               <a:t>■  </a:t>
             </a:r>
             <a:r>
-              <a:rPr sz="1700" b="0" i="0">
+              <a:rPr sz="2000" b="0" i="0" dirty="0">
                 <a:solidFill>
                   <a:srgbClr val="2A2929"/>
                 </a:solidFill>
@@ -8789,7 +8863,7 @@
               </a:spcAft>
             </a:pPr>
             <a:r>
-              <a:rPr sz="1400" b="0" i="0">
+              <a:rPr b="0" i="0" dirty="0">
                 <a:solidFill>
                   <a:srgbClr val="7A7A7A"/>
                 </a:solidFill>
@@ -8798,7 +8872,7 @@
               <a:t>–  </a:t>
             </a:r>
             <a:r>
-              <a:rPr sz="1400" b="0" i="0">
+              <a:rPr b="0" i="0" dirty="0">
                 <a:solidFill>
                   <a:srgbClr val="2A2929"/>
                 </a:solidFill>
@@ -8820,7 +8894,7 @@
               </a:spcAft>
             </a:pPr>
             <a:r>
-              <a:rPr sz="1400" b="0" i="0">
+              <a:rPr b="0" i="0" dirty="0">
                 <a:solidFill>
                   <a:srgbClr val="7A7A7A"/>
                 </a:solidFill>
@@ -8829,7 +8903,7 @@
               <a:t>–  </a:t>
             </a:r>
             <a:r>
-              <a:rPr sz="1400" b="0" i="0">
+              <a:rPr b="0" i="0" dirty="0">
                 <a:solidFill>
                   <a:srgbClr val="2A2929"/>
                 </a:solidFill>
@@ -8851,7 +8925,7 @@
               </a:spcAft>
             </a:pPr>
             <a:r>
-              <a:rPr sz="1400" b="0" i="0">
+              <a:rPr b="0" i="0" dirty="0">
                 <a:solidFill>
                   <a:srgbClr val="7A7A7A"/>
                 </a:solidFill>
@@ -8860,7 +8934,7 @@
               <a:t>–  </a:t>
             </a:r>
             <a:r>
-              <a:rPr sz="1400" b="0" i="0">
+              <a:rPr b="0" i="0" dirty="0">
                 <a:solidFill>
                   <a:srgbClr val="2A2929"/>
                 </a:solidFill>
@@ -8882,7 +8956,7 @@
               </a:spcAft>
             </a:pPr>
             <a:r>
-              <a:rPr sz="1700" b="1" i="0">
+              <a:rPr sz="2000" b="1" i="0" dirty="0">
                 <a:solidFill>
                   <a:srgbClr val="EDAB0C"/>
                 </a:solidFill>
@@ -8891,7 +8965,7 @@
               <a:t>■  </a:t>
             </a:r>
             <a:r>
-              <a:rPr sz="1700" b="0" i="0">
+              <a:rPr sz="2000" b="0" i="0" dirty="0">
                 <a:solidFill>
                   <a:srgbClr val="2A2929"/>
                 </a:solidFill>
@@ -8913,7 +8987,7 @@
               </a:spcAft>
             </a:pPr>
             <a:r>
-              <a:rPr sz="1700" b="1" i="0">
+              <a:rPr sz="2000" b="1" i="0" dirty="0">
                 <a:solidFill>
                   <a:srgbClr val="EDAB0C"/>
                 </a:solidFill>
@@ -8922,14 +8996,29 @@
               <a:t>■  </a:t>
             </a:r>
             <a:r>
-              <a:rPr sz="1700" b="0" i="0">
+              <a:rPr sz="2000" b="0" i="0" dirty="0">
                 <a:solidFill>
                   <a:srgbClr val="2A2929"/>
                 </a:solidFill>
                 <a:latin typeface="Roboto"/>
               </a:rPr>
-              <a:t>🔗  calculator.aws</a:t>
-            </a:r>
+              <a:t>🔗  </a:t>
+            </a:r>
+            <a:r>
+              <a:rPr sz="2000" b="0" i="0" dirty="0" err="1">
+                <a:solidFill>
+                  <a:srgbClr val="2A2929"/>
+                </a:solidFill>
+                <a:latin typeface="Roboto"/>
+              </a:rPr>
+              <a:t>calculator.aws</a:t>
+            </a:r>
+            <a:endParaRPr sz="2000" b="0" i="0" dirty="0">
+              <a:solidFill>
+                <a:srgbClr val="2A2929"/>
+              </a:solidFill>
+              <a:latin typeface="Roboto"/>
+            </a:endParaRPr>
           </a:p>
         </p:txBody>
       </p:sp>
@@ -8976,6 +9065,7 @@
           <a:lstStyle/>
           <a:p>
             <a:pPr algn="ctr"/>
+            <a:endParaRPr/>
           </a:p>
         </p:txBody>
       </p:sp>
@@ -8996,7 +9086,7 @@
           <a:noFill/>
         </p:spPr>
         <p:txBody>
-          <a:bodyPr wrap="square" anchor="ctr" lIns="0" rIns="0" tIns="0" bIns="0">
+          <a:bodyPr wrap="square" lIns="0" tIns="0" rIns="0" bIns="0" anchor="ctr">
             <a:spAutoFit/>
           </a:bodyPr>
           <a:lstStyle/>
@@ -9054,6 +9144,7 @@
           <a:lstStyle/>
           <a:p>
             <a:pPr algn="ctr"/>
+            <a:endParaRPr/>
           </a:p>
         </p:txBody>
       </p:sp>
@@ -9074,7 +9165,7 @@
           <a:noFill/>
         </p:spPr>
         <p:txBody>
-          <a:bodyPr wrap="square" anchor="t" lIns="0" rIns="0" tIns="0" bIns="0">
+          <a:bodyPr wrap="square" lIns="0" tIns="0" rIns="0" bIns="0" anchor="t">
             <a:spAutoFit/>
           </a:bodyPr>
           <a:lstStyle/>
@@ -9117,7 +9208,7 @@
           <a:noFill/>
         </p:spPr>
         <p:txBody>
-          <a:bodyPr wrap="square" anchor="t" lIns="0" rIns="0" tIns="0" bIns="0">
+          <a:bodyPr wrap="square" lIns="0" tIns="0" rIns="0" bIns="0" anchor="t">
             <a:spAutoFit/>
           </a:bodyPr>
           <a:lstStyle/>
@@ -9144,7 +9235,7 @@
 </file>
 
 <file path=ppt/slides/slide17.xml><?xml version="1.0" encoding="utf-8"?>
-<p:sld xmlns:a="http://schemas.openxmlformats.org/drawingml/2006/main" xmlns:p="http://schemas.openxmlformats.org/presentationml/2006/main" xmlns:r="http://schemas.openxmlformats.org/officeDocument/2006/relationships">
+<p:sld xmlns:a="http://schemas.openxmlformats.org/drawingml/2006/main" xmlns:r="http://schemas.openxmlformats.org/officeDocument/2006/relationships" xmlns:p="http://schemas.openxmlformats.org/presentationml/2006/main">
   <p:cSld>
     <p:bg>
       <p:bgPr>
@@ -9160,7 +9251,14 @@
         <p:cNvGrpSpPr/>
         <p:nvPr/>
       </p:nvGrpSpPr>
-      <p:grpSpPr/>
+      <p:grpSpPr>
+        <a:xfrm>
+          <a:off x="0" y="0"/>
+          <a:ext cx="0" cy="0"/>
+          <a:chOff x="0" y="0"/>
+          <a:chExt cx="0" cy="0"/>
+        </a:xfrm>
+      </p:grpSpPr>
       <p:sp>
         <p:nvSpPr>
           <p:cNvPr id="2" name="TextBox 1"/>
@@ -9178,7 +9276,7 @@
           <a:noFill/>
         </p:spPr>
         <p:txBody>
-          <a:bodyPr wrap="square" anchor="t" lIns="0" rIns="0" tIns="0" bIns="0">
+          <a:bodyPr wrap="square" lIns="0" tIns="0" rIns="0" bIns="0" anchor="t">
             <a:spAutoFit/>
           </a:bodyPr>
           <a:lstStyle/>
@@ -9252,6 +9350,7 @@
           <a:lstStyle/>
           <a:p>
             <a:pPr algn="ctr"/>
+            <a:endParaRPr/>
           </a:p>
         </p:txBody>
       </p:sp>
@@ -9272,7 +9371,7 @@
           <a:noFill/>
         </p:spPr>
         <p:txBody>
-          <a:bodyPr wrap="square" anchor="ctr" lIns="0" rIns="0" tIns="0" bIns="0">
+          <a:bodyPr wrap="square" lIns="0" tIns="0" rIns="0" bIns="0" anchor="ctr">
             <a:spAutoFit/>
           </a:bodyPr>
           <a:lstStyle/>
@@ -9443,6 +9542,7 @@
           <a:lstStyle/>
           <a:p>
             <a:pPr algn="ctr"/>
+            <a:endParaRPr/>
           </a:p>
         </p:txBody>
       </p:sp>
@@ -9463,7 +9563,7 @@
           <a:noFill/>
         </p:spPr>
         <p:txBody>
-          <a:bodyPr wrap="square" anchor="t" lIns="0" rIns="0" tIns="0" bIns="0">
+          <a:bodyPr wrap="square" lIns="0" tIns="0" rIns="0" bIns="0" anchor="t">
             <a:spAutoFit/>
           </a:bodyPr>
           <a:lstStyle/>
@@ -9506,7 +9606,7 @@
           <a:noFill/>
         </p:spPr>
         <p:txBody>
-          <a:bodyPr wrap="square" anchor="t" lIns="0" rIns="0" tIns="0" bIns="0">
+          <a:bodyPr wrap="square" lIns="0" tIns="0" rIns="0" bIns="0" anchor="t">
             <a:spAutoFit/>
           </a:bodyPr>
           <a:lstStyle/>
@@ -9533,7 +9633,7 @@
 </file>
 
 <file path=ppt/slides/slide18.xml><?xml version="1.0" encoding="utf-8"?>
-<p:sld xmlns:a="http://schemas.openxmlformats.org/drawingml/2006/main" xmlns:p="http://schemas.openxmlformats.org/presentationml/2006/main" xmlns:r="http://schemas.openxmlformats.org/officeDocument/2006/relationships">
+<p:sld xmlns:a="http://schemas.openxmlformats.org/drawingml/2006/main" xmlns:r="http://schemas.openxmlformats.org/officeDocument/2006/relationships" xmlns:p="http://schemas.openxmlformats.org/presentationml/2006/main">
   <p:cSld>
     <p:bg>
       <p:bgPr>
@@ -9549,7 +9649,14 @@
         <p:cNvGrpSpPr/>
         <p:nvPr/>
       </p:nvGrpSpPr>
-      <p:grpSpPr/>
+      <p:grpSpPr>
+        <a:xfrm>
+          <a:off x="0" y="0"/>
+          <a:ext cx="0" cy="0"/>
+          <a:chOff x="0" y="0"/>
+          <a:chExt cx="0" cy="0"/>
+        </a:xfrm>
+      </p:grpSpPr>
       <p:sp>
         <p:nvSpPr>
           <p:cNvPr id="2" name="Rectangle 1"/>
@@ -9591,6 +9698,7 @@
           <a:lstStyle/>
           <a:p>
             <a:pPr algn="ctr"/>
+            <a:endParaRPr/>
           </a:p>
         </p:txBody>
       </p:sp>
@@ -9664,7 +9772,7 @@
           <a:noFill/>
         </p:spPr>
         <p:txBody>
-          <a:bodyPr wrap="square" anchor="ctr" lIns="0" rIns="0" tIns="0" bIns="0">
+          <a:bodyPr wrap="square" lIns="0" tIns="0" rIns="0" bIns="0" anchor="ctr">
             <a:spAutoFit/>
           </a:bodyPr>
           <a:lstStyle/>
@@ -9690,7 +9798,7 @@
         <p:spPr>
           <a:xfrm>
             <a:off x="658368" y="1554480"/>
-            <a:ext cx="10881360" cy="4297680"/>
+            <a:ext cx="10881360" cy="3054939"/>
           </a:xfrm>
           <a:prstGeom prst="rect">
             <a:avLst/>
@@ -9698,7 +9806,7 @@
           <a:noFill/>
         </p:spPr>
         <p:txBody>
-          <a:bodyPr wrap="square" anchor="t" lIns="0" rIns="0" tIns="0" bIns="0">
+          <a:bodyPr wrap="square" lIns="0" tIns="0" rIns="0" bIns="0" anchor="t">
             <a:spAutoFit/>
           </a:bodyPr>
           <a:lstStyle/>
@@ -9715,7 +9823,7 @@
               </a:spcAft>
             </a:pPr>
             <a:r>
-              <a:rPr sz="1700" b="1" i="0">
+              <a:rPr sz="2000" b="1" i="0" dirty="0">
                 <a:solidFill>
                   <a:srgbClr val="EDAB0C"/>
                 </a:solidFill>
@@ -9724,7 +9832,7 @@
               <a:t>■  </a:t>
             </a:r>
             <a:r>
-              <a:rPr sz="1700" b="0" i="0">
+              <a:rPr sz="2000" b="0" i="0" dirty="0">
                 <a:solidFill>
                   <a:srgbClr val="2A2929"/>
                 </a:solidFill>
@@ -9746,7 +9854,7 @@
               </a:spcAft>
             </a:pPr>
             <a:r>
-              <a:rPr sz="1700" b="1" i="0">
+              <a:rPr sz="2000" b="1" i="0" dirty="0">
                 <a:solidFill>
                   <a:srgbClr val="EDAB0C"/>
                 </a:solidFill>
@@ -9755,7 +9863,7 @@
               <a:t>■  </a:t>
             </a:r>
             <a:r>
-              <a:rPr sz="1700" b="0" i="0">
+              <a:rPr sz="2000" b="0" i="0" dirty="0">
                 <a:solidFill>
                   <a:srgbClr val="2A2929"/>
                 </a:solidFill>
@@ -9777,7 +9885,7 @@
               </a:spcAft>
             </a:pPr>
             <a:r>
-              <a:rPr sz="1400" b="0" i="0">
+              <a:rPr b="0" i="0" dirty="0">
                 <a:solidFill>
                   <a:srgbClr val="7A7A7A"/>
                 </a:solidFill>
@@ -9786,7 +9894,7 @@
               <a:t>–  </a:t>
             </a:r>
             <a:r>
-              <a:rPr sz="1400" b="0" i="0">
+              <a:rPr b="0" i="0" dirty="0">
                 <a:solidFill>
                   <a:srgbClr val="2A2929"/>
                 </a:solidFill>
@@ -9808,7 +9916,7 @@
               </a:spcAft>
             </a:pPr>
             <a:r>
-              <a:rPr sz="1400" b="0" i="0">
+              <a:rPr b="0" i="0" dirty="0">
                 <a:solidFill>
                   <a:srgbClr val="7A7A7A"/>
                 </a:solidFill>
@@ -9817,7 +9925,7 @@
               <a:t>–  </a:t>
             </a:r>
             <a:r>
-              <a:rPr sz="1400" b="0" i="0">
+              <a:rPr b="0" i="0" dirty="0">
                 <a:solidFill>
                   <a:srgbClr val="2A2929"/>
                 </a:solidFill>
@@ -9839,7 +9947,7 @@
               </a:spcAft>
             </a:pPr>
             <a:r>
-              <a:rPr sz="1400" b="0" i="0">
+              <a:rPr b="0" i="0" dirty="0">
                 <a:solidFill>
                   <a:srgbClr val="7A7A7A"/>
                 </a:solidFill>
@@ -9848,7 +9956,7 @@
               <a:t>–  </a:t>
             </a:r>
             <a:r>
-              <a:rPr sz="1400" b="0" i="0">
+              <a:rPr b="0" i="0" dirty="0">
                 <a:solidFill>
                   <a:srgbClr val="2A2929"/>
                 </a:solidFill>
@@ -9870,7 +9978,7 @@
               </a:spcAft>
             </a:pPr>
             <a:r>
-              <a:rPr sz="1700" b="1" i="0">
+              <a:rPr sz="2000" b="1" i="0" dirty="0">
                 <a:solidFill>
                   <a:srgbClr val="EDAB0C"/>
                 </a:solidFill>
@@ -9879,7 +9987,7 @@
               <a:t>■  </a:t>
             </a:r>
             <a:r>
-              <a:rPr sz="1700" b="0" i="0">
+              <a:rPr sz="2000" b="0" i="0" dirty="0">
                 <a:solidFill>
                   <a:srgbClr val="2A2929"/>
                 </a:solidFill>
@@ -9901,7 +10009,7 @@
               </a:spcAft>
             </a:pPr>
             <a:r>
-              <a:rPr sz="1700" b="1" i="0">
+              <a:rPr sz="2000" b="1" i="0" dirty="0">
                 <a:solidFill>
                   <a:srgbClr val="EDAB0C"/>
                 </a:solidFill>
@@ -9910,7 +10018,7 @@
               <a:t>■  </a:t>
             </a:r>
             <a:r>
-              <a:rPr sz="1700" b="0" i="0">
+              <a:rPr sz="2000" b="0" i="0" dirty="0">
                 <a:solidFill>
                   <a:srgbClr val="2A2929"/>
                 </a:solidFill>
@@ -9964,6 +10072,7 @@
           <a:lstStyle/>
           <a:p>
             <a:pPr algn="ctr"/>
+            <a:endParaRPr/>
           </a:p>
         </p:txBody>
       </p:sp>
@@ -9984,7 +10093,7 @@
           <a:noFill/>
         </p:spPr>
         <p:txBody>
-          <a:bodyPr wrap="square" anchor="ctr" lIns="0" rIns="0" tIns="0" bIns="0">
+          <a:bodyPr wrap="square" lIns="0" tIns="0" rIns="0" bIns="0" anchor="ctr">
             <a:spAutoFit/>
           </a:bodyPr>
           <a:lstStyle/>
@@ -10042,6 +10151,7 @@
           <a:lstStyle/>
           <a:p>
             <a:pPr algn="ctr"/>
+            <a:endParaRPr/>
           </a:p>
         </p:txBody>
       </p:sp>
@@ -10062,7 +10172,7 @@
           <a:noFill/>
         </p:spPr>
         <p:txBody>
-          <a:bodyPr wrap="square" anchor="t" lIns="0" rIns="0" tIns="0" bIns="0">
+          <a:bodyPr wrap="square" lIns="0" tIns="0" rIns="0" bIns="0" anchor="t">
             <a:spAutoFit/>
           </a:bodyPr>
           <a:lstStyle/>
@@ -10105,7 +10215,7 @@
           <a:noFill/>
         </p:spPr>
         <p:txBody>
-          <a:bodyPr wrap="square" anchor="t" lIns="0" rIns="0" tIns="0" bIns="0">
+          <a:bodyPr wrap="square" lIns="0" tIns="0" rIns="0" bIns="0" anchor="t">
             <a:spAutoFit/>
           </a:bodyPr>
           <a:lstStyle/>
@@ -10132,7 +10242,7 @@
 </file>
 
 <file path=ppt/slides/slide19.xml><?xml version="1.0" encoding="utf-8"?>
-<p:sld xmlns:a="http://schemas.openxmlformats.org/drawingml/2006/main" xmlns:p="http://schemas.openxmlformats.org/presentationml/2006/main" xmlns:r="http://schemas.openxmlformats.org/officeDocument/2006/relationships">
+<p:sld xmlns:a="http://schemas.openxmlformats.org/drawingml/2006/main" xmlns:r="http://schemas.openxmlformats.org/officeDocument/2006/relationships" xmlns:p="http://schemas.openxmlformats.org/presentationml/2006/main">
   <p:cSld>
     <p:bg>
       <p:bgPr>
@@ -10148,7 +10258,14 @@
         <p:cNvGrpSpPr/>
         <p:nvPr/>
       </p:nvGrpSpPr>
-      <p:grpSpPr/>
+      <p:grpSpPr>
+        <a:xfrm>
+          <a:off x="0" y="0"/>
+          <a:ext cx="0" cy="0"/>
+          <a:chOff x="0" y="0"/>
+          <a:chExt cx="0" cy="0"/>
+        </a:xfrm>
+      </p:grpSpPr>
       <p:sp>
         <p:nvSpPr>
           <p:cNvPr id="2" name="TextBox 1"/>
@@ -10166,7 +10283,7 @@
           <a:noFill/>
         </p:spPr>
         <p:txBody>
-          <a:bodyPr wrap="square" anchor="t" lIns="0" rIns="0" tIns="0" bIns="0">
+          <a:bodyPr wrap="square" lIns="0" tIns="0" rIns="0" bIns="0" anchor="t">
             <a:spAutoFit/>
           </a:bodyPr>
           <a:lstStyle/>
@@ -10240,6 +10357,7 @@
           <a:lstStyle/>
           <a:p>
             <a:pPr algn="ctr"/>
+            <a:endParaRPr/>
           </a:p>
         </p:txBody>
       </p:sp>
@@ -10286,6 +10404,7 @@
           <a:lstStyle/>
           <a:p>
             <a:pPr algn="ctr"/>
+            <a:endParaRPr/>
           </a:p>
         </p:txBody>
       </p:sp>
@@ -10330,6 +10449,7 @@
           <a:lstStyle/>
           <a:p>
             <a:pPr algn="ctr"/>
+            <a:endParaRPr/>
           </a:p>
         </p:txBody>
       </p:sp>
@@ -10350,7 +10470,7 @@
           <a:noFill/>
         </p:spPr>
         <p:txBody>
-          <a:bodyPr wrap="square" anchor="ctr" lIns="0" rIns="0" tIns="0" bIns="0">
+          <a:bodyPr wrap="square" lIns="0" tIns="0" rIns="0" bIns="0" anchor="ctr">
             <a:spAutoFit/>
           </a:bodyPr>
           <a:lstStyle/>
@@ -10415,6 +10535,7 @@
           <a:lstStyle/>
           <a:p>
             <a:pPr algn="ctr"/>
+            <a:endParaRPr/>
           </a:p>
         </p:txBody>
       </p:sp>
@@ -10459,6 +10580,7 @@
           <a:lstStyle/>
           <a:p>
             <a:pPr algn="ctr"/>
+            <a:endParaRPr/>
           </a:p>
         </p:txBody>
       </p:sp>
@@ -10479,7 +10601,7 @@
           <a:noFill/>
         </p:spPr>
         <p:txBody>
-          <a:bodyPr wrap="square" anchor="ctr" lIns="0" rIns="0" tIns="0" bIns="0">
+          <a:bodyPr wrap="square" lIns="0" tIns="0" rIns="0" bIns="0" anchor="ctr">
             <a:spAutoFit/>
           </a:bodyPr>
           <a:lstStyle/>
@@ -10544,6 +10666,7 @@
           <a:lstStyle/>
           <a:p>
             <a:pPr algn="ctr"/>
+            <a:endParaRPr/>
           </a:p>
         </p:txBody>
       </p:sp>
@@ -10588,6 +10711,7 @@
           <a:lstStyle/>
           <a:p>
             <a:pPr algn="ctr"/>
+            <a:endParaRPr/>
           </a:p>
         </p:txBody>
       </p:sp>
@@ -10608,7 +10732,7 @@
           <a:noFill/>
         </p:spPr>
         <p:txBody>
-          <a:bodyPr wrap="square" anchor="ctr" lIns="0" rIns="0" tIns="0" bIns="0">
+          <a:bodyPr wrap="square" lIns="0" tIns="0" rIns="0" bIns="0" anchor="ctr">
             <a:spAutoFit/>
           </a:bodyPr>
           <a:lstStyle/>
@@ -10673,6 +10797,7 @@
           <a:lstStyle/>
           <a:p>
             <a:pPr algn="ctr"/>
+            <a:endParaRPr/>
           </a:p>
         </p:txBody>
       </p:sp>
@@ -10717,6 +10842,7 @@
           <a:lstStyle/>
           <a:p>
             <a:pPr algn="ctr"/>
+            <a:endParaRPr/>
           </a:p>
         </p:txBody>
       </p:sp>
@@ -10737,7 +10863,7 @@
           <a:noFill/>
         </p:spPr>
         <p:txBody>
-          <a:bodyPr wrap="square" anchor="ctr" lIns="0" rIns="0" tIns="0" bIns="0">
+          <a:bodyPr wrap="square" lIns="0" tIns="0" rIns="0" bIns="0" anchor="ctr">
             <a:spAutoFit/>
           </a:bodyPr>
           <a:lstStyle/>
@@ -10800,6 +10926,7 @@
           <a:lstStyle/>
           <a:p>
             <a:pPr algn="ctr"/>
+            <a:endParaRPr/>
           </a:p>
         </p:txBody>
       </p:sp>
@@ -10820,7 +10947,7 @@
           <a:noFill/>
         </p:spPr>
         <p:txBody>
-          <a:bodyPr wrap="square" anchor="t" lIns="0" rIns="0" tIns="0" bIns="0">
+          <a:bodyPr wrap="square" lIns="0" tIns="0" rIns="0" bIns="0" anchor="t">
             <a:spAutoFit/>
           </a:bodyPr>
           <a:lstStyle/>
@@ -10863,7 +10990,7 @@
           <a:noFill/>
         </p:spPr>
         <p:txBody>
-          <a:bodyPr wrap="square" anchor="t" lIns="0" rIns="0" tIns="0" bIns="0">
+          <a:bodyPr wrap="square" lIns="0" tIns="0" rIns="0" bIns="0" anchor="t">
             <a:spAutoFit/>
           </a:bodyPr>
           <a:lstStyle/>
@@ -10890,7 +11017,7 @@
 </file>
 
 <file path=ppt/slides/slide2.xml><?xml version="1.0" encoding="utf-8"?>
-<p:sld xmlns:a="http://schemas.openxmlformats.org/drawingml/2006/main" xmlns:p="http://schemas.openxmlformats.org/presentationml/2006/main" xmlns:r="http://schemas.openxmlformats.org/officeDocument/2006/relationships">
+<p:sld xmlns:a="http://schemas.openxmlformats.org/drawingml/2006/main" xmlns:r="http://schemas.openxmlformats.org/officeDocument/2006/relationships" xmlns:p="http://schemas.openxmlformats.org/presentationml/2006/main">
   <p:cSld>
     <p:bg>
       <p:bgPr>
@@ -10906,7 +11033,14 @@
         <p:cNvGrpSpPr/>
         <p:nvPr/>
       </p:nvGrpSpPr>
-      <p:grpSpPr/>
+      <p:grpSpPr>
+        <a:xfrm>
+          <a:off x="0" y="0"/>
+          <a:ext cx="0" cy="0"/>
+          <a:chOff x="0" y="0"/>
+          <a:chExt cx="0" cy="0"/>
+        </a:xfrm>
+      </p:grpSpPr>
       <p:sp>
         <p:nvSpPr>
           <p:cNvPr id="2" name="TextBox 1"/>
@@ -10924,7 +11058,7 @@
           <a:noFill/>
         </p:spPr>
         <p:txBody>
-          <a:bodyPr wrap="square" anchor="t" lIns="0" rIns="0" tIns="0" bIns="0">
+          <a:bodyPr wrap="square" lIns="0" tIns="0" rIns="0" bIns="0" anchor="t">
             <a:spAutoFit/>
           </a:bodyPr>
           <a:lstStyle/>
@@ -10998,6 +11132,7 @@
           <a:lstStyle/>
           <a:p>
             <a:pPr algn="ctr"/>
+            <a:endParaRPr/>
           </a:p>
         </p:txBody>
       </p:sp>
@@ -11018,7 +11153,7 @@
           <a:noFill/>
         </p:spPr>
         <p:txBody>
-          <a:bodyPr wrap="square" anchor="ctr" lIns="0" rIns="0" tIns="0" bIns="0">
+          <a:bodyPr wrap="square" lIns="0" tIns="0" rIns="0" bIns="0" anchor="ctr">
             <a:spAutoFit/>
           </a:bodyPr>
           <a:lstStyle/>
@@ -11189,6 +11324,7 @@
           <a:lstStyle/>
           <a:p>
             <a:pPr algn="ctr"/>
+            <a:endParaRPr/>
           </a:p>
         </p:txBody>
       </p:sp>
@@ -11209,7 +11345,7 @@
           <a:noFill/>
         </p:spPr>
         <p:txBody>
-          <a:bodyPr wrap="square" anchor="t" lIns="0" rIns="0" tIns="0" bIns="0">
+          <a:bodyPr wrap="square" lIns="0" tIns="0" rIns="0" bIns="0" anchor="t">
             <a:spAutoFit/>
           </a:bodyPr>
           <a:lstStyle/>
@@ -11252,7 +11388,7 @@
           <a:noFill/>
         </p:spPr>
         <p:txBody>
-          <a:bodyPr wrap="square" anchor="t" lIns="0" rIns="0" tIns="0" bIns="0">
+          <a:bodyPr wrap="square" lIns="0" tIns="0" rIns="0" bIns="0" anchor="t">
             <a:spAutoFit/>
           </a:bodyPr>
           <a:lstStyle/>
@@ -11279,7 +11415,7 @@
 </file>
 
 <file path=ppt/slides/slide20.xml><?xml version="1.0" encoding="utf-8"?>
-<p:sld xmlns:a="http://schemas.openxmlformats.org/drawingml/2006/main" xmlns:p="http://schemas.openxmlformats.org/presentationml/2006/main" xmlns:r="http://schemas.openxmlformats.org/officeDocument/2006/relationships">
+<p:sld xmlns:a="http://schemas.openxmlformats.org/drawingml/2006/main" xmlns:r="http://schemas.openxmlformats.org/officeDocument/2006/relationships" xmlns:p="http://schemas.openxmlformats.org/presentationml/2006/main">
   <p:cSld>
     <p:bg>
       <p:bgPr>
@@ -11295,7 +11431,14 @@
         <p:cNvGrpSpPr/>
         <p:nvPr/>
       </p:nvGrpSpPr>
-      <p:grpSpPr/>
+      <p:grpSpPr>
+        <a:xfrm>
+          <a:off x="0" y="0"/>
+          <a:ext cx="0" cy="0"/>
+          <a:chOff x="0" y="0"/>
+          <a:chExt cx="0" cy="0"/>
+        </a:xfrm>
+      </p:grpSpPr>
       <p:sp>
         <p:nvSpPr>
           <p:cNvPr id="2" name="Rectangle 1"/>
@@ -11337,6 +11480,7 @@
           <a:lstStyle/>
           <a:p>
             <a:pPr algn="ctr"/>
+            <a:endParaRPr/>
           </a:p>
         </p:txBody>
       </p:sp>
@@ -11357,7 +11501,7 @@
           <a:noFill/>
         </p:spPr>
         <p:txBody>
-          <a:bodyPr wrap="square" anchor="t" lIns="0" rIns="0" tIns="0" bIns="0">
+          <a:bodyPr wrap="square" lIns="0" tIns="0" rIns="0" bIns="0" anchor="t">
             <a:spAutoFit/>
           </a:bodyPr>
           <a:lstStyle/>
@@ -11391,7 +11535,7 @@
           <a:noFill/>
         </p:spPr>
         <p:txBody>
-          <a:bodyPr wrap="square" anchor="t" lIns="0" rIns="0" tIns="0" bIns="0">
+          <a:bodyPr wrap="square" lIns="0" tIns="0" rIns="0" bIns="0" anchor="t">
             <a:spAutoFit/>
           </a:bodyPr>
           <a:lstStyle/>
@@ -11481,6 +11625,7 @@
           <a:lstStyle/>
           <a:p>
             <a:pPr algn="ctr"/>
+            <a:endParaRPr/>
           </a:p>
         </p:txBody>
       </p:sp>
@@ -11501,7 +11646,7 @@
           <a:noFill/>
         </p:spPr>
         <p:txBody>
-          <a:bodyPr wrap="square" anchor="t" lIns="0" rIns="0" tIns="0" bIns="0">
+          <a:bodyPr wrap="square" lIns="0" tIns="0" rIns="0" bIns="0" anchor="t">
             <a:spAutoFit/>
           </a:bodyPr>
           <a:lstStyle/>
@@ -11544,21 +11689,13 @@
           <a:noFill/>
         </p:spPr>
         <p:txBody>
-          <a:bodyPr wrap="square" anchor="t" lIns="0" rIns="0" tIns="0" bIns="0">
+          <a:bodyPr wrap="square" lIns="0" tIns="0" rIns="0" bIns="0" anchor="t">
             <a:spAutoFit/>
           </a:bodyPr>
           <a:lstStyle/>
           <a:p>
             <a:pPr algn="r"/>
-            <a:r>
-              <a:rPr sz="1100" b="0" i="0">
-                <a:solidFill>
-                  <a:srgbClr val="7A7A7A"/>
-                </a:solidFill>
-                <a:latin typeface="Roboto"/>
-              </a:rPr>
-              <a:t/>
-            </a:r>
+            <a:endParaRPr/>
           </a:p>
         </p:txBody>
       </p:sp>
@@ -11571,7 +11708,7 @@
 </file>
 
 <file path=ppt/slides/slide21.xml><?xml version="1.0" encoding="utf-8"?>
-<p:sld xmlns:a="http://schemas.openxmlformats.org/drawingml/2006/main" xmlns:p="http://schemas.openxmlformats.org/presentationml/2006/main" xmlns:r="http://schemas.openxmlformats.org/officeDocument/2006/relationships">
+<p:sld xmlns:a="http://schemas.openxmlformats.org/drawingml/2006/main" xmlns:r="http://schemas.openxmlformats.org/officeDocument/2006/relationships" xmlns:p="http://schemas.openxmlformats.org/presentationml/2006/main">
   <p:cSld>
     <p:bg>
       <p:bgPr>
@@ -11587,7 +11724,14 @@
         <p:cNvGrpSpPr/>
         <p:nvPr/>
       </p:nvGrpSpPr>
-      <p:grpSpPr/>
+      <p:grpSpPr>
+        <a:xfrm>
+          <a:off x="0" y="0"/>
+          <a:ext cx="0" cy="0"/>
+          <a:chOff x="0" y="0"/>
+          <a:chExt cx="0" cy="0"/>
+        </a:xfrm>
+      </p:grpSpPr>
       <p:sp>
         <p:nvSpPr>
           <p:cNvPr id="2" name="TextBox 1"/>
@@ -11605,7 +11749,7 @@
           <a:noFill/>
         </p:spPr>
         <p:txBody>
-          <a:bodyPr wrap="square" anchor="t" lIns="0" rIns="0" tIns="0" bIns="0">
+          <a:bodyPr wrap="square" lIns="0" tIns="0" rIns="0" bIns="0" anchor="t">
             <a:spAutoFit/>
           </a:bodyPr>
           <a:lstStyle/>
@@ -11663,6 +11807,7 @@
           <a:lstStyle/>
           <a:p>
             <a:pPr algn="ctr"/>
+            <a:endParaRPr/>
           </a:p>
         </p:txBody>
       </p:sp>
@@ -11683,7 +11828,7 @@
           <a:noFill/>
         </p:spPr>
         <p:txBody>
-          <a:bodyPr wrap="square" anchor="ctr" lIns="0" rIns="0" tIns="0" bIns="0">
+          <a:bodyPr wrap="square" lIns="0" tIns="0" rIns="0" bIns="0" anchor="ctr">
             <a:spAutoFit/>
           </a:bodyPr>
           <a:lstStyle/>
@@ -11823,6 +11968,7 @@
           <a:lstStyle/>
           <a:p>
             <a:pPr algn="ctr"/>
+            <a:endParaRPr/>
           </a:p>
         </p:txBody>
       </p:sp>
@@ -11843,7 +11989,7 @@
           <a:noFill/>
         </p:spPr>
         <p:txBody>
-          <a:bodyPr wrap="square" anchor="t" lIns="0" rIns="0" tIns="0" bIns="0">
+          <a:bodyPr wrap="square" lIns="0" tIns="0" rIns="0" bIns="0" anchor="t">
             <a:spAutoFit/>
           </a:bodyPr>
           <a:lstStyle/>
@@ -11886,7 +12032,7 @@
           <a:noFill/>
         </p:spPr>
         <p:txBody>
-          <a:bodyPr wrap="square" anchor="t" lIns="0" rIns="0" tIns="0" bIns="0">
+          <a:bodyPr wrap="square" lIns="0" tIns="0" rIns="0" bIns="0" anchor="t">
             <a:spAutoFit/>
           </a:bodyPr>
           <a:lstStyle/>
@@ -11913,7 +12059,7 @@
 </file>
 
 <file path=ppt/slides/slide22.xml><?xml version="1.0" encoding="utf-8"?>
-<p:sld xmlns:a="http://schemas.openxmlformats.org/drawingml/2006/main" xmlns:p="http://schemas.openxmlformats.org/presentationml/2006/main" xmlns:r="http://schemas.openxmlformats.org/officeDocument/2006/relationships">
+<p:sld xmlns:a="http://schemas.openxmlformats.org/drawingml/2006/main" xmlns:r="http://schemas.openxmlformats.org/officeDocument/2006/relationships" xmlns:p="http://schemas.openxmlformats.org/presentationml/2006/main">
   <p:cSld>
     <p:bg>
       <p:bgPr>
@@ -11929,7 +12075,14 @@
         <p:cNvGrpSpPr/>
         <p:nvPr/>
       </p:nvGrpSpPr>
-      <p:grpSpPr/>
+      <p:grpSpPr>
+        <a:xfrm>
+          <a:off x="0" y="0"/>
+          <a:ext cx="0" cy="0"/>
+          <a:chOff x="0" y="0"/>
+          <a:chExt cx="0" cy="0"/>
+        </a:xfrm>
+      </p:grpSpPr>
       <p:sp>
         <p:nvSpPr>
           <p:cNvPr id="2" name="TextBox 1"/>
@@ -11947,7 +12100,7 @@
           <a:noFill/>
         </p:spPr>
         <p:txBody>
-          <a:bodyPr wrap="square" anchor="t" lIns="0" rIns="0" tIns="0" bIns="0">
+          <a:bodyPr wrap="square" lIns="0" tIns="0" rIns="0" bIns="0" anchor="t">
             <a:spAutoFit/>
           </a:bodyPr>
           <a:lstStyle/>
@@ -12021,6 +12174,7 @@
           <a:lstStyle/>
           <a:p>
             <a:pPr algn="ctr"/>
+            <a:endParaRPr/>
           </a:p>
         </p:txBody>
       </p:sp>
@@ -12041,7 +12195,7 @@
           <a:noFill/>
         </p:spPr>
         <p:txBody>
-          <a:bodyPr wrap="square" anchor="ctr" lIns="0" rIns="0" tIns="0" bIns="0">
+          <a:bodyPr wrap="square" lIns="0" tIns="0" rIns="0" bIns="0" anchor="ctr">
             <a:spAutoFit/>
           </a:bodyPr>
           <a:lstStyle/>
@@ -12212,6 +12366,7 @@
           <a:lstStyle/>
           <a:p>
             <a:pPr algn="ctr"/>
+            <a:endParaRPr/>
           </a:p>
         </p:txBody>
       </p:sp>
@@ -12232,7 +12387,7 @@
           <a:noFill/>
         </p:spPr>
         <p:txBody>
-          <a:bodyPr wrap="square" anchor="t" lIns="0" rIns="0" tIns="0" bIns="0">
+          <a:bodyPr wrap="square" lIns="0" tIns="0" rIns="0" bIns="0" anchor="t">
             <a:spAutoFit/>
           </a:bodyPr>
           <a:lstStyle/>
@@ -12275,7 +12430,7 @@
           <a:noFill/>
         </p:spPr>
         <p:txBody>
-          <a:bodyPr wrap="square" anchor="t" lIns="0" rIns="0" tIns="0" bIns="0">
+          <a:bodyPr wrap="square" lIns="0" tIns="0" rIns="0" bIns="0" anchor="t">
             <a:spAutoFit/>
           </a:bodyPr>
           <a:lstStyle/>
@@ -12302,7 +12457,7 @@
 </file>
 
 <file path=ppt/slides/slide23.xml><?xml version="1.0" encoding="utf-8"?>
-<p:sld xmlns:a="http://schemas.openxmlformats.org/drawingml/2006/main" xmlns:p="http://schemas.openxmlformats.org/presentationml/2006/main" xmlns:r="http://schemas.openxmlformats.org/officeDocument/2006/relationships">
+<p:sld xmlns:a="http://schemas.openxmlformats.org/drawingml/2006/main" xmlns:r="http://schemas.openxmlformats.org/officeDocument/2006/relationships" xmlns:p="http://schemas.openxmlformats.org/presentationml/2006/main">
   <p:cSld>
     <p:bg>
       <p:bgPr>
@@ -12318,7 +12473,14 @@
         <p:cNvGrpSpPr/>
         <p:nvPr/>
       </p:nvGrpSpPr>
-      <p:grpSpPr/>
+      <p:grpSpPr>
+        <a:xfrm>
+          <a:off x="0" y="0"/>
+          <a:ext cx="0" cy="0"/>
+          <a:chOff x="0" y="0"/>
+          <a:chExt cx="0" cy="0"/>
+        </a:xfrm>
+      </p:grpSpPr>
       <p:sp>
         <p:nvSpPr>
           <p:cNvPr id="2" name="TextBox 1"/>
@@ -12336,7 +12498,7 @@
           <a:noFill/>
         </p:spPr>
         <p:txBody>
-          <a:bodyPr wrap="square" anchor="t" lIns="0" rIns="0" tIns="0" bIns="0">
+          <a:bodyPr wrap="square" lIns="0" tIns="0" rIns="0" bIns="0" anchor="t">
             <a:spAutoFit/>
           </a:bodyPr>
           <a:lstStyle/>
@@ -12394,6 +12556,7 @@
           <a:lstStyle/>
           <a:p>
             <a:pPr algn="ctr"/>
+            <a:endParaRPr/>
           </a:p>
         </p:txBody>
       </p:sp>
@@ -12414,7 +12577,7 @@
           <a:noFill/>
         </p:spPr>
         <p:txBody>
-          <a:bodyPr wrap="square" anchor="ctr" lIns="0" rIns="0" tIns="0" bIns="0">
+          <a:bodyPr wrap="square" lIns="0" tIns="0" rIns="0" bIns="0" anchor="ctr">
             <a:spAutoFit/>
           </a:bodyPr>
           <a:lstStyle/>
@@ -12585,6 +12748,7 @@
           <a:lstStyle/>
           <a:p>
             <a:pPr algn="ctr"/>
+            <a:endParaRPr/>
           </a:p>
         </p:txBody>
       </p:sp>
@@ -12605,7 +12769,7 @@
           <a:noFill/>
         </p:spPr>
         <p:txBody>
-          <a:bodyPr wrap="square" anchor="t" lIns="0" rIns="0" tIns="0" bIns="0">
+          <a:bodyPr wrap="square" lIns="0" tIns="0" rIns="0" bIns="0" anchor="t">
             <a:spAutoFit/>
           </a:bodyPr>
           <a:lstStyle/>
@@ -12648,7 +12812,7 @@
           <a:noFill/>
         </p:spPr>
         <p:txBody>
-          <a:bodyPr wrap="square" anchor="t" lIns="0" rIns="0" tIns="0" bIns="0">
+          <a:bodyPr wrap="square" lIns="0" tIns="0" rIns="0" bIns="0" anchor="t">
             <a:spAutoFit/>
           </a:bodyPr>
           <a:lstStyle/>
@@ -12675,7 +12839,7 @@
 </file>
 
 <file path=ppt/slides/slide24.xml><?xml version="1.0" encoding="utf-8"?>
-<p:sld xmlns:a="http://schemas.openxmlformats.org/drawingml/2006/main" xmlns:p="http://schemas.openxmlformats.org/presentationml/2006/main" xmlns:r="http://schemas.openxmlformats.org/officeDocument/2006/relationships">
+<p:sld xmlns:a="http://schemas.openxmlformats.org/drawingml/2006/main" xmlns:r="http://schemas.openxmlformats.org/officeDocument/2006/relationships" xmlns:p="http://schemas.openxmlformats.org/presentationml/2006/main">
   <p:cSld>
     <p:bg>
       <p:bgPr>
@@ -12691,7 +12855,14 @@
         <p:cNvGrpSpPr/>
         <p:nvPr/>
       </p:nvGrpSpPr>
-      <p:grpSpPr/>
+      <p:grpSpPr>
+        <a:xfrm>
+          <a:off x="0" y="0"/>
+          <a:ext cx="0" cy="0"/>
+          <a:chOff x="0" y="0"/>
+          <a:chExt cx="0" cy="0"/>
+        </a:xfrm>
+      </p:grpSpPr>
       <p:sp>
         <p:nvSpPr>
           <p:cNvPr id="2" name="Rectangle 1"/>
@@ -12733,6 +12904,7 @@
           <a:lstStyle/>
           <a:p>
             <a:pPr algn="ctr"/>
+            <a:endParaRPr/>
           </a:p>
         </p:txBody>
       </p:sp>
@@ -12806,7 +12978,7 @@
           <a:noFill/>
         </p:spPr>
         <p:txBody>
-          <a:bodyPr wrap="square" anchor="ctr" lIns="0" rIns="0" tIns="0" bIns="0">
+          <a:bodyPr wrap="square" lIns="0" tIns="0" rIns="0" bIns="0" anchor="ctr">
             <a:spAutoFit/>
           </a:bodyPr>
           <a:lstStyle/>
@@ -12832,7 +13004,7 @@
         <p:spPr>
           <a:xfrm>
             <a:off x="658368" y="1554480"/>
-            <a:ext cx="10881360" cy="4297680"/>
+            <a:ext cx="10881360" cy="3085653"/>
           </a:xfrm>
           <a:prstGeom prst="rect">
             <a:avLst/>
@@ -12840,7 +13012,7 @@
           <a:noFill/>
         </p:spPr>
         <p:txBody>
-          <a:bodyPr wrap="square" anchor="t" lIns="0" rIns="0" tIns="0" bIns="0">
+          <a:bodyPr wrap="square" lIns="0" tIns="0" rIns="0" bIns="0" anchor="t">
             <a:spAutoFit/>
           </a:bodyPr>
           <a:lstStyle/>
@@ -12857,7 +13029,7 @@
               </a:spcAft>
             </a:pPr>
             <a:r>
-              <a:rPr sz="1700" b="1" i="0">
+              <a:rPr sz="2400" b="1" i="0" dirty="0">
                 <a:solidFill>
                   <a:srgbClr val="EDAB0C"/>
                 </a:solidFill>
@@ -12866,7 +13038,7 @@
               <a:t>■  </a:t>
             </a:r>
             <a:r>
-              <a:rPr sz="1700" b="0" i="0">
+              <a:rPr sz="2400" b="0" i="0" dirty="0">
                 <a:solidFill>
                   <a:srgbClr val="2A2929"/>
                 </a:solidFill>
@@ -12888,7 +13060,7 @@
               </a:spcAft>
             </a:pPr>
             <a:r>
-              <a:rPr sz="1700" b="1" i="0">
+              <a:rPr sz="2400" b="1" i="0" dirty="0">
                 <a:solidFill>
                   <a:srgbClr val="EDAB0C"/>
                 </a:solidFill>
@@ -12897,7 +13069,7 @@
               <a:t>■  </a:t>
             </a:r>
             <a:r>
-              <a:rPr sz="1700" b="0" i="0">
+              <a:rPr sz="2400" b="0" i="0" dirty="0">
                 <a:solidFill>
                   <a:srgbClr val="2A2929"/>
                 </a:solidFill>
@@ -12919,7 +13091,7 @@
               </a:spcAft>
             </a:pPr>
             <a:r>
-              <a:rPr sz="1400" b="0" i="0">
+              <a:rPr sz="2000" b="0" i="0" dirty="0">
                 <a:solidFill>
                   <a:srgbClr val="7A7A7A"/>
                 </a:solidFill>
@@ -12928,7 +13100,7 @@
               <a:t>–  </a:t>
             </a:r>
             <a:r>
-              <a:rPr sz="1400" b="0" i="0">
+              <a:rPr sz="2000" b="0" i="0" dirty="0">
                 <a:solidFill>
                   <a:srgbClr val="2A2929"/>
                 </a:solidFill>
@@ -12950,7 +13122,7 @@
               </a:spcAft>
             </a:pPr>
             <a:r>
-              <a:rPr sz="1400" b="0" i="0">
+              <a:rPr sz="2000" b="0" i="0" dirty="0">
                 <a:solidFill>
                   <a:srgbClr val="7A7A7A"/>
                 </a:solidFill>
@@ -12959,7 +13131,7 @@
               <a:t>–  </a:t>
             </a:r>
             <a:r>
-              <a:rPr sz="1400" b="0" i="0">
+              <a:rPr sz="2000" b="0" i="0" dirty="0">
                 <a:solidFill>
                   <a:srgbClr val="2A2929"/>
                 </a:solidFill>
@@ -12981,7 +13153,7 @@
               </a:spcAft>
             </a:pPr>
             <a:r>
-              <a:rPr sz="1700" b="1" i="0">
+              <a:rPr sz="2400" b="1" i="0" dirty="0">
                 <a:solidFill>
                   <a:srgbClr val="EDAB0C"/>
                 </a:solidFill>
@@ -12990,7 +13162,7 @@
               <a:t>■  </a:t>
             </a:r>
             <a:r>
-              <a:rPr sz="1700" b="0" i="0">
+              <a:rPr sz="2400" b="0" i="0" dirty="0">
                 <a:solidFill>
                   <a:srgbClr val="2A2929"/>
                 </a:solidFill>
@@ -13012,7 +13184,7 @@
               </a:spcAft>
             </a:pPr>
             <a:r>
-              <a:rPr sz="1700" b="1" i="0">
+              <a:rPr sz="2400" b="1" i="0" dirty="0">
                 <a:solidFill>
                   <a:srgbClr val="EDAB0C"/>
                 </a:solidFill>
@@ -13021,7 +13193,7 @@
               <a:t>■  </a:t>
             </a:r>
             <a:r>
-              <a:rPr sz="1700" b="0" i="0">
+              <a:rPr sz="2400" b="0" i="0" dirty="0">
                 <a:solidFill>
                   <a:srgbClr val="2A2929"/>
                 </a:solidFill>
@@ -13075,6 +13247,7 @@
           <a:lstStyle/>
           <a:p>
             <a:pPr algn="ctr"/>
+            <a:endParaRPr/>
           </a:p>
         </p:txBody>
       </p:sp>
@@ -13095,7 +13268,7 @@
           <a:noFill/>
         </p:spPr>
         <p:txBody>
-          <a:bodyPr wrap="square" anchor="ctr" lIns="0" rIns="0" tIns="0" bIns="0">
+          <a:bodyPr wrap="square" lIns="0" tIns="0" rIns="0" bIns="0" anchor="ctr">
             <a:spAutoFit/>
           </a:bodyPr>
           <a:lstStyle/>
@@ -13153,6 +13326,7 @@
           <a:lstStyle/>
           <a:p>
             <a:pPr algn="ctr"/>
+            <a:endParaRPr/>
           </a:p>
         </p:txBody>
       </p:sp>
@@ -13173,7 +13347,7 @@
           <a:noFill/>
         </p:spPr>
         <p:txBody>
-          <a:bodyPr wrap="square" anchor="t" lIns="0" rIns="0" tIns="0" bIns="0">
+          <a:bodyPr wrap="square" lIns="0" tIns="0" rIns="0" bIns="0" anchor="t">
             <a:spAutoFit/>
           </a:bodyPr>
           <a:lstStyle/>
@@ -13216,7 +13390,7 @@
           <a:noFill/>
         </p:spPr>
         <p:txBody>
-          <a:bodyPr wrap="square" anchor="t" lIns="0" rIns="0" tIns="0" bIns="0">
+          <a:bodyPr wrap="square" lIns="0" tIns="0" rIns="0" bIns="0" anchor="t">
             <a:spAutoFit/>
           </a:bodyPr>
           <a:lstStyle/>
@@ -13243,7 +13417,7 @@
 </file>
 
 <file path=ppt/slides/slide25.xml><?xml version="1.0" encoding="utf-8"?>
-<p:sld xmlns:a="http://schemas.openxmlformats.org/drawingml/2006/main" xmlns:p="http://schemas.openxmlformats.org/presentationml/2006/main" xmlns:r="http://schemas.openxmlformats.org/officeDocument/2006/relationships">
+<p:sld xmlns:a="http://schemas.openxmlformats.org/drawingml/2006/main" xmlns:r="http://schemas.openxmlformats.org/officeDocument/2006/relationships" xmlns:p="http://schemas.openxmlformats.org/presentationml/2006/main">
   <p:cSld>
     <p:bg>
       <p:bgPr>
@@ -13259,7 +13433,14 @@
         <p:cNvGrpSpPr/>
         <p:nvPr/>
       </p:nvGrpSpPr>
-      <p:grpSpPr/>
+      <p:grpSpPr>
+        <a:xfrm>
+          <a:off x="0" y="0"/>
+          <a:ext cx="0" cy="0"/>
+          <a:chOff x="0" y="0"/>
+          <a:chExt cx="0" cy="0"/>
+        </a:xfrm>
+      </p:grpSpPr>
       <p:sp>
         <p:nvSpPr>
           <p:cNvPr id="2" name="TextBox 1"/>
@@ -13277,7 +13458,7 @@
           <a:noFill/>
         </p:spPr>
         <p:txBody>
-          <a:bodyPr wrap="square" anchor="t" lIns="0" rIns="0" tIns="0" bIns="0">
+          <a:bodyPr wrap="square" lIns="0" tIns="0" rIns="0" bIns="0" anchor="t">
             <a:spAutoFit/>
           </a:bodyPr>
           <a:lstStyle/>
@@ -13351,6 +13532,7 @@
           <a:lstStyle/>
           <a:p>
             <a:pPr algn="ctr"/>
+            <a:endParaRPr/>
           </a:p>
         </p:txBody>
       </p:sp>
@@ -13397,6 +13579,7 @@
           <a:lstStyle/>
           <a:p>
             <a:pPr algn="ctr"/>
+            <a:endParaRPr/>
           </a:p>
         </p:txBody>
       </p:sp>
@@ -13441,6 +13624,7 @@
           <a:lstStyle/>
           <a:p>
             <a:pPr algn="ctr"/>
+            <a:endParaRPr/>
           </a:p>
         </p:txBody>
       </p:sp>
@@ -13461,7 +13645,7 @@
           <a:noFill/>
         </p:spPr>
         <p:txBody>
-          <a:bodyPr wrap="square" anchor="ctr" lIns="0" rIns="0" tIns="0" bIns="0">
+          <a:bodyPr wrap="square" lIns="0" tIns="0" rIns="0" bIns="0" anchor="ctr">
             <a:spAutoFit/>
           </a:bodyPr>
           <a:lstStyle/>
@@ -13526,6 +13710,7 @@
           <a:lstStyle/>
           <a:p>
             <a:pPr algn="ctr"/>
+            <a:endParaRPr/>
           </a:p>
         </p:txBody>
       </p:sp>
@@ -13570,6 +13755,7 @@
           <a:lstStyle/>
           <a:p>
             <a:pPr algn="ctr"/>
+            <a:endParaRPr/>
           </a:p>
         </p:txBody>
       </p:sp>
@@ -13590,7 +13776,7 @@
           <a:noFill/>
         </p:spPr>
         <p:txBody>
-          <a:bodyPr wrap="square" anchor="ctr" lIns="0" rIns="0" tIns="0" bIns="0">
+          <a:bodyPr wrap="square" lIns="0" tIns="0" rIns="0" bIns="0" anchor="ctr">
             <a:spAutoFit/>
           </a:bodyPr>
           <a:lstStyle/>
@@ -13655,6 +13841,7 @@
           <a:lstStyle/>
           <a:p>
             <a:pPr algn="ctr"/>
+            <a:endParaRPr/>
           </a:p>
         </p:txBody>
       </p:sp>
@@ -13699,6 +13886,7 @@
           <a:lstStyle/>
           <a:p>
             <a:pPr algn="ctr"/>
+            <a:endParaRPr/>
           </a:p>
         </p:txBody>
       </p:sp>
@@ -13719,7 +13907,7 @@
           <a:noFill/>
         </p:spPr>
         <p:txBody>
-          <a:bodyPr wrap="square" anchor="ctr" lIns="0" rIns="0" tIns="0" bIns="0">
+          <a:bodyPr wrap="square" lIns="0" tIns="0" rIns="0" bIns="0" anchor="ctr">
             <a:spAutoFit/>
           </a:bodyPr>
           <a:lstStyle/>
@@ -13782,6 +13970,7 @@
           <a:lstStyle/>
           <a:p>
             <a:pPr algn="ctr"/>
+            <a:endParaRPr/>
           </a:p>
         </p:txBody>
       </p:sp>
@@ -13802,7 +13991,7 @@
           <a:noFill/>
         </p:spPr>
         <p:txBody>
-          <a:bodyPr wrap="square" anchor="t" lIns="0" rIns="0" tIns="0" bIns="0">
+          <a:bodyPr wrap="square" lIns="0" tIns="0" rIns="0" bIns="0" anchor="t">
             <a:spAutoFit/>
           </a:bodyPr>
           <a:lstStyle/>
@@ -13845,7 +14034,7 @@
           <a:noFill/>
         </p:spPr>
         <p:txBody>
-          <a:bodyPr wrap="square" anchor="t" lIns="0" rIns="0" tIns="0" bIns="0">
+          <a:bodyPr wrap="square" lIns="0" tIns="0" rIns="0" bIns="0" anchor="t">
             <a:spAutoFit/>
           </a:bodyPr>
           <a:lstStyle/>
@@ -13872,7 +14061,7 @@
 </file>
 
 <file path=ppt/slides/slide26.xml><?xml version="1.0" encoding="utf-8"?>
-<p:sld xmlns:a="http://schemas.openxmlformats.org/drawingml/2006/main" xmlns:p="http://schemas.openxmlformats.org/presentationml/2006/main" xmlns:r="http://schemas.openxmlformats.org/officeDocument/2006/relationships">
+<p:sld xmlns:a="http://schemas.openxmlformats.org/drawingml/2006/main" xmlns:r="http://schemas.openxmlformats.org/officeDocument/2006/relationships" xmlns:p="http://schemas.openxmlformats.org/presentationml/2006/main">
   <p:cSld>
     <p:bg>
       <p:bgPr>
@@ -13888,7 +14077,14 @@
         <p:cNvGrpSpPr/>
         <p:nvPr/>
       </p:nvGrpSpPr>
-      <p:grpSpPr/>
+      <p:grpSpPr>
+        <a:xfrm>
+          <a:off x="0" y="0"/>
+          <a:ext cx="0" cy="0"/>
+          <a:chOff x="0" y="0"/>
+          <a:chExt cx="0" cy="0"/>
+        </a:xfrm>
+      </p:grpSpPr>
       <p:sp>
         <p:nvSpPr>
           <p:cNvPr id="2" name="Rectangle 1"/>
@@ -13930,6 +14126,7 @@
           <a:lstStyle/>
           <a:p>
             <a:pPr algn="ctr"/>
+            <a:endParaRPr/>
           </a:p>
         </p:txBody>
       </p:sp>
@@ -13950,7 +14147,7 @@
           <a:noFill/>
         </p:spPr>
         <p:txBody>
-          <a:bodyPr wrap="square" anchor="t" lIns="0" rIns="0" tIns="0" bIns="0">
+          <a:bodyPr wrap="square" lIns="0" tIns="0" rIns="0" bIns="0" anchor="t">
             <a:spAutoFit/>
           </a:bodyPr>
           <a:lstStyle/>
@@ -14052,7 +14249,7 @@
 </file>
 
 <file path=ppt/slides/slide3.xml><?xml version="1.0" encoding="utf-8"?>
-<p:sld xmlns:a="http://schemas.openxmlformats.org/drawingml/2006/main" xmlns:p="http://schemas.openxmlformats.org/presentationml/2006/main" xmlns:r="http://schemas.openxmlformats.org/officeDocument/2006/relationships">
+<p:sld xmlns:a="http://schemas.openxmlformats.org/drawingml/2006/main" xmlns:r="http://schemas.openxmlformats.org/officeDocument/2006/relationships" xmlns:p="http://schemas.openxmlformats.org/presentationml/2006/main">
   <p:cSld>
     <p:bg>
       <p:bgPr>
@@ -14068,7 +14265,14 @@
         <p:cNvGrpSpPr/>
         <p:nvPr/>
       </p:nvGrpSpPr>
-      <p:grpSpPr/>
+      <p:grpSpPr>
+        <a:xfrm>
+          <a:off x="0" y="0"/>
+          <a:ext cx="0" cy="0"/>
+          <a:chOff x="0" y="0"/>
+          <a:chExt cx="0" cy="0"/>
+        </a:xfrm>
+      </p:grpSpPr>
       <p:sp>
         <p:nvSpPr>
           <p:cNvPr id="2" name="Rectangle 1"/>
@@ -14110,6 +14314,7 @@
           <a:lstStyle/>
           <a:p>
             <a:pPr algn="ctr"/>
+            <a:endParaRPr/>
           </a:p>
         </p:txBody>
       </p:sp>
@@ -14130,7 +14335,7 @@
           <a:noFill/>
         </p:spPr>
         <p:txBody>
-          <a:bodyPr wrap="square" anchor="t" lIns="0" rIns="0" tIns="0" bIns="0">
+          <a:bodyPr wrap="square" lIns="0" tIns="0" rIns="0" bIns="0" anchor="t">
             <a:spAutoFit/>
           </a:bodyPr>
           <a:lstStyle/>
@@ -14164,7 +14369,7 @@
           <a:noFill/>
         </p:spPr>
         <p:txBody>
-          <a:bodyPr wrap="square" anchor="t" lIns="0" rIns="0" tIns="0" bIns="0">
+          <a:bodyPr wrap="square" lIns="0" tIns="0" rIns="0" bIns="0" anchor="t">
             <a:spAutoFit/>
           </a:bodyPr>
           <a:lstStyle/>
@@ -14254,6 +14459,7 @@
           <a:lstStyle/>
           <a:p>
             <a:pPr algn="ctr"/>
+            <a:endParaRPr/>
           </a:p>
         </p:txBody>
       </p:sp>
@@ -14274,7 +14480,7 @@
           <a:noFill/>
         </p:spPr>
         <p:txBody>
-          <a:bodyPr wrap="square" anchor="t" lIns="0" rIns="0" tIns="0" bIns="0">
+          <a:bodyPr wrap="square" lIns="0" tIns="0" rIns="0" bIns="0" anchor="t">
             <a:spAutoFit/>
           </a:bodyPr>
           <a:lstStyle/>
@@ -14317,21 +14523,13 @@
           <a:noFill/>
         </p:spPr>
         <p:txBody>
-          <a:bodyPr wrap="square" anchor="t" lIns="0" rIns="0" tIns="0" bIns="0">
+          <a:bodyPr wrap="square" lIns="0" tIns="0" rIns="0" bIns="0" anchor="t">
             <a:spAutoFit/>
           </a:bodyPr>
           <a:lstStyle/>
           <a:p>
             <a:pPr algn="r"/>
-            <a:r>
-              <a:rPr sz="1100" b="0" i="0">
-                <a:solidFill>
-                  <a:srgbClr val="7A7A7A"/>
-                </a:solidFill>
-                <a:latin typeface="Roboto"/>
-              </a:rPr>
-              <a:t/>
-            </a:r>
+            <a:endParaRPr/>
           </a:p>
         </p:txBody>
       </p:sp>
@@ -14344,7 +14542,7 @@
 </file>
 
 <file path=ppt/slides/slide4.xml><?xml version="1.0" encoding="utf-8"?>
-<p:sld xmlns:a="http://schemas.openxmlformats.org/drawingml/2006/main" xmlns:p="http://schemas.openxmlformats.org/presentationml/2006/main" xmlns:r="http://schemas.openxmlformats.org/officeDocument/2006/relationships">
+<p:sld xmlns:a="http://schemas.openxmlformats.org/drawingml/2006/main" xmlns:r="http://schemas.openxmlformats.org/officeDocument/2006/relationships" xmlns:p="http://schemas.openxmlformats.org/presentationml/2006/main">
   <p:cSld>
     <p:bg>
       <p:bgPr>
@@ -14360,7 +14558,14 @@
         <p:cNvGrpSpPr/>
         <p:nvPr/>
       </p:nvGrpSpPr>
-      <p:grpSpPr/>
+      <p:grpSpPr>
+        <a:xfrm>
+          <a:off x="0" y="0"/>
+          <a:ext cx="0" cy="0"/>
+          <a:chOff x="0" y="0"/>
+          <a:chExt cx="0" cy="0"/>
+        </a:xfrm>
+      </p:grpSpPr>
       <p:sp>
         <p:nvSpPr>
           <p:cNvPr id="2" name="TextBox 1"/>
@@ -14378,7 +14583,7 @@
           <a:noFill/>
         </p:spPr>
         <p:txBody>
-          <a:bodyPr wrap="square" anchor="t" lIns="0" rIns="0" tIns="0" bIns="0">
+          <a:bodyPr wrap="square" lIns="0" tIns="0" rIns="0" bIns="0" anchor="t">
             <a:spAutoFit/>
           </a:bodyPr>
           <a:lstStyle/>
@@ -14436,6 +14641,7 @@
           <a:lstStyle/>
           <a:p>
             <a:pPr algn="ctr"/>
+            <a:endParaRPr/>
           </a:p>
         </p:txBody>
       </p:sp>
@@ -14456,7 +14662,7 @@
           <a:noFill/>
         </p:spPr>
         <p:txBody>
-          <a:bodyPr wrap="square" anchor="ctr" lIns="0" rIns="0" tIns="0" bIns="0">
+          <a:bodyPr wrap="square" lIns="0" tIns="0" rIns="0" bIns="0" anchor="ctr">
             <a:spAutoFit/>
           </a:bodyPr>
           <a:lstStyle/>
@@ -14596,6 +14802,7 @@
           <a:lstStyle/>
           <a:p>
             <a:pPr algn="ctr"/>
+            <a:endParaRPr/>
           </a:p>
         </p:txBody>
       </p:sp>
@@ -14616,7 +14823,7 @@
           <a:noFill/>
         </p:spPr>
         <p:txBody>
-          <a:bodyPr wrap="square" anchor="t" lIns="0" rIns="0" tIns="0" bIns="0">
+          <a:bodyPr wrap="square" lIns="0" tIns="0" rIns="0" bIns="0" anchor="t">
             <a:spAutoFit/>
           </a:bodyPr>
           <a:lstStyle/>
@@ -14659,7 +14866,7 @@
           <a:noFill/>
         </p:spPr>
         <p:txBody>
-          <a:bodyPr wrap="square" anchor="t" lIns="0" rIns="0" tIns="0" bIns="0">
+          <a:bodyPr wrap="square" lIns="0" tIns="0" rIns="0" bIns="0" anchor="t">
             <a:spAutoFit/>
           </a:bodyPr>
           <a:lstStyle/>
@@ -14686,7 +14893,7 @@
 </file>
 
 <file path=ppt/slides/slide5.xml><?xml version="1.0" encoding="utf-8"?>
-<p:sld xmlns:a="http://schemas.openxmlformats.org/drawingml/2006/main" xmlns:p="http://schemas.openxmlformats.org/presentationml/2006/main" xmlns:r="http://schemas.openxmlformats.org/officeDocument/2006/relationships">
+<p:sld xmlns:a="http://schemas.openxmlformats.org/drawingml/2006/main" xmlns:r="http://schemas.openxmlformats.org/officeDocument/2006/relationships" xmlns:p="http://schemas.openxmlformats.org/presentationml/2006/main">
   <p:cSld>
     <p:bg>
       <p:bgPr>
@@ -14702,7 +14909,14 @@
         <p:cNvGrpSpPr/>
         <p:nvPr/>
       </p:nvGrpSpPr>
-      <p:grpSpPr/>
+      <p:grpSpPr>
+        <a:xfrm>
+          <a:off x="0" y="0"/>
+          <a:ext cx="0" cy="0"/>
+          <a:chOff x="0" y="0"/>
+          <a:chExt cx="0" cy="0"/>
+        </a:xfrm>
+      </p:grpSpPr>
       <p:sp>
         <p:nvSpPr>
           <p:cNvPr id="2" name="TextBox 1"/>
@@ -14720,7 +14934,7 @@
           <a:noFill/>
         </p:spPr>
         <p:txBody>
-          <a:bodyPr wrap="square" anchor="t" lIns="0" rIns="0" tIns="0" bIns="0">
+          <a:bodyPr wrap="square" lIns="0" tIns="0" rIns="0" bIns="0" anchor="t">
             <a:spAutoFit/>
           </a:bodyPr>
           <a:lstStyle/>
@@ -14794,6 +15008,7 @@
           <a:lstStyle/>
           <a:p>
             <a:pPr algn="ctr"/>
+            <a:endParaRPr/>
           </a:p>
         </p:txBody>
       </p:sp>
@@ -14814,7 +15029,7 @@
           <a:noFill/>
         </p:spPr>
         <p:txBody>
-          <a:bodyPr wrap="square" anchor="ctr" lIns="0" rIns="0" tIns="0" bIns="0">
+          <a:bodyPr wrap="square" lIns="0" tIns="0" rIns="0" bIns="0" anchor="ctr">
             <a:spAutoFit/>
           </a:bodyPr>
           <a:lstStyle/>
@@ -14985,6 +15200,7 @@
           <a:lstStyle/>
           <a:p>
             <a:pPr algn="ctr"/>
+            <a:endParaRPr/>
           </a:p>
         </p:txBody>
       </p:sp>
@@ -15005,7 +15221,7 @@
           <a:noFill/>
         </p:spPr>
         <p:txBody>
-          <a:bodyPr wrap="square" anchor="t" lIns="0" rIns="0" tIns="0" bIns="0">
+          <a:bodyPr wrap="square" lIns="0" tIns="0" rIns="0" bIns="0" anchor="t">
             <a:spAutoFit/>
           </a:bodyPr>
           <a:lstStyle/>
@@ -15048,7 +15264,7 @@
           <a:noFill/>
         </p:spPr>
         <p:txBody>
-          <a:bodyPr wrap="square" anchor="t" lIns="0" rIns="0" tIns="0" bIns="0">
+          <a:bodyPr wrap="square" lIns="0" tIns="0" rIns="0" bIns="0" anchor="t">
             <a:spAutoFit/>
           </a:bodyPr>
           <a:lstStyle/>
@@ -15075,7 +15291,7 @@
 </file>
 
 <file path=ppt/slides/slide6.xml><?xml version="1.0" encoding="utf-8"?>
-<p:sld xmlns:a="http://schemas.openxmlformats.org/drawingml/2006/main" xmlns:p="http://schemas.openxmlformats.org/presentationml/2006/main" xmlns:r="http://schemas.openxmlformats.org/officeDocument/2006/relationships">
+<p:sld xmlns:a="http://schemas.openxmlformats.org/drawingml/2006/main" xmlns:r="http://schemas.openxmlformats.org/officeDocument/2006/relationships" xmlns:p="http://schemas.openxmlformats.org/presentationml/2006/main">
   <p:cSld>
     <p:bg>
       <p:bgPr>
@@ -15091,7 +15307,14 @@
         <p:cNvGrpSpPr/>
         <p:nvPr/>
       </p:nvGrpSpPr>
-      <p:grpSpPr/>
+      <p:grpSpPr>
+        <a:xfrm>
+          <a:off x="0" y="0"/>
+          <a:ext cx="0" cy="0"/>
+          <a:chOff x="0" y="0"/>
+          <a:chExt cx="0" cy="0"/>
+        </a:xfrm>
+      </p:grpSpPr>
       <p:sp>
         <p:nvSpPr>
           <p:cNvPr id="2" name="TextBox 1"/>
@@ -15109,7 +15332,7 @@
           <a:noFill/>
         </p:spPr>
         <p:txBody>
-          <a:bodyPr wrap="square" anchor="t" lIns="0" rIns="0" tIns="0" bIns="0">
+          <a:bodyPr wrap="square" lIns="0" tIns="0" rIns="0" bIns="0" anchor="t">
             <a:spAutoFit/>
           </a:bodyPr>
           <a:lstStyle/>
@@ -15167,6 +15390,7 @@
           <a:lstStyle/>
           <a:p>
             <a:pPr algn="ctr"/>
+            <a:endParaRPr/>
           </a:p>
         </p:txBody>
       </p:sp>
@@ -15187,7 +15411,7 @@
           <a:noFill/>
         </p:spPr>
         <p:txBody>
-          <a:bodyPr wrap="square" anchor="ctr" lIns="0" rIns="0" tIns="0" bIns="0">
+          <a:bodyPr wrap="square" lIns="0" tIns="0" rIns="0" bIns="0" anchor="ctr">
             <a:spAutoFit/>
           </a:bodyPr>
           <a:lstStyle/>
@@ -15389,6 +15613,7 @@
           <a:lstStyle/>
           <a:p>
             <a:pPr algn="ctr"/>
+            <a:endParaRPr/>
           </a:p>
         </p:txBody>
       </p:sp>
@@ -15409,7 +15634,7 @@
           <a:noFill/>
         </p:spPr>
         <p:txBody>
-          <a:bodyPr wrap="square" anchor="t" lIns="0" rIns="0" tIns="0" bIns="0">
+          <a:bodyPr wrap="square" lIns="0" tIns="0" rIns="0" bIns="0" anchor="t">
             <a:spAutoFit/>
           </a:bodyPr>
           <a:lstStyle/>
@@ -15452,7 +15677,7 @@
           <a:noFill/>
         </p:spPr>
         <p:txBody>
-          <a:bodyPr wrap="square" anchor="t" lIns="0" rIns="0" tIns="0" bIns="0">
+          <a:bodyPr wrap="square" lIns="0" tIns="0" rIns="0" bIns="0" anchor="t">
             <a:spAutoFit/>
           </a:bodyPr>
           <a:lstStyle/>
@@ -15479,7 +15704,7 @@
 </file>
 
 <file path=ppt/slides/slide7.xml><?xml version="1.0" encoding="utf-8"?>
-<p:sld xmlns:a="http://schemas.openxmlformats.org/drawingml/2006/main" xmlns:p="http://schemas.openxmlformats.org/presentationml/2006/main" xmlns:r="http://schemas.openxmlformats.org/officeDocument/2006/relationships">
+<p:sld xmlns:a="http://schemas.openxmlformats.org/drawingml/2006/main" xmlns:r="http://schemas.openxmlformats.org/officeDocument/2006/relationships" xmlns:p="http://schemas.openxmlformats.org/presentationml/2006/main">
   <p:cSld>
     <p:bg>
       <p:bgPr>
@@ -15495,7 +15720,14 @@
         <p:cNvGrpSpPr/>
         <p:nvPr/>
       </p:nvGrpSpPr>
-      <p:grpSpPr/>
+      <p:grpSpPr>
+        <a:xfrm>
+          <a:off x="0" y="0"/>
+          <a:ext cx="0" cy="0"/>
+          <a:chOff x="0" y="0"/>
+          <a:chExt cx="0" cy="0"/>
+        </a:xfrm>
+      </p:grpSpPr>
       <p:sp>
         <p:nvSpPr>
           <p:cNvPr id="2" name="TextBox 1"/>
@@ -15513,7 +15745,7 @@
           <a:noFill/>
         </p:spPr>
         <p:txBody>
-          <a:bodyPr wrap="square" anchor="t" lIns="0" rIns="0" tIns="0" bIns="0">
+          <a:bodyPr wrap="square" lIns="0" tIns="0" rIns="0" bIns="0" anchor="t">
             <a:spAutoFit/>
           </a:bodyPr>
           <a:lstStyle/>
@@ -15587,6 +15819,7 @@
           <a:lstStyle/>
           <a:p>
             <a:pPr algn="ctr"/>
+            <a:endParaRPr/>
           </a:p>
         </p:txBody>
       </p:sp>
@@ -15607,7 +15840,7 @@
           <a:noFill/>
         </p:spPr>
         <p:txBody>
-          <a:bodyPr wrap="square" anchor="ctr" lIns="0" rIns="0" tIns="0" bIns="0">
+          <a:bodyPr wrap="square" lIns="0" tIns="0" rIns="0" bIns="0" anchor="ctr">
             <a:spAutoFit/>
           </a:bodyPr>
           <a:lstStyle/>
@@ -15778,6 +16011,7 @@
           <a:lstStyle/>
           <a:p>
             <a:pPr algn="ctr"/>
+            <a:endParaRPr/>
           </a:p>
         </p:txBody>
       </p:sp>
@@ -15798,7 +16032,7 @@
           <a:noFill/>
         </p:spPr>
         <p:txBody>
-          <a:bodyPr wrap="square" anchor="t" lIns="0" rIns="0" tIns="0" bIns="0">
+          <a:bodyPr wrap="square" lIns="0" tIns="0" rIns="0" bIns="0" anchor="t">
             <a:spAutoFit/>
           </a:bodyPr>
           <a:lstStyle/>
@@ -15841,7 +16075,7 @@
           <a:noFill/>
         </p:spPr>
         <p:txBody>
-          <a:bodyPr wrap="square" anchor="t" lIns="0" rIns="0" tIns="0" bIns="0">
+          <a:bodyPr wrap="square" lIns="0" tIns="0" rIns="0" bIns="0" anchor="t">
             <a:spAutoFit/>
           </a:bodyPr>
           <a:lstStyle/>
@@ -15868,7 +16102,7 @@
 </file>
 
 <file path=ppt/slides/slide8.xml><?xml version="1.0" encoding="utf-8"?>
-<p:sld xmlns:a="http://schemas.openxmlformats.org/drawingml/2006/main" xmlns:p="http://schemas.openxmlformats.org/presentationml/2006/main" xmlns:r="http://schemas.openxmlformats.org/officeDocument/2006/relationships">
+<p:sld xmlns:a="http://schemas.openxmlformats.org/drawingml/2006/main" xmlns:r="http://schemas.openxmlformats.org/officeDocument/2006/relationships" xmlns:p="http://schemas.openxmlformats.org/presentationml/2006/main">
   <p:cSld>
     <p:bg>
       <p:bgPr>
@@ -15884,7 +16118,14 @@
         <p:cNvGrpSpPr/>
         <p:nvPr/>
       </p:nvGrpSpPr>
-      <p:grpSpPr/>
+      <p:grpSpPr>
+        <a:xfrm>
+          <a:off x="0" y="0"/>
+          <a:ext cx="0" cy="0"/>
+          <a:chOff x="0" y="0"/>
+          <a:chExt cx="0" cy="0"/>
+        </a:xfrm>
+      </p:grpSpPr>
       <p:sp>
         <p:nvSpPr>
           <p:cNvPr id="2" name="TextBox 1"/>
@@ -15902,7 +16143,7 @@
           <a:noFill/>
         </p:spPr>
         <p:txBody>
-          <a:bodyPr wrap="square" anchor="t" lIns="0" rIns="0" tIns="0" bIns="0">
+          <a:bodyPr wrap="square" lIns="0" tIns="0" rIns="0" bIns="0" anchor="t">
             <a:spAutoFit/>
           </a:bodyPr>
           <a:lstStyle/>
@@ -15960,6 +16201,7 @@
           <a:lstStyle/>
           <a:p>
             <a:pPr algn="ctr"/>
+            <a:endParaRPr/>
           </a:p>
         </p:txBody>
       </p:sp>
@@ -15980,7 +16222,7 @@
           <a:noFill/>
         </p:spPr>
         <p:txBody>
-          <a:bodyPr wrap="square" anchor="ctr" lIns="0" rIns="0" tIns="0" bIns="0">
+          <a:bodyPr wrap="square" lIns="0" tIns="0" rIns="0" bIns="0" anchor="ctr">
             <a:spAutoFit/>
           </a:bodyPr>
           <a:lstStyle/>
@@ -16151,6 +16393,7 @@
           <a:lstStyle/>
           <a:p>
             <a:pPr algn="ctr"/>
+            <a:endParaRPr/>
           </a:p>
         </p:txBody>
       </p:sp>
@@ -16171,7 +16414,7 @@
           <a:noFill/>
         </p:spPr>
         <p:txBody>
-          <a:bodyPr wrap="square" anchor="t" lIns="0" rIns="0" tIns="0" bIns="0">
+          <a:bodyPr wrap="square" lIns="0" tIns="0" rIns="0" bIns="0" anchor="t">
             <a:spAutoFit/>
           </a:bodyPr>
           <a:lstStyle/>
@@ -16214,7 +16457,7 @@
           <a:noFill/>
         </p:spPr>
         <p:txBody>
-          <a:bodyPr wrap="square" anchor="t" lIns="0" rIns="0" tIns="0" bIns="0">
+          <a:bodyPr wrap="square" lIns="0" tIns="0" rIns="0" bIns="0" anchor="t">
             <a:spAutoFit/>
           </a:bodyPr>
           <a:lstStyle/>
@@ -16241,7 +16484,7 @@
 </file>
 
 <file path=ppt/slides/slide9.xml><?xml version="1.0" encoding="utf-8"?>
-<p:sld xmlns:a="http://schemas.openxmlformats.org/drawingml/2006/main" xmlns:p="http://schemas.openxmlformats.org/presentationml/2006/main" xmlns:r="http://schemas.openxmlformats.org/officeDocument/2006/relationships">
+<p:sld xmlns:a="http://schemas.openxmlformats.org/drawingml/2006/main" xmlns:r="http://schemas.openxmlformats.org/officeDocument/2006/relationships" xmlns:p="http://schemas.openxmlformats.org/presentationml/2006/main">
   <p:cSld>
     <p:bg>
       <p:bgPr>
@@ -16257,7 +16500,14 @@
         <p:cNvGrpSpPr/>
         <p:nvPr/>
       </p:nvGrpSpPr>
-      <p:grpSpPr/>
+      <p:grpSpPr>
+        <a:xfrm>
+          <a:off x="0" y="0"/>
+          <a:ext cx="0" cy="0"/>
+          <a:chOff x="0" y="0"/>
+          <a:chExt cx="0" cy="0"/>
+        </a:xfrm>
+      </p:grpSpPr>
       <p:sp>
         <p:nvSpPr>
           <p:cNvPr id="2" name="Rectangle 1"/>
@@ -16299,6 +16549,7 @@
           <a:lstStyle/>
           <a:p>
             <a:pPr algn="ctr"/>
+            <a:endParaRPr/>
           </a:p>
         </p:txBody>
       </p:sp>
@@ -16372,7 +16623,7 @@
           <a:noFill/>
         </p:spPr>
         <p:txBody>
-          <a:bodyPr wrap="square" anchor="ctr" lIns="0" rIns="0" tIns="0" bIns="0">
+          <a:bodyPr wrap="square" lIns="0" tIns="0" rIns="0" bIns="0" anchor="ctr">
             <a:spAutoFit/>
           </a:bodyPr>
           <a:lstStyle/>
@@ -16406,7 +16657,7 @@
           <a:noFill/>
         </p:spPr>
         <p:txBody>
-          <a:bodyPr wrap="square" anchor="t" lIns="0" rIns="0" tIns="0" bIns="0">
+          <a:bodyPr wrap="square" lIns="0" tIns="0" rIns="0" bIns="0" anchor="t">
             <a:spAutoFit/>
           </a:bodyPr>
           <a:lstStyle/>
@@ -16672,6 +16923,7 @@
           <a:lstStyle/>
           <a:p>
             <a:pPr algn="ctr"/>
+            <a:endParaRPr/>
           </a:p>
         </p:txBody>
       </p:sp>
@@ -16692,7 +16944,7 @@
           <a:noFill/>
         </p:spPr>
         <p:txBody>
-          <a:bodyPr wrap="square" anchor="ctr" lIns="0" rIns="0" tIns="0" bIns="0">
+          <a:bodyPr wrap="square" lIns="0" tIns="0" rIns="0" bIns="0" anchor="ctr">
             <a:spAutoFit/>
           </a:bodyPr>
           <a:lstStyle/>
@@ -16750,6 +17002,7 @@
           <a:lstStyle/>
           <a:p>
             <a:pPr algn="ctr"/>
+            <a:endParaRPr/>
           </a:p>
         </p:txBody>
       </p:sp>
@@ -16770,7 +17023,7 @@
           <a:noFill/>
         </p:spPr>
         <p:txBody>
-          <a:bodyPr wrap="square" anchor="t" lIns="0" rIns="0" tIns="0" bIns="0">
+          <a:bodyPr wrap="square" lIns="0" tIns="0" rIns="0" bIns="0" anchor="t">
             <a:spAutoFit/>
           </a:bodyPr>
           <a:lstStyle/>
@@ -16813,7 +17066,7 @@
           <a:noFill/>
         </p:spPr>
         <p:txBody>
-          <a:bodyPr wrap="square" anchor="t" lIns="0" rIns="0" tIns="0" bIns="0">
+          <a:bodyPr wrap="square" lIns="0" tIns="0" rIns="0" bIns="0" anchor="t">
             <a:spAutoFit/>
           </a:bodyPr>
           <a:lstStyle/>
@@ -17170,44 +17423,44 @@
         <a:sysClr val="window" lastClr="FFFFFF"/>
       </a:lt1>
       <a:dk2>
-        <a:srgbClr val="1F497D"/>
+        <a:srgbClr val="0E2841"/>
       </a:dk2>
       <a:lt2>
-        <a:srgbClr val="EEECE1"/>
+        <a:srgbClr val="E8E8E8"/>
       </a:lt2>
       <a:accent1>
-        <a:srgbClr val="4F81BD"/>
+        <a:srgbClr val="156082"/>
       </a:accent1>
       <a:accent2>
-        <a:srgbClr val="C0504D"/>
+        <a:srgbClr val="E97132"/>
       </a:accent2>
       <a:accent3>
-        <a:srgbClr val="9BBB59"/>
+        <a:srgbClr val="196B24"/>
       </a:accent3>
       <a:accent4>
-        <a:srgbClr val="8064A2"/>
+        <a:srgbClr val="0F9ED5"/>
       </a:accent4>
       <a:accent5>
-        <a:srgbClr val="4BACC6"/>
+        <a:srgbClr val="A02B93"/>
       </a:accent5>
       <a:accent6>
-        <a:srgbClr val="F79646"/>
+        <a:srgbClr val="4EA72E"/>
       </a:accent6>
       <a:hlink>
-        <a:srgbClr val="0000FF"/>
+        <a:srgbClr val="467886"/>
       </a:hlink>
       <a:folHlink>
-        <a:srgbClr val="800080"/>
+        <a:srgbClr val="96607D"/>
       </a:folHlink>
     </a:clrScheme>
     <a:fontScheme name="Office">
       <a:majorFont>
-        <a:latin typeface="Calibri"/>
+        <a:latin typeface="Aptos Display" panose="02110004020202020204"/>
         <a:ea typeface=""/>
         <a:cs typeface=""/>
-        <a:font script="Jpan" typeface="ＭＳ Ｐゴシック"/>
+        <a:font script="Jpan" typeface="游ゴシック Light"/>
         <a:font script="Hang" typeface="맑은 고딕"/>
-        <a:font script="Hans" typeface="宋体"/>
+        <a:font script="Hans" typeface="等线 Light"/>
         <a:font script="Hant" typeface="新細明體"/>
         <a:font script="Arab" typeface="Times New Roman"/>
         <a:font script="Hebr" typeface="Times New Roman"/>
@@ -17235,14 +17488,31 @@
         <a:font script="Viet" typeface="Times New Roman"/>
         <a:font script="Uigh" typeface="Microsoft Uighur"/>
         <a:font script="Geor" typeface="Sylfaen"/>
+        <a:font script="Armn" typeface="Arial"/>
+        <a:font script="Bugi" typeface="Leelawadee UI"/>
+        <a:font script="Bopo" typeface="Microsoft JhengHei"/>
+        <a:font script="Java" typeface="Javanese Text"/>
+        <a:font script="Lisu" typeface="Segoe UI"/>
+        <a:font script="Mymr" typeface="Myanmar Text"/>
+        <a:font script="Nkoo" typeface="Ebrima"/>
+        <a:font script="Olck" typeface="Nirmala UI"/>
+        <a:font script="Osma" typeface="Ebrima"/>
+        <a:font script="Phag" typeface="Phagspa"/>
+        <a:font script="Syrn" typeface="Estrangelo Edessa"/>
+        <a:font script="Syrj" typeface="Estrangelo Edessa"/>
+        <a:font script="Syre" typeface="Estrangelo Edessa"/>
+        <a:font script="Sora" typeface="Nirmala UI"/>
+        <a:font script="Tale" typeface="Microsoft Tai Le"/>
+        <a:font script="Talu" typeface="Microsoft New Tai Lue"/>
+        <a:font script="Tfng" typeface="Ebrima"/>
       </a:majorFont>
       <a:minorFont>
-        <a:latin typeface="Calibri"/>
+        <a:latin typeface="Aptos" panose="02110004020202020204"/>
         <a:ea typeface=""/>
         <a:cs typeface=""/>
-        <a:font script="Jpan" typeface="ＭＳ Ｐゴシック"/>
+        <a:font script="Jpan" typeface="游ゴシック"/>
         <a:font script="Hang" typeface="맑은 고딕"/>
-        <a:font script="Hans" typeface="宋体"/>
+        <a:font script="Hans" typeface="等线"/>
         <a:font script="Hant" typeface="新細明體"/>
         <a:font script="Arab" typeface="Arial"/>
         <a:font script="Hebr" typeface="Arial"/>
@@ -17270,6 +17540,23 @@
         <a:font script="Viet" typeface="Arial"/>
         <a:font script="Uigh" typeface="Microsoft Uighur"/>
         <a:font script="Geor" typeface="Sylfaen"/>
+        <a:font script="Armn" typeface="Arial"/>
+        <a:font script="Bugi" typeface="Leelawadee UI"/>
+        <a:font script="Bopo" typeface="Microsoft JhengHei"/>
+        <a:font script="Java" typeface="Javanese Text"/>
+        <a:font script="Lisu" typeface="Segoe UI"/>
+        <a:font script="Mymr" typeface="Myanmar Text"/>
+        <a:font script="Nkoo" typeface="Ebrima"/>
+        <a:font script="Olck" typeface="Nirmala UI"/>
+        <a:font script="Osma" typeface="Ebrima"/>
+        <a:font script="Phag" typeface="Phagspa"/>
+        <a:font script="Syrn" typeface="Estrangelo Edessa"/>
+        <a:font script="Syrj" typeface="Estrangelo Edessa"/>
+        <a:font script="Syre" typeface="Estrangelo Edessa"/>
+        <a:font script="Sora" typeface="Nirmala UI"/>
+        <a:font script="Tale" typeface="Microsoft Tai Le"/>
+        <a:font script="Talu" typeface="Microsoft New Tai Lue"/>
+        <a:font script="Tfng" typeface="Ebrima"/>
       </a:minorFont>
     </a:fontScheme>
     <a:fmtScheme name="Office">
@@ -17281,180 +17568,136 @@
           <a:gsLst>
             <a:gs pos="0">
               <a:schemeClr val="phClr">
-                <a:tint val="50000"/>
-                <a:satMod val="300000"/>
+                <a:lumMod val="110000"/>
+                <a:satMod val="105000"/>
+                <a:tint val="67000"/>
               </a:schemeClr>
             </a:gs>
-            <a:gs pos="35000">
+            <a:gs pos="50000">
               <a:schemeClr val="phClr">
-                <a:tint val="37000"/>
-                <a:satMod val="300000"/>
+                <a:lumMod val="105000"/>
+                <a:satMod val="103000"/>
+                <a:tint val="73000"/>
               </a:schemeClr>
             </a:gs>
             <a:gs pos="100000">
               <a:schemeClr val="phClr">
-                <a:tint val="15000"/>
-                <a:satMod val="350000"/>
+                <a:lumMod val="105000"/>
+                <a:satMod val="109000"/>
+                <a:tint val="81000"/>
               </a:schemeClr>
             </a:gs>
           </a:gsLst>
-          <a:lin ang="16200000" scaled="1"/>
+          <a:lin ang="5400000" scaled="0"/>
         </a:gradFill>
         <a:gradFill rotWithShape="1">
           <a:gsLst>
             <a:gs pos="0">
               <a:schemeClr val="phClr">
-                <a:tint val="100000"/>
+                <a:satMod val="103000"/>
+                <a:lumMod val="102000"/>
+                <a:tint val="94000"/>
+              </a:schemeClr>
+            </a:gs>
+            <a:gs pos="50000">
+              <a:schemeClr val="phClr">
+                <a:satMod val="110000"/>
+                <a:lumMod val="100000"/>
                 <a:shade val="100000"/>
-                <a:satMod val="130000"/>
               </a:schemeClr>
             </a:gs>
             <a:gs pos="100000">
               <a:schemeClr val="phClr">
-                <a:tint val="50000"/>
-                <a:shade val="100000"/>
-                <a:satMod val="350000"/>
+                <a:lumMod val="99000"/>
+                <a:satMod val="120000"/>
+                <a:shade val="78000"/>
               </a:schemeClr>
             </a:gs>
           </a:gsLst>
-          <a:lin ang="16200000" scaled="0"/>
+          <a:lin ang="5400000" scaled="0"/>
         </a:gradFill>
       </a:fillStyleLst>
       <a:lnStyleLst>
-        <a:ln w="9525" cap="flat" cmpd="sng" algn="ctr">
+        <a:ln w="12700" cap="flat" cmpd="sng" algn="ctr">
           <a:solidFill>
-            <a:schemeClr val="phClr">
-              <a:shade val="95000"/>
-              <a:satMod val="105000"/>
-            </a:schemeClr>
+            <a:schemeClr val="phClr"/>
           </a:solidFill>
           <a:prstDash val="solid"/>
+          <a:miter lim="800000"/>
+        </a:ln>
+        <a:ln w="19050" cap="flat" cmpd="sng" algn="ctr">
+          <a:solidFill>
+            <a:schemeClr val="phClr"/>
+          </a:solidFill>
+          <a:prstDash val="solid"/>
+          <a:miter lim="800000"/>
         </a:ln>
         <a:ln w="25400" cap="flat" cmpd="sng" algn="ctr">
           <a:solidFill>
             <a:schemeClr val="phClr"/>
           </a:solidFill>
           <a:prstDash val="solid"/>
-        </a:ln>
-        <a:ln w="38100" cap="flat" cmpd="sng" algn="ctr">
-          <a:solidFill>
-            <a:schemeClr val="phClr"/>
-          </a:solidFill>
-          <a:prstDash val="solid"/>
+          <a:miter lim="800000"/>
         </a:ln>
       </a:lnStyleLst>
       <a:effectStyleLst>
         <a:effectStyle>
+          <a:effectLst/>
+        </a:effectStyle>
+        <a:effectStyle>
+          <a:effectLst/>
+        </a:effectStyle>
+        <a:effectStyle>
           <a:effectLst>
-            <a:outerShdw blurRad="40000" dist="20000" dir="5400000" rotWithShape="0">
+            <a:outerShdw blurRad="57150" dist="19050" dir="5400000" algn="ctr" rotWithShape="0">
               <a:srgbClr val="000000">
-                <a:alpha val="38000"/>
+                <a:alpha val="63000"/>
               </a:srgbClr>
             </a:outerShdw>
           </a:effectLst>
-        </a:effectStyle>
-        <a:effectStyle>
-          <a:effectLst>
-            <a:outerShdw blurRad="40000" dist="23000" dir="5400000" rotWithShape="0">
-              <a:srgbClr val="000000">
-                <a:alpha val="35000"/>
-              </a:srgbClr>
-            </a:outerShdw>
-          </a:effectLst>
-        </a:effectStyle>
-        <a:effectStyle>
-          <a:effectLst>
-            <a:outerShdw blurRad="40000" dist="23000" dir="5400000" rotWithShape="0">
-              <a:srgbClr val="000000">
-                <a:alpha val="35000"/>
-              </a:srgbClr>
-            </a:outerShdw>
-          </a:effectLst>
-          <a:scene3d>
-            <a:camera prst="orthographicFront">
-              <a:rot lat="0" lon="0" rev="0"/>
-            </a:camera>
-            <a:lightRig rig="threePt" dir="t">
-              <a:rot lat="0" lon="0" rev="1200000"/>
-            </a:lightRig>
-          </a:scene3d>
-          <a:sp3d>
-            <a:bevelT w="63500" h="25400"/>
-          </a:sp3d>
         </a:effectStyle>
       </a:effectStyleLst>
       <a:bgFillStyleLst>
         <a:solidFill>
           <a:schemeClr val="phClr"/>
         </a:solidFill>
+        <a:solidFill>
+          <a:schemeClr val="phClr">
+            <a:tint val="95000"/>
+            <a:satMod val="170000"/>
+          </a:schemeClr>
+        </a:solidFill>
         <a:gradFill rotWithShape="1">
           <a:gsLst>
             <a:gs pos="0">
               <a:schemeClr val="phClr">
-                <a:tint val="40000"/>
-                <a:satMod val="350000"/>
+                <a:tint val="93000"/>
+                <a:satMod val="150000"/>
+                <a:shade val="98000"/>
+                <a:lumMod val="102000"/>
               </a:schemeClr>
             </a:gs>
-            <a:gs pos="40000">
+            <a:gs pos="50000">
               <a:schemeClr val="phClr">
-                <a:tint val="45000"/>
-                <a:shade val="99000"/>
-                <a:satMod val="350000"/>
+                <a:tint val="98000"/>
+                <a:satMod val="130000"/>
+                <a:shade val="90000"/>
+                <a:lumMod val="103000"/>
               </a:schemeClr>
             </a:gs>
             <a:gs pos="100000">
               <a:schemeClr val="phClr">
-                <a:shade val="20000"/>
-                <a:satMod val="255000"/>
+                <a:shade val="63000"/>
+                <a:satMod val="120000"/>
               </a:schemeClr>
             </a:gs>
           </a:gsLst>
-          <a:path path="circle">
-            <a:fillToRect l="50000" t="-80000" r="50000" b="180000"/>
-          </a:path>
-        </a:gradFill>
-        <a:gradFill rotWithShape="1">
-          <a:gsLst>
-            <a:gs pos="0">
-              <a:schemeClr val="phClr">
-                <a:tint val="80000"/>
-                <a:satMod val="300000"/>
-              </a:schemeClr>
-            </a:gs>
-            <a:gs pos="100000">
-              <a:schemeClr val="phClr">
-                <a:shade val="30000"/>
-                <a:satMod val="200000"/>
-              </a:schemeClr>
-            </a:gs>
-          </a:gsLst>
-          <a:path path="circle">
-            <a:fillToRect l="50000" t="50000" r="50000" b="50000"/>
-          </a:path>
+          <a:lin ang="5400000" scaled="0"/>
         </a:gradFill>
       </a:bgFillStyleLst>
     </a:fmtScheme>
   </a:themeElements>
   <a:objectDefaults>
-    <a:spDef>
-      <a:spPr/>
-      <a:bodyPr/>
-      <a:lstStyle/>
-      <a:style>
-        <a:lnRef idx="1">
-          <a:schemeClr val="accent1"/>
-        </a:lnRef>
-        <a:fillRef idx="3">
-          <a:schemeClr val="accent1"/>
-        </a:fillRef>
-        <a:effectRef idx="2">
-          <a:schemeClr val="accent1"/>
-        </a:effectRef>
-        <a:fontRef idx="minor">
-          <a:schemeClr val="lt1"/>
-        </a:fontRef>
-      </a:style>
-    </a:spDef>
     <a:lnDef>
       <a:spPr/>
       <a:bodyPr/>
@@ -17476,5 +17719,10 @@
     </a:lnDef>
   </a:objectDefaults>
   <a:extraClrSchemeLst/>
+  <a:extLst>
+    <a:ext uri="{05A4C25C-085E-4340-85A3-A5531E510DB2}">
+      <thm15:themeFamily xmlns:thm15="http://schemas.microsoft.com/office/thememl/2012/main" name="Office Theme" id="{2E142A2C-CD16-42D6-873A-C26D2A0506FA}" vid="{1BDDFF52-6CD6-40A5-AB3C-68EB2F1E4D0A}"/>
+    </a:ext>
+  </a:extLst>
 </a:theme>
 </file>
</xml_diff>